<commit_message>
Jisc-webinar: nieuwe titel, Hannah Lawrence, logoplek voor Jisc op elke slide
Co-Authored-By: Claude Opus 5.5 <noreply@anthropic.com>
Claude-Session: https://claude.ai/code/session_015wepMCxdSi78pa2LxvGqQg
</commit_message>
<xml_diff>
--- a/GTM/Event manager/jisc-webinar/deck/jisc-webinar-bewerkbaar.pptx
+++ b/GTM/Event manager/jisc-webinar/deck/jisc-webinar-bewerkbaar.pptx
@@ -3379,7 +3379,7 @@
                 </a:solidFill>
                 <a:latin typeface="League Spartan"/>
               </a:rPr>
-              <a:t>What 20+ AI feedback</a:t>
+              <a:t>The business outcomes of</a:t>
             </a:r>
           </a:p>
           <a:p>
@@ -3395,7 +3395,7 @@
                 </a:solidFill>
                 <a:latin typeface="League Spartan"/>
               </a:rPr>
-              <a:t>implementations taught us</a:t>
+              <a:t>AI marking and feedback</a:t>
             </a:r>
           </a:p>
         </p:txBody>
@@ -3434,14 +3434,60 @@
                 </a:solidFill>
                 <a:latin typeface="Inter"/>
               </a:rPr>
-              <a:t>Consistency, efficiency and the risk nobody planned for</a:t>
-            </a:r>
+              <a:t>Lessons from 20+ pilots and implementations</a:t>
+            </a:r>
+          </a:p>
+        </p:txBody>
+      </p:sp>
+      <p:sp>
+        <p:nvSpPr>
+          <p:cNvPr id="9" name="Rounded Rectangle 8"/>
+          <p:cNvSpPr/>
+          <p:nvPr/>
+        </p:nvSpPr>
+        <p:spPr>
+          <a:xfrm>
+            <a:off x="584200" y="5791200"/>
+            <a:ext cx="3130550" cy="736600"/>
+          </a:xfrm>
+          <a:prstGeom prst="roundRect">
+            <a:avLst>
+              <a:gd name="adj" fmla="val 18965"/>
+            </a:avLst>
+          </a:prstGeom>
+          <a:solidFill>
+            <a:srgbClr val="FFFFFF"/>
+          </a:solidFill>
+          <a:ln>
+            <a:noFill/>
+          </a:ln>
+          <a:effectLst/>
+        </p:spPr>
+        <p:style>
+          <a:lnRef idx="1">
+            <a:schemeClr val="accent1"/>
+          </a:lnRef>
+          <a:fillRef idx="3">
+            <a:schemeClr val="accent1"/>
+          </a:fillRef>
+          <a:effectRef idx="2">
+            <a:schemeClr val="accent1"/>
+          </a:effectRef>
+          <a:fontRef idx="minor">
+            <a:schemeClr val="lt1"/>
+          </a:fontRef>
+        </p:style>
+        <p:txBody>
+          <a:bodyPr rtlCol="0" anchor="ctr"/>
+          <a:lstStyle/>
+          <a:p>
+            <a:pPr algn="ctr"/>
           </a:p>
         </p:txBody>
       </p:sp>
       <p:pic>
         <p:nvPicPr>
-          <p:cNvPr id="9" name="Picture 8" descr="logo_white_c.png"/>
+          <p:cNvPr id="10" name="Picture 9" descr="logo_navy_c.png"/>
           <p:cNvPicPr>
             <a:picLocks noChangeAspect="1"/>
           </p:cNvPicPr>
@@ -3457,6 +3503,74 @@
           <a:xfrm>
             <a:off x="762000" y="5969000"/>
             <a:ext cx="1409700" cy="381000"/>
+          </a:xfrm>
+          <a:prstGeom prst="rect">
+            <a:avLst/>
+          </a:prstGeom>
+        </p:spPr>
+      </p:pic>
+      <p:sp>
+        <p:nvSpPr>
+          <p:cNvPr id="11" name="Rectangle 10"/>
+          <p:cNvSpPr/>
+          <p:nvPr/>
+        </p:nvSpPr>
+        <p:spPr>
+          <a:xfrm>
+            <a:off x="2324100" y="5930900"/>
+            <a:ext cx="12700" cy="457200"/>
+          </a:xfrm>
+          <a:prstGeom prst="rect">
+            <a:avLst/>
+          </a:prstGeom>
+          <a:solidFill>
+            <a:srgbClr val="CDD9DE"/>
+          </a:solidFill>
+          <a:ln>
+            <a:noFill/>
+          </a:ln>
+          <a:effectLst/>
+        </p:spPr>
+        <p:style>
+          <a:lnRef idx="1">
+            <a:schemeClr val="accent1"/>
+          </a:lnRef>
+          <a:fillRef idx="3">
+            <a:schemeClr val="accent1"/>
+          </a:fillRef>
+          <a:effectRef idx="2">
+            <a:schemeClr val="accent1"/>
+          </a:effectRef>
+          <a:fontRef idx="minor">
+            <a:schemeClr val="lt1"/>
+          </a:fontRef>
+        </p:style>
+        <p:txBody>
+          <a:bodyPr rtlCol="0" anchor="ctr"/>
+          <a:lstStyle/>
+          <a:p>
+            <a:pPr algn="ctr"/>
+          </a:p>
+        </p:txBody>
+      </p:sp>
+      <p:pic>
+        <p:nvPicPr>
+          <p:cNvPr id="12" name="Picture 11" descr="logo_jisc_placeholder.png"/>
+          <p:cNvPicPr>
+            <a:picLocks noChangeAspect="1"/>
+          </p:cNvPicPr>
+          <p:nvPr/>
+        </p:nvPicPr>
+        <p:blipFill>
+          <a:blip r:embed="rId3"/>
+          <a:stretch>
+            <a:fillRect/>
+          </a:stretch>
+        </p:blipFill>
+        <p:spPr>
+          <a:xfrm>
+            <a:off x="2489200" y="5969000"/>
+            <a:ext cx="1047750" cy="381000"/>
           </a:xfrm>
           <a:prstGeom prst="rect">
             <a:avLst/>
@@ -4235,7 +4349,7 @@
         </p:blipFill>
         <p:spPr>
           <a:xfrm>
-            <a:off x="10490200" y="6324600"/>
+            <a:off x="9417050" y="6311900"/>
             <a:ext cx="939800" cy="254000"/>
           </a:xfrm>
           <a:prstGeom prst="rect">
@@ -4245,13 +4359,81 @@
       </p:pic>
       <p:sp>
         <p:nvSpPr>
-          <p:cNvPr id="22" name="TextBox 21"/>
+          <p:cNvPr id="22" name="Rectangle 21"/>
+          <p:cNvSpPr/>
+          <p:nvPr/>
+        </p:nvSpPr>
+        <p:spPr>
+          <a:xfrm>
+            <a:off x="10509250" y="6299200"/>
+            <a:ext cx="12700" cy="279400"/>
+          </a:xfrm>
+          <a:prstGeom prst="rect">
+            <a:avLst/>
+          </a:prstGeom>
+          <a:solidFill>
+            <a:srgbClr val="CDD9DE"/>
+          </a:solidFill>
+          <a:ln>
+            <a:noFill/>
+          </a:ln>
+          <a:effectLst/>
+        </p:spPr>
+        <p:style>
+          <a:lnRef idx="1">
+            <a:schemeClr val="accent1"/>
+          </a:lnRef>
+          <a:fillRef idx="3">
+            <a:schemeClr val="accent1"/>
+          </a:fillRef>
+          <a:effectRef idx="2">
+            <a:schemeClr val="accent1"/>
+          </a:effectRef>
+          <a:fontRef idx="minor">
+            <a:schemeClr val="lt1"/>
+          </a:fontRef>
+        </p:style>
+        <p:txBody>
+          <a:bodyPr rtlCol="0" anchor="ctr"/>
+          <a:lstStyle/>
+          <a:p>
+            <a:pPr algn="ctr"/>
+          </a:p>
+        </p:txBody>
+      </p:sp>
+      <p:pic>
+        <p:nvPicPr>
+          <p:cNvPr id="23" name="Picture 22" descr="logo_jisc_placeholder.png"/>
+          <p:cNvPicPr>
+            <a:picLocks noChangeAspect="1"/>
+          </p:cNvPicPr>
+          <p:nvPr/>
+        </p:nvPicPr>
+        <p:blipFill>
+          <a:blip r:embed="rId8"/>
+          <a:stretch>
+            <a:fillRect/>
+          </a:stretch>
+        </p:blipFill>
+        <p:spPr>
+          <a:xfrm>
+            <a:off x="10661650" y="6299200"/>
+            <a:ext cx="768350" cy="279400"/>
+          </a:xfrm>
+          <a:prstGeom prst="rect">
+            <a:avLst/>
+          </a:prstGeom>
+        </p:spPr>
+      </p:pic>
+      <p:sp>
+        <p:nvSpPr>
+          <p:cNvPr id="24" name="TextBox 23"/>
           <p:cNvSpPr txBox="1"/>
           <p:nvPr/>
         </p:nvSpPr>
         <p:spPr>
           <a:xfrm>
-            <a:off x="9906000" y="6375400"/>
+            <a:off x="8445500" y="6375400"/>
             <a:ext cx="381000" cy="190500"/>
           </a:xfrm>
           <a:prstGeom prst="rect">
@@ -4399,9 +4581,55 @@
           </a:p>
         </p:txBody>
       </p:sp>
+      <p:sp>
+        <p:nvSpPr>
+          <p:cNvPr id="4" name="Rounded Rectangle 3"/>
+          <p:cNvSpPr/>
+          <p:nvPr/>
+        </p:nvSpPr>
+        <p:spPr>
+          <a:xfrm>
+            <a:off x="9264650" y="6210300"/>
+            <a:ext cx="2317750" cy="457200"/>
+          </a:xfrm>
+          <a:prstGeom prst="roundRect">
+            <a:avLst>
+              <a:gd name="adj" fmla="val 25000"/>
+            </a:avLst>
+          </a:prstGeom>
+          <a:solidFill>
+            <a:srgbClr val="FFFFFF"/>
+          </a:solidFill>
+          <a:ln>
+            <a:noFill/>
+          </a:ln>
+          <a:effectLst/>
+        </p:spPr>
+        <p:style>
+          <a:lnRef idx="1">
+            <a:schemeClr val="accent1"/>
+          </a:lnRef>
+          <a:fillRef idx="3">
+            <a:schemeClr val="accent1"/>
+          </a:fillRef>
+          <a:effectRef idx="2">
+            <a:schemeClr val="accent1"/>
+          </a:effectRef>
+          <a:fontRef idx="minor">
+            <a:schemeClr val="lt1"/>
+          </a:fontRef>
+        </p:style>
+        <p:txBody>
+          <a:bodyPr rtlCol="0" anchor="ctr"/>
+          <a:lstStyle/>
+          <a:p>
+            <a:pPr algn="ctr"/>
+          </a:p>
+        </p:txBody>
+      </p:sp>
       <p:pic>
         <p:nvPicPr>
-          <p:cNvPr id="4" name="Picture 3" descr="logo_white_c.png"/>
+          <p:cNvPr id="5" name="Picture 4" descr="logo_navy_c.png"/>
           <p:cNvPicPr>
             <a:picLocks noChangeAspect="1"/>
           </p:cNvPicPr>
@@ -4415,7 +4643,7 @@
         </p:blipFill>
         <p:spPr>
           <a:xfrm>
-            <a:off x="10490200" y="6324600"/>
+            <a:off x="9417050" y="6311900"/>
             <a:ext cx="939800" cy="254000"/>
           </a:xfrm>
           <a:prstGeom prst="rect">
@@ -4425,13 +4653,81 @@
       </p:pic>
       <p:sp>
         <p:nvSpPr>
-          <p:cNvPr id="5" name="TextBox 4"/>
+          <p:cNvPr id="6" name="Rectangle 5"/>
+          <p:cNvSpPr/>
+          <p:nvPr/>
+        </p:nvSpPr>
+        <p:spPr>
+          <a:xfrm>
+            <a:off x="10509250" y="6299200"/>
+            <a:ext cx="12700" cy="279400"/>
+          </a:xfrm>
+          <a:prstGeom prst="rect">
+            <a:avLst/>
+          </a:prstGeom>
+          <a:solidFill>
+            <a:srgbClr val="CDD9DE"/>
+          </a:solidFill>
+          <a:ln>
+            <a:noFill/>
+          </a:ln>
+          <a:effectLst/>
+        </p:spPr>
+        <p:style>
+          <a:lnRef idx="1">
+            <a:schemeClr val="accent1"/>
+          </a:lnRef>
+          <a:fillRef idx="3">
+            <a:schemeClr val="accent1"/>
+          </a:fillRef>
+          <a:effectRef idx="2">
+            <a:schemeClr val="accent1"/>
+          </a:effectRef>
+          <a:fontRef idx="minor">
+            <a:schemeClr val="lt1"/>
+          </a:fontRef>
+        </p:style>
+        <p:txBody>
+          <a:bodyPr rtlCol="0" anchor="ctr"/>
+          <a:lstStyle/>
+          <a:p>
+            <a:pPr algn="ctr"/>
+          </a:p>
+        </p:txBody>
+      </p:sp>
+      <p:pic>
+        <p:nvPicPr>
+          <p:cNvPr id="7" name="Picture 6" descr="logo_jisc_placeholder.png"/>
+          <p:cNvPicPr>
+            <a:picLocks noChangeAspect="1"/>
+          </p:cNvPicPr>
+          <p:nvPr/>
+        </p:nvPicPr>
+        <p:blipFill>
+          <a:blip r:embed="rId3"/>
+          <a:stretch>
+            <a:fillRect/>
+          </a:stretch>
+        </p:blipFill>
+        <p:spPr>
+          <a:xfrm>
+            <a:off x="10661650" y="6299200"/>
+            <a:ext cx="768350" cy="279400"/>
+          </a:xfrm>
+          <a:prstGeom prst="rect">
+            <a:avLst/>
+          </a:prstGeom>
+        </p:spPr>
+      </p:pic>
+      <p:sp>
+        <p:nvSpPr>
+          <p:cNvPr id="8" name="TextBox 7"/>
           <p:cNvSpPr txBox="1"/>
           <p:nvPr/>
         </p:nvSpPr>
         <p:spPr>
           <a:xfrm>
-            <a:off x="9906000" y="6375400"/>
+            <a:off x="8445500" y="6375400"/>
             <a:ext cx="381000" cy="190500"/>
           </a:xfrm>
           <a:prstGeom prst="rect">
@@ -5183,7 +5479,7 @@
         </p:blipFill>
         <p:spPr>
           <a:xfrm>
-            <a:off x="10490200" y="6324600"/>
+            <a:off x="9417050" y="6311900"/>
             <a:ext cx="939800" cy="254000"/>
           </a:xfrm>
           <a:prstGeom prst="rect">
@@ -5193,13 +5489,81 @@
       </p:pic>
       <p:sp>
         <p:nvSpPr>
-          <p:cNvPr id="20" name="TextBox 19"/>
+          <p:cNvPr id="20" name="Rectangle 19"/>
+          <p:cNvSpPr/>
+          <p:nvPr/>
+        </p:nvSpPr>
+        <p:spPr>
+          <a:xfrm>
+            <a:off x="10509250" y="6299200"/>
+            <a:ext cx="12700" cy="279400"/>
+          </a:xfrm>
+          <a:prstGeom prst="rect">
+            <a:avLst/>
+          </a:prstGeom>
+          <a:solidFill>
+            <a:srgbClr val="CDD9DE"/>
+          </a:solidFill>
+          <a:ln>
+            <a:noFill/>
+          </a:ln>
+          <a:effectLst/>
+        </p:spPr>
+        <p:style>
+          <a:lnRef idx="1">
+            <a:schemeClr val="accent1"/>
+          </a:lnRef>
+          <a:fillRef idx="3">
+            <a:schemeClr val="accent1"/>
+          </a:fillRef>
+          <a:effectRef idx="2">
+            <a:schemeClr val="accent1"/>
+          </a:effectRef>
+          <a:fontRef idx="minor">
+            <a:schemeClr val="lt1"/>
+          </a:fontRef>
+        </p:style>
+        <p:txBody>
+          <a:bodyPr rtlCol="0" anchor="ctr"/>
+          <a:lstStyle/>
+          <a:p>
+            <a:pPr algn="ctr"/>
+          </a:p>
+        </p:txBody>
+      </p:sp>
+      <p:pic>
+        <p:nvPicPr>
+          <p:cNvPr id="21" name="Picture 20" descr="logo_jisc_placeholder.png"/>
+          <p:cNvPicPr>
+            <a:picLocks noChangeAspect="1"/>
+          </p:cNvPicPr>
+          <p:nvPr/>
+        </p:nvPicPr>
+        <p:blipFill>
+          <a:blip r:embed="rId6"/>
+          <a:stretch>
+            <a:fillRect/>
+          </a:stretch>
+        </p:blipFill>
+        <p:spPr>
+          <a:xfrm>
+            <a:off x="10661650" y="6299200"/>
+            <a:ext cx="768350" cy="279400"/>
+          </a:xfrm>
+          <a:prstGeom prst="rect">
+            <a:avLst/>
+          </a:prstGeom>
+        </p:spPr>
+      </p:pic>
+      <p:sp>
+        <p:nvSpPr>
+          <p:cNvPr id="22" name="TextBox 21"/>
           <p:cNvSpPr txBox="1"/>
           <p:nvPr/>
         </p:nvSpPr>
         <p:spPr>
           <a:xfrm>
-            <a:off x="9906000" y="6375400"/>
+            <a:off x="8445500" y="6375400"/>
             <a:ext cx="381000" cy="190500"/>
           </a:xfrm>
           <a:prstGeom prst="rect">
@@ -6011,7 +6375,7 @@
         </p:blipFill>
         <p:spPr>
           <a:xfrm>
-            <a:off x="10490200" y="6324600"/>
+            <a:off x="9417050" y="6311900"/>
             <a:ext cx="939800" cy="254000"/>
           </a:xfrm>
           <a:prstGeom prst="rect">
@@ -6021,13 +6385,81 @@
       </p:pic>
       <p:sp>
         <p:nvSpPr>
-          <p:cNvPr id="20" name="TextBox 19"/>
+          <p:cNvPr id="20" name="Rectangle 19"/>
+          <p:cNvSpPr/>
+          <p:nvPr/>
+        </p:nvSpPr>
+        <p:spPr>
+          <a:xfrm>
+            <a:off x="10509250" y="6299200"/>
+            <a:ext cx="12700" cy="279400"/>
+          </a:xfrm>
+          <a:prstGeom prst="rect">
+            <a:avLst/>
+          </a:prstGeom>
+          <a:solidFill>
+            <a:srgbClr val="CDD9DE"/>
+          </a:solidFill>
+          <a:ln>
+            <a:noFill/>
+          </a:ln>
+          <a:effectLst/>
+        </p:spPr>
+        <p:style>
+          <a:lnRef idx="1">
+            <a:schemeClr val="accent1"/>
+          </a:lnRef>
+          <a:fillRef idx="3">
+            <a:schemeClr val="accent1"/>
+          </a:fillRef>
+          <a:effectRef idx="2">
+            <a:schemeClr val="accent1"/>
+          </a:effectRef>
+          <a:fontRef idx="minor">
+            <a:schemeClr val="lt1"/>
+          </a:fontRef>
+        </p:style>
+        <p:txBody>
+          <a:bodyPr rtlCol="0" anchor="ctr"/>
+          <a:lstStyle/>
+          <a:p>
+            <a:pPr algn="ctr"/>
+          </a:p>
+        </p:txBody>
+      </p:sp>
+      <p:pic>
+        <p:nvPicPr>
+          <p:cNvPr id="21" name="Picture 20" descr="logo_jisc_placeholder.png"/>
+          <p:cNvPicPr>
+            <a:picLocks noChangeAspect="1"/>
+          </p:cNvPicPr>
+          <p:nvPr/>
+        </p:nvPicPr>
+        <p:blipFill>
+          <a:blip r:embed="rId3"/>
+          <a:stretch>
+            <a:fillRect/>
+          </a:stretch>
+        </p:blipFill>
+        <p:spPr>
+          <a:xfrm>
+            <a:off x="10661650" y="6299200"/>
+            <a:ext cx="768350" cy="279400"/>
+          </a:xfrm>
+          <a:prstGeom prst="rect">
+            <a:avLst/>
+          </a:prstGeom>
+        </p:spPr>
+      </p:pic>
+      <p:sp>
+        <p:nvSpPr>
+          <p:cNvPr id="22" name="TextBox 21"/>
           <p:cNvSpPr txBox="1"/>
           <p:nvPr/>
         </p:nvSpPr>
         <p:spPr>
           <a:xfrm>
-            <a:off x="9906000" y="6375400"/>
+            <a:off x="8445500" y="6375400"/>
             <a:ext cx="381000" cy="190500"/>
           </a:xfrm>
           <a:prstGeom prst="rect">
@@ -6175,9 +6607,55 @@
           </a:p>
         </p:txBody>
       </p:sp>
+      <p:sp>
+        <p:nvSpPr>
+          <p:cNvPr id="4" name="Rounded Rectangle 3"/>
+          <p:cNvSpPr/>
+          <p:nvPr/>
+        </p:nvSpPr>
+        <p:spPr>
+          <a:xfrm>
+            <a:off x="9264650" y="6210300"/>
+            <a:ext cx="2317750" cy="457200"/>
+          </a:xfrm>
+          <a:prstGeom prst="roundRect">
+            <a:avLst>
+              <a:gd name="adj" fmla="val 25000"/>
+            </a:avLst>
+          </a:prstGeom>
+          <a:solidFill>
+            <a:srgbClr val="FFFFFF"/>
+          </a:solidFill>
+          <a:ln>
+            <a:noFill/>
+          </a:ln>
+          <a:effectLst/>
+        </p:spPr>
+        <p:style>
+          <a:lnRef idx="1">
+            <a:schemeClr val="accent1"/>
+          </a:lnRef>
+          <a:fillRef idx="3">
+            <a:schemeClr val="accent1"/>
+          </a:fillRef>
+          <a:effectRef idx="2">
+            <a:schemeClr val="accent1"/>
+          </a:effectRef>
+          <a:fontRef idx="minor">
+            <a:schemeClr val="lt1"/>
+          </a:fontRef>
+        </p:style>
+        <p:txBody>
+          <a:bodyPr rtlCol="0" anchor="ctr"/>
+          <a:lstStyle/>
+          <a:p>
+            <a:pPr algn="ctr"/>
+          </a:p>
+        </p:txBody>
+      </p:sp>
       <p:pic>
         <p:nvPicPr>
-          <p:cNvPr id="4" name="Picture 3" descr="logo_white_c.png"/>
+          <p:cNvPr id="5" name="Picture 4" descr="logo_navy_c.png"/>
           <p:cNvPicPr>
             <a:picLocks noChangeAspect="1"/>
           </p:cNvPicPr>
@@ -6191,7 +6669,7 @@
         </p:blipFill>
         <p:spPr>
           <a:xfrm>
-            <a:off x="10490200" y="6324600"/>
+            <a:off x="9417050" y="6311900"/>
             <a:ext cx="939800" cy="254000"/>
           </a:xfrm>
           <a:prstGeom prst="rect">
@@ -6201,13 +6679,81 @@
       </p:pic>
       <p:sp>
         <p:nvSpPr>
-          <p:cNvPr id="5" name="TextBox 4"/>
+          <p:cNvPr id="6" name="Rectangle 5"/>
+          <p:cNvSpPr/>
+          <p:nvPr/>
+        </p:nvSpPr>
+        <p:spPr>
+          <a:xfrm>
+            <a:off x="10509250" y="6299200"/>
+            <a:ext cx="12700" cy="279400"/>
+          </a:xfrm>
+          <a:prstGeom prst="rect">
+            <a:avLst/>
+          </a:prstGeom>
+          <a:solidFill>
+            <a:srgbClr val="CDD9DE"/>
+          </a:solidFill>
+          <a:ln>
+            <a:noFill/>
+          </a:ln>
+          <a:effectLst/>
+        </p:spPr>
+        <p:style>
+          <a:lnRef idx="1">
+            <a:schemeClr val="accent1"/>
+          </a:lnRef>
+          <a:fillRef idx="3">
+            <a:schemeClr val="accent1"/>
+          </a:fillRef>
+          <a:effectRef idx="2">
+            <a:schemeClr val="accent1"/>
+          </a:effectRef>
+          <a:fontRef idx="minor">
+            <a:schemeClr val="lt1"/>
+          </a:fontRef>
+        </p:style>
+        <p:txBody>
+          <a:bodyPr rtlCol="0" anchor="ctr"/>
+          <a:lstStyle/>
+          <a:p>
+            <a:pPr algn="ctr"/>
+          </a:p>
+        </p:txBody>
+      </p:sp>
+      <p:pic>
+        <p:nvPicPr>
+          <p:cNvPr id="7" name="Picture 6" descr="logo_jisc_placeholder.png"/>
+          <p:cNvPicPr>
+            <a:picLocks noChangeAspect="1"/>
+          </p:cNvPicPr>
+          <p:nvPr/>
+        </p:nvPicPr>
+        <p:blipFill>
+          <a:blip r:embed="rId3"/>
+          <a:stretch>
+            <a:fillRect/>
+          </a:stretch>
+        </p:blipFill>
+        <p:spPr>
+          <a:xfrm>
+            <a:off x="10661650" y="6299200"/>
+            <a:ext cx="768350" cy="279400"/>
+          </a:xfrm>
+          <a:prstGeom prst="rect">
+            <a:avLst/>
+          </a:prstGeom>
+        </p:spPr>
+      </p:pic>
+      <p:sp>
+        <p:nvSpPr>
+          <p:cNvPr id="8" name="TextBox 7"/>
           <p:cNvSpPr txBox="1"/>
           <p:nvPr/>
         </p:nvSpPr>
         <p:spPr>
           <a:xfrm>
-            <a:off x="9906000" y="6375400"/>
+            <a:off x="8445500" y="6375400"/>
             <a:ext cx="381000" cy="190500"/>
           </a:xfrm>
           <a:prstGeom prst="rect">
@@ -6417,9 +6963,55 @@
           </a:p>
         </p:txBody>
       </p:sp>
+      <p:sp>
+        <p:nvSpPr>
+          <p:cNvPr id="6" name="Rounded Rectangle 5"/>
+          <p:cNvSpPr/>
+          <p:nvPr/>
+        </p:nvSpPr>
+        <p:spPr>
+          <a:xfrm>
+            <a:off x="9264650" y="6210300"/>
+            <a:ext cx="2317750" cy="457200"/>
+          </a:xfrm>
+          <a:prstGeom prst="roundRect">
+            <a:avLst>
+              <a:gd name="adj" fmla="val 25000"/>
+            </a:avLst>
+          </a:prstGeom>
+          <a:solidFill>
+            <a:srgbClr val="FFFFFF"/>
+          </a:solidFill>
+          <a:ln>
+            <a:noFill/>
+          </a:ln>
+          <a:effectLst/>
+        </p:spPr>
+        <p:style>
+          <a:lnRef idx="1">
+            <a:schemeClr val="accent1"/>
+          </a:lnRef>
+          <a:fillRef idx="3">
+            <a:schemeClr val="accent1"/>
+          </a:fillRef>
+          <a:effectRef idx="2">
+            <a:schemeClr val="accent1"/>
+          </a:effectRef>
+          <a:fontRef idx="minor">
+            <a:schemeClr val="lt1"/>
+          </a:fontRef>
+        </p:style>
+        <p:txBody>
+          <a:bodyPr rtlCol="0" anchor="ctr"/>
+          <a:lstStyle/>
+          <a:p>
+            <a:pPr algn="ctr"/>
+          </a:p>
+        </p:txBody>
+      </p:sp>
       <p:pic>
         <p:nvPicPr>
-          <p:cNvPr id="6" name="Picture 5" descr="logo_white_c.png"/>
+          <p:cNvPr id="7" name="Picture 6" descr="logo_navy_c.png"/>
           <p:cNvPicPr>
             <a:picLocks noChangeAspect="1"/>
           </p:cNvPicPr>
@@ -6433,7 +7025,7 @@
         </p:blipFill>
         <p:spPr>
           <a:xfrm>
-            <a:off x="10490200" y="6324600"/>
+            <a:off x="9417050" y="6311900"/>
             <a:ext cx="939800" cy="254000"/>
           </a:xfrm>
           <a:prstGeom prst="rect">
@@ -6443,13 +7035,81 @@
       </p:pic>
       <p:sp>
         <p:nvSpPr>
-          <p:cNvPr id="7" name="TextBox 6"/>
+          <p:cNvPr id="8" name="Rectangle 7"/>
+          <p:cNvSpPr/>
+          <p:nvPr/>
+        </p:nvSpPr>
+        <p:spPr>
+          <a:xfrm>
+            <a:off x="10509250" y="6299200"/>
+            <a:ext cx="12700" cy="279400"/>
+          </a:xfrm>
+          <a:prstGeom prst="rect">
+            <a:avLst/>
+          </a:prstGeom>
+          <a:solidFill>
+            <a:srgbClr val="CDD9DE"/>
+          </a:solidFill>
+          <a:ln>
+            <a:noFill/>
+          </a:ln>
+          <a:effectLst/>
+        </p:spPr>
+        <p:style>
+          <a:lnRef idx="1">
+            <a:schemeClr val="accent1"/>
+          </a:lnRef>
+          <a:fillRef idx="3">
+            <a:schemeClr val="accent1"/>
+          </a:fillRef>
+          <a:effectRef idx="2">
+            <a:schemeClr val="accent1"/>
+          </a:effectRef>
+          <a:fontRef idx="minor">
+            <a:schemeClr val="lt1"/>
+          </a:fontRef>
+        </p:style>
+        <p:txBody>
+          <a:bodyPr rtlCol="0" anchor="ctr"/>
+          <a:lstStyle/>
+          <a:p>
+            <a:pPr algn="ctr"/>
+          </a:p>
+        </p:txBody>
+      </p:sp>
+      <p:pic>
+        <p:nvPicPr>
+          <p:cNvPr id="9" name="Picture 8" descr="logo_jisc_placeholder.png"/>
+          <p:cNvPicPr>
+            <a:picLocks noChangeAspect="1"/>
+          </p:cNvPicPr>
+          <p:nvPr/>
+        </p:nvPicPr>
+        <p:blipFill>
+          <a:blip r:embed="rId3"/>
+          <a:stretch>
+            <a:fillRect/>
+          </a:stretch>
+        </p:blipFill>
+        <p:spPr>
+          <a:xfrm>
+            <a:off x="10661650" y="6299200"/>
+            <a:ext cx="768350" cy="279400"/>
+          </a:xfrm>
+          <a:prstGeom prst="rect">
+            <a:avLst/>
+          </a:prstGeom>
+        </p:spPr>
+      </p:pic>
+      <p:sp>
+        <p:nvSpPr>
+          <p:cNvPr id="10" name="TextBox 9"/>
           <p:cNvSpPr txBox="1"/>
           <p:nvPr/>
         </p:nvSpPr>
         <p:spPr>
           <a:xfrm>
-            <a:off x="9906000" y="6375400"/>
+            <a:off x="8445500" y="6375400"/>
             <a:ext cx="381000" cy="190500"/>
           </a:xfrm>
           <a:prstGeom prst="rect">
@@ -7052,7 +7712,7 @@
         </p:blipFill>
         <p:spPr>
           <a:xfrm>
-            <a:off x="10490200" y="6324600"/>
+            <a:off x="9417050" y="6311900"/>
             <a:ext cx="939800" cy="254000"/>
           </a:xfrm>
           <a:prstGeom prst="rect">
@@ -7062,13 +7722,81 @@
       </p:pic>
       <p:sp>
         <p:nvSpPr>
-          <p:cNvPr id="15" name="TextBox 14"/>
+          <p:cNvPr id="15" name="Rectangle 14"/>
+          <p:cNvSpPr/>
+          <p:nvPr/>
+        </p:nvSpPr>
+        <p:spPr>
+          <a:xfrm>
+            <a:off x="10509250" y="6299200"/>
+            <a:ext cx="12700" cy="279400"/>
+          </a:xfrm>
+          <a:prstGeom prst="rect">
+            <a:avLst/>
+          </a:prstGeom>
+          <a:solidFill>
+            <a:srgbClr val="CDD9DE"/>
+          </a:solidFill>
+          <a:ln>
+            <a:noFill/>
+          </a:ln>
+          <a:effectLst/>
+        </p:spPr>
+        <p:style>
+          <a:lnRef idx="1">
+            <a:schemeClr val="accent1"/>
+          </a:lnRef>
+          <a:fillRef idx="3">
+            <a:schemeClr val="accent1"/>
+          </a:fillRef>
+          <a:effectRef idx="2">
+            <a:schemeClr val="accent1"/>
+          </a:effectRef>
+          <a:fontRef idx="minor">
+            <a:schemeClr val="lt1"/>
+          </a:fontRef>
+        </p:style>
+        <p:txBody>
+          <a:bodyPr rtlCol="0" anchor="ctr"/>
+          <a:lstStyle/>
+          <a:p>
+            <a:pPr algn="ctr"/>
+          </a:p>
+        </p:txBody>
+      </p:sp>
+      <p:pic>
+        <p:nvPicPr>
+          <p:cNvPr id="16" name="Picture 15" descr="logo_jisc_placeholder.png"/>
+          <p:cNvPicPr>
+            <a:picLocks noChangeAspect="1"/>
+          </p:cNvPicPr>
+          <p:nvPr/>
+        </p:nvPicPr>
+        <p:blipFill>
+          <a:blip r:embed="rId3"/>
+          <a:stretch>
+            <a:fillRect/>
+          </a:stretch>
+        </p:blipFill>
+        <p:spPr>
+          <a:xfrm>
+            <a:off x="10661650" y="6299200"/>
+            <a:ext cx="768350" cy="279400"/>
+          </a:xfrm>
+          <a:prstGeom prst="rect">
+            <a:avLst/>
+          </a:prstGeom>
+        </p:spPr>
+      </p:pic>
+      <p:sp>
+        <p:nvSpPr>
+          <p:cNvPr id="17" name="TextBox 16"/>
           <p:cNvSpPr txBox="1"/>
           <p:nvPr/>
         </p:nvSpPr>
         <p:spPr>
           <a:xfrm>
-            <a:off x="9906000" y="6375400"/>
+            <a:off x="8445500" y="6375400"/>
             <a:ext cx="381000" cy="190500"/>
           </a:xfrm>
           <a:prstGeom prst="rect">
@@ -8264,7 +8992,7 @@
         </p:blipFill>
         <p:spPr>
           <a:xfrm>
-            <a:off x="10490200" y="6324600"/>
+            <a:off x="9417050" y="6311900"/>
             <a:ext cx="939800" cy="254000"/>
           </a:xfrm>
           <a:prstGeom prst="rect">
@@ -8274,13 +9002,81 @@
       </p:pic>
       <p:sp>
         <p:nvSpPr>
-          <p:cNvPr id="28" name="TextBox 27"/>
+          <p:cNvPr id="28" name="Rectangle 27"/>
+          <p:cNvSpPr/>
+          <p:nvPr/>
+        </p:nvSpPr>
+        <p:spPr>
+          <a:xfrm>
+            <a:off x="10509250" y="6299200"/>
+            <a:ext cx="12700" cy="279400"/>
+          </a:xfrm>
+          <a:prstGeom prst="rect">
+            <a:avLst/>
+          </a:prstGeom>
+          <a:solidFill>
+            <a:srgbClr val="CDD9DE"/>
+          </a:solidFill>
+          <a:ln>
+            <a:noFill/>
+          </a:ln>
+          <a:effectLst/>
+        </p:spPr>
+        <p:style>
+          <a:lnRef idx="1">
+            <a:schemeClr val="accent1"/>
+          </a:lnRef>
+          <a:fillRef idx="3">
+            <a:schemeClr val="accent1"/>
+          </a:fillRef>
+          <a:effectRef idx="2">
+            <a:schemeClr val="accent1"/>
+          </a:effectRef>
+          <a:fontRef idx="minor">
+            <a:schemeClr val="lt1"/>
+          </a:fontRef>
+        </p:style>
+        <p:txBody>
+          <a:bodyPr rtlCol="0" anchor="ctr"/>
+          <a:lstStyle/>
+          <a:p>
+            <a:pPr algn="ctr"/>
+          </a:p>
+        </p:txBody>
+      </p:sp>
+      <p:pic>
+        <p:nvPicPr>
+          <p:cNvPr id="29" name="Picture 28" descr="logo_jisc_placeholder.png"/>
+          <p:cNvPicPr>
+            <a:picLocks noChangeAspect="1"/>
+          </p:cNvPicPr>
+          <p:nvPr/>
+        </p:nvPicPr>
+        <p:blipFill>
+          <a:blip r:embed="rId3"/>
+          <a:stretch>
+            <a:fillRect/>
+          </a:stretch>
+        </p:blipFill>
+        <p:spPr>
+          <a:xfrm>
+            <a:off x="10661650" y="6299200"/>
+            <a:ext cx="768350" cy="279400"/>
+          </a:xfrm>
+          <a:prstGeom prst="rect">
+            <a:avLst/>
+          </a:prstGeom>
+        </p:spPr>
+      </p:pic>
+      <p:sp>
+        <p:nvSpPr>
+          <p:cNvPr id="30" name="TextBox 29"/>
           <p:cNvSpPr txBox="1"/>
           <p:nvPr/>
         </p:nvSpPr>
         <p:spPr>
           <a:xfrm>
-            <a:off x="9906000" y="6375400"/>
+            <a:off x="8445500" y="6375400"/>
             <a:ext cx="381000" cy="190500"/>
           </a:xfrm>
           <a:prstGeom prst="rect">
@@ -9107,7 +9903,7 @@
         </p:blipFill>
         <p:spPr>
           <a:xfrm>
-            <a:off x="10490200" y="6324600"/>
+            <a:off x="9417050" y="6311900"/>
             <a:ext cx="939800" cy="254000"/>
           </a:xfrm>
           <a:prstGeom prst="rect">
@@ -9117,13 +9913,81 @@
       </p:pic>
       <p:sp>
         <p:nvSpPr>
-          <p:cNvPr id="21" name="TextBox 20"/>
+          <p:cNvPr id="21" name="Rectangle 20"/>
+          <p:cNvSpPr/>
+          <p:nvPr/>
+        </p:nvSpPr>
+        <p:spPr>
+          <a:xfrm>
+            <a:off x="10509250" y="6299200"/>
+            <a:ext cx="12700" cy="279400"/>
+          </a:xfrm>
+          <a:prstGeom prst="rect">
+            <a:avLst/>
+          </a:prstGeom>
+          <a:solidFill>
+            <a:srgbClr val="CDD9DE"/>
+          </a:solidFill>
+          <a:ln>
+            <a:noFill/>
+          </a:ln>
+          <a:effectLst/>
+        </p:spPr>
+        <p:style>
+          <a:lnRef idx="1">
+            <a:schemeClr val="accent1"/>
+          </a:lnRef>
+          <a:fillRef idx="3">
+            <a:schemeClr val="accent1"/>
+          </a:fillRef>
+          <a:effectRef idx="2">
+            <a:schemeClr val="accent1"/>
+          </a:effectRef>
+          <a:fontRef idx="minor">
+            <a:schemeClr val="lt1"/>
+          </a:fontRef>
+        </p:style>
+        <p:txBody>
+          <a:bodyPr rtlCol="0" anchor="ctr"/>
+          <a:lstStyle/>
+          <a:p>
+            <a:pPr algn="ctr"/>
+          </a:p>
+        </p:txBody>
+      </p:sp>
+      <p:pic>
+        <p:nvPicPr>
+          <p:cNvPr id="22" name="Picture 21" descr="logo_jisc_placeholder.png"/>
+          <p:cNvPicPr>
+            <a:picLocks noChangeAspect="1"/>
+          </p:cNvPicPr>
+          <p:nvPr/>
+        </p:nvPicPr>
+        <p:blipFill>
+          <a:blip r:embed="rId7"/>
+          <a:stretch>
+            <a:fillRect/>
+          </a:stretch>
+        </p:blipFill>
+        <p:spPr>
+          <a:xfrm>
+            <a:off x="10661650" y="6299200"/>
+            <a:ext cx="768350" cy="279400"/>
+          </a:xfrm>
+          <a:prstGeom prst="rect">
+            <a:avLst/>
+          </a:prstGeom>
+        </p:spPr>
+      </p:pic>
+      <p:sp>
+        <p:nvSpPr>
+          <p:cNvPr id="23" name="TextBox 22"/>
           <p:cNvSpPr txBox="1"/>
           <p:nvPr/>
         </p:nvSpPr>
         <p:spPr>
           <a:xfrm>
-            <a:off x="9906000" y="6375400"/>
+            <a:off x="8445500" y="6375400"/>
             <a:ext cx="381000" cy="190500"/>
           </a:xfrm>
           <a:prstGeom prst="rect">
@@ -10731,7 +11595,7 @@
         </p:blipFill>
         <p:spPr>
           <a:xfrm>
-            <a:off x="10490200" y="6324600"/>
+            <a:off x="9417050" y="6311900"/>
             <a:ext cx="939800" cy="254000"/>
           </a:xfrm>
           <a:prstGeom prst="rect">
@@ -10741,13 +11605,81 @@
       </p:pic>
       <p:sp>
         <p:nvSpPr>
-          <p:cNvPr id="40" name="TextBox 39"/>
+          <p:cNvPr id="40" name="Rectangle 39"/>
+          <p:cNvSpPr/>
+          <p:nvPr/>
+        </p:nvSpPr>
+        <p:spPr>
+          <a:xfrm>
+            <a:off x="10509250" y="6299200"/>
+            <a:ext cx="12700" cy="279400"/>
+          </a:xfrm>
+          <a:prstGeom prst="rect">
+            <a:avLst/>
+          </a:prstGeom>
+          <a:solidFill>
+            <a:srgbClr val="CDD9DE"/>
+          </a:solidFill>
+          <a:ln>
+            <a:noFill/>
+          </a:ln>
+          <a:effectLst/>
+        </p:spPr>
+        <p:style>
+          <a:lnRef idx="1">
+            <a:schemeClr val="accent1"/>
+          </a:lnRef>
+          <a:fillRef idx="3">
+            <a:schemeClr val="accent1"/>
+          </a:fillRef>
+          <a:effectRef idx="2">
+            <a:schemeClr val="accent1"/>
+          </a:effectRef>
+          <a:fontRef idx="minor">
+            <a:schemeClr val="lt1"/>
+          </a:fontRef>
+        </p:style>
+        <p:txBody>
+          <a:bodyPr rtlCol="0" anchor="ctr"/>
+          <a:lstStyle/>
+          <a:p>
+            <a:pPr algn="ctr"/>
+          </a:p>
+        </p:txBody>
+      </p:sp>
+      <p:pic>
+        <p:nvPicPr>
+          <p:cNvPr id="41" name="Picture 40" descr="logo_jisc_placeholder.png"/>
+          <p:cNvPicPr>
+            <a:picLocks noChangeAspect="1"/>
+          </p:cNvPicPr>
+          <p:nvPr/>
+        </p:nvPicPr>
+        <p:blipFill>
+          <a:blip r:embed="rId3"/>
+          <a:stretch>
+            <a:fillRect/>
+          </a:stretch>
+        </p:blipFill>
+        <p:spPr>
+          <a:xfrm>
+            <a:off x="10661650" y="6299200"/>
+            <a:ext cx="768350" cy="279400"/>
+          </a:xfrm>
+          <a:prstGeom prst="rect">
+            <a:avLst/>
+          </a:prstGeom>
+        </p:spPr>
+      </p:pic>
+      <p:sp>
+        <p:nvSpPr>
+          <p:cNvPr id="42" name="TextBox 41"/>
           <p:cNvSpPr txBox="1"/>
           <p:nvPr/>
         </p:nvSpPr>
         <p:spPr>
           <a:xfrm>
-            <a:off x="9906000" y="6375400"/>
+            <a:off x="8445500" y="6375400"/>
             <a:ext cx="381000" cy="190500"/>
           </a:xfrm>
           <a:prstGeom prst="rect">
@@ -11473,7 +12405,7 @@
         </p:blipFill>
         <p:spPr>
           <a:xfrm>
-            <a:off x="10490200" y="6324600"/>
+            <a:off x="9417050" y="6311900"/>
             <a:ext cx="939800" cy="254000"/>
           </a:xfrm>
           <a:prstGeom prst="rect">
@@ -11483,13 +12415,81 @@
       </p:pic>
       <p:sp>
         <p:nvSpPr>
-          <p:cNvPr id="19" name="TextBox 18"/>
+          <p:cNvPr id="19" name="Rectangle 18"/>
+          <p:cNvSpPr/>
+          <p:nvPr/>
+        </p:nvSpPr>
+        <p:spPr>
+          <a:xfrm>
+            <a:off x="10509250" y="6299200"/>
+            <a:ext cx="12700" cy="279400"/>
+          </a:xfrm>
+          <a:prstGeom prst="rect">
+            <a:avLst/>
+          </a:prstGeom>
+          <a:solidFill>
+            <a:srgbClr val="CDD9DE"/>
+          </a:solidFill>
+          <a:ln>
+            <a:noFill/>
+          </a:ln>
+          <a:effectLst/>
+        </p:spPr>
+        <p:style>
+          <a:lnRef idx="1">
+            <a:schemeClr val="accent1"/>
+          </a:lnRef>
+          <a:fillRef idx="3">
+            <a:schemeClr val="accent1"/>
+          </a:fillRef>
+          <a:effectRef idx="2">
+            <a:schemeClr val="accent1"/>
+          </a:effectRef>
+          <a:fontRef idx="minor">
+            <a:schemeClr val="lt1"/>
+          </a:fontRef>
+        </p:style>
+        <p:txBody>
+          <a:bodyPr rtlCol="0" anchor="ctr"/>
+          <a:lstStyle/>
+          <a:p>
+            <a:pPr algn="ctr"/>
+          </a:p>
+        </p:txBody>
+      </p:sp>
+      <p:pic>
+        <p:nvPicPr>
+          <p:cNvPr id="20" name="Picture 19" descr="logo_jisc_placeholder.png"/>
+          <p:cNvPicPr>
+            <a:picLocks noChangeAspect="1"/>
+          </p:cNvPicPr>
+          <p:nvPr/>
+        </p:nvPicPr>
+        <p:blipFill>
+          <a:blip r:embed="rId7"/>
+          <a:stretch>
+            <a:fillRect/>
+          </a:stretch>
+        </p:blipFill>
+        <p:spPr>
+          <a:xfrm>
+            <a:off x="10661650" y="6299200"/>
+            <a:ext cx="768350" cy="279400"/>
+          </a:xfrm>
+          <a:prstGeom prst="rect">
+            <a:avLst/>
+          </a:prstGeom>
+        </p:spPr>
+      </p:pic>
+      <p:sp>
+        <p:nvSpPr>
+          <p:cNvPr id="21" name="TextBox 20"/>
           <p:cNvSpPr txBox="1"/>
           <p:nvPr/>
         </p:nvSpPr>
         <p:spPr>
           <a:xfrm>
-            <a:off x="9906000" y="6375400"/>
+            <a:off x="8445500" y="6375400"/>
             <a:ext cx="381000" cy="190500"/>
           </a:xfrm>
           <a:prstGeom prst="rect">
@@ -17628,9 +18628,55 @@
           </a:p>
         </p:txBody>
       </p:sp>
+      <p:sp>
+        <p:nvSpPr>
+          <p:cNvPr id="135" name="Rounded Rectangle 134"/>
+          <p:cNvSpPr/>
+          <p:nvPr/>
+        </p:nvSpPr>
+        <p:spPr>
+          <a:xfrm>
+            <a:off x="9264650" y="6210300"/>
+            <a:ext cx="2317750" cy="457200"/>
+          </a:xfrm>
+          <a:prstGeom prst="roundRect">
+            <a:avLst>
+              <a:gd name="adj" fmla="val 25000"/>
+            </a:avLst>
+          </a:prstGeom>
+          <a:solidFill>
+            <a:srgbClr val="FFFFFF"/>
+          </a:solidFill>
+          <a:ln>
+            <a:noFill/>
+          </a:ln>
+          <a:effectLst/>
+        </p:spPr>
+        <p:style>
+          <a:lnRef idx="1">
+            <a:schemeClr val="accent1"/>
+          </a:lnRef>
+          <a:fillRef idx="3">
+            <a:schemeClr val="accent1"/>
+          </a:fillRef>
+          <a:effectRef idx="2">
+            <a:schemeClr val="accent1"/>
+          </a:effectRef>
+          <a:fontRef idx="minor">
+            <a:schemeClr val="lt1"/>
+          </a:fontRef>
+        </p:style>
+        <p:txBody>
+          <a:bodyPr rtlCol="0" anchor="ctr"/>
+          <a:lstStyle/>
+          <a:p>
+            <a:pPr algn="ctr"/>
+          </a:p>
+        </p:txBody>
+      </p:sp>
       <p:pic>
         <p:nvPicPr>
-          <p:cNvPr id="135" name="Picture 134" descr="logo_white_c.png"/>
+          <p:cNvPr id="136" name="Picture 135" descr="logo_navy_c.png"/>
           <p:cNvPicPr>
             <a:picLocks noChangeAspect="1"/>
           </p:cNvPicPr>
@@ -17644,7 +18690,7 @@
         </p:blipFill>
         <p:spPr>
           <a:xfrm>
-            <a:off x="10490200" y="6324600"/>
+            <a:off x="9417050" y="6311900"/>
             <a:ext cx="939800" cy="254000"/>
           </a:xfrm>
           <a:prstGeom prst="rect">
@@ -17654,13 +18700,81 @@
       </p:pic>
       <p:sp>
         <p:nvSpPr>
-          <p:cNvPr id="136" name="TextBox 135"/>
+          <p:cNvPr id="137" name="Rectangle 136"/>
+          <p:cNvSpPr/>
+          <p:nvPr/>
+        </p:nvSpPr>
+        <p:spPr>
+          <a:xfrm>
+            <a:off x="10509250" y="6299200"/>
+            <a:ext cx="12700" cy="279400"/>
+          </a:xfrm>
+          <a:prstGeom prst="rect">
+            <a:avLst/>
+          </a:prstGeom>
+          <a:solidFill>
+            <a:srgbClr val="CDD9DE"/>
+          </a:solidFill>
+          <a:ln>
+            <a:noFill/>
+          </a:ln>
+          <a:effectLst/>
+        </p:spPr>
+        <p:style>
+          <a:lnRef idx="1">
+            <a:schemeClr val="accent1"/>
+          </a:lnRef>
+          <a:fillRef idx="3">
+            <a:schemeClr val="accent1"/>
+          </a:fillRef>
+          <a:effectRef idx="2">
+            <a:schemeClr val="accent1"/>
+          </a:effectRef>
+          <a:fontRef idx="minor">
+            <a:schemeClr val="lt1"/>
+          </a:fontRef>
+        </p:style>
+        <p:txBody>
+          <a:bodyPr rtlCol="0" anchor="ctr"/>
+          <a:lstStyle/>
+          <a:p>
+            <a:pPr algn="ctr"/>
+          </a:p>
+        </p:txBody>
+      </p:sp>
+      <p:pic>
+        <p:nvPicPr>
+          <p:cNvPr id="138" name="Picture 137" descr="logo_jisc_placeholder.png"/>
+          <p:cNvPicPr>
+            <a:picLocks noChangeAspect="1"/>
+          </p:cNvPicPr>
+          <p:nvPr/>
+        </p:nvPicPr>
+        <p:blipFill>
+          <a:blip r:embed="rId3"/>
+          <a:stretch>
+            <a:fillRect/>
+          </a:stretch>
+        </p:blipFill>
+        <p:spPr>
+          <a:xfrm>
+            <a:off x="10661650" y="6299200"/>
+            <a:ext cx="768350" cy="279400"/>
+          </a:xfrm>
+          <a:prstGeom prst="rect">
+            <a:avLst/>
+          </a:prstGeom>
+        </p:spPr>
+      </p:pic>
+      <p:sp>
+        <p:nvSpPr>
+          <p:cNvPr id="139" name="TextBox 138"/>
           <p:cNvSpPr txBox="1"/>
           <p:nvPr/>
         </p:nvSpPr>
         <p:spPr>
           <a:xfrm>
-            <a:off x="9906000" y="6375400"/>
+            <a:off x="8445500" y="6375400"/>
             <a:ext cx="381000" cy="190500"/>
           </a:xfrm>
           <a:prstGeom prst="rect">
@@ -20498,7 +21612,7 @@
         </p:blipFill>
         <p:spPr>
           <a:xfrm>
-            <a:off x="10490200" y="6324600"/>
+            <a:off x="9417050" y="6311900"/>
             <a:ext cx="939800" cy="254000"/>
           </a:xfrm>
           <a:prstGeom prst="rect">
@@ -20508,13 +21622,81 @@
       </p:pic>
       <p:sp>
         <p:nvSpPr>
-          <p:cNvPr id="64" name="TextBox 63"/>
+          <p:cNvPr id="64" name="Rectangle 63"/>
+          <p:cNvSpPr/>
+          <p:nvPr/>
+        </p:nvSpPr>
+        <p:spPr>
+          <a:xfrm>
+            <a:off x="10509250" y="6299200"/>
+            <a:ext cx="12700" cy="279400"/>
+          </a:xfrm>
+          <a:prstGeom prst="rect">
+            <a:avLst/>
+          </a:prstGeom>
+          <a:solidFill>
+            <a:srgbClr val="CDD9DE"/>
+          </a:solidFill>
+          <a:ln>
+            <a:noFill/>
+          </a:ln>
+          <a:effectLst/>
+        </p:spPr>
+        <p:style>
+          <a:lnRef idx="1">
+            <a:schemeClr val="accent1"/>
+          </a:lnRef>
+          <a:fillRef idx="3">
+            <a:schemeClr val="accent1"/>
+          </a:fillRef>
+          <a:effectRef idx="2">
+            <a:schemeClr val="accent1"/>
+          </a:effectRef>
+          <a:fontRef idx="minor">
+            <a:schemeClr val="lt1"/>
+          </a:fontRef>
+        </p:style>
+        <p:txBody>
+          <a:bodyPr rtlCol="0" anchor="ctr"/>
+          <a:lstStyle/>
+          <a:p>
+            <a:pPr algn="ctr"/>
+          </a:p>
+        </p:txBody>
+      </p:sp>
+      <p:pic>
+        <p:nvPicPr>
+          <p:cNvPr id="65" name="Picture 64" descr="logo_jisc_placeholder.png"/>
+          <p:cNvPicPr>
+            <a:picLocks noChangeAspect="1"/>
+          </p:cNvPicPr>
+          <p:nvPr/>
+        </p:nvPicPr>
+        <p:blipFill>
+          <a:blip r:embed="rId3"/>
+          <a:stretch>
+            <a:fillRect/>
+          </a:stretch>
+        </p:blipFill>
+        <p:spPr>
+          <a:xfrm>
+            <a:off x="10661650" y="6299200"/>
+            <a:ext cx="768350" cy="279400"/>
+          </a:xfrm>
+          <a:prstGeom prst="rect">
+            <a:avLst/>
+          </a:prstGeom>
+        </p:spPr>
+      </p:pic>
+      <p:sp>
+        <p:nvSpPr>
+          <p:cNvPr id="66" name="TextBox 65"/>
           <p:cNvSpPr txBox="1"/>
           <p:nvPr/>
         </p:nvSpPr>
         <p:spPr>
           <a:xfrm>
-            <a:off x="9906000" y="6375400"/>
+            <a:off x="8445500" y="6375400"/>
             <a:ext cx="381000" cy="190500"/>
           </a:xfrm>
           <a:prstGeom prst="rect">
@@ -21088,7 +22270,7 @@
         </p:blipFill>
         <p:spPr>
           <a:xfrm>
-            <a:off x="10490200" y="6324600"/>
+            <a:off x="9417050" y="6311900"/>
             <a:ext cx="939800" cy="254000"/>
           </a:xfrm>
           <a:prstGeom prst="rect">
@@ -21098,13 +22280,81 @@
       </p:pic>
       <p:sp>
         <p:nvSpPr>
-          <p:cNvPr id="14" name="TextBox 13"/>
+          <p:cNvPr id="14" name="Rectangle 13"/>
+          <p:cNvSpPr/>
+          <p:nvPr/>
+        </p:nvSpPr>
+        <p:spPr>
+          <a:xfrm>
+            <a:off x="10509250" y="6299200"/>
+            <a:ext cx="12700" cy="279400"/>
+          </a:xfrm>
+          <a:prstGeom prst="rect">
+            <a:avLst/>
+          </a:prstGeom>
+          <a:solidFill>
+            <a:srgbClr val="CDD9DE"/>
+          </a:solidFill>
+          <a:ln>
+            <a:noFill/>
+          </a:ln>
+          <a:effectLst/>
+        </p:spPr>
+        <p:style>
+          <a:lnRef idx="1">
+            <a:schemeClr val="accent1"/>
+          </a:lnRef>
+          <a:fillRef idx="3">
+            <a:schemeClr val="accent1"/>
+          </a:fillRef>
+          <a:effectRef idx="2">
+            <a:schemeClr val="accent1"/>
+          </a:effectRef>
+          <a:fontRef idx="minor">
+            <a:schemeClr val="lt1"/>
+          </a:fontRef>
+        </p:style>
+        <p:txBody>
+          <a:bodyPr rtlCol="0" anchor="ctr"/>
+          <a:lstStyle/>
+          <a:p>
+            <a:pPr algn="ctr"/>
+          </a:p>
+        </p:txBody>
+      </p:sp>
+      <p:pic>
+        <p:nvPicPr>
+          <p:cNvPr id="15" name="Picture 14" descr="logo_jisc_placeholder.png"/>
+          <p:cNvPicPr>
+            <a:picLocks noChangeAspect="1"/>
+          </p:cNvPicPr>
+          <p:nvPr/>
+        </p:nvPicPr>
+        <p:blipFill>
+          <a:blip r:embed="rId5"/>
+          <a:stretch>
+            <a:fillRect/>
+          </a:stretch>
+        </p:blipFill>
+        <p:spPr>
+          <a:xfrm>
+            <a:off x="10661650" y="6299200"/>
+            <a:ext cx="768350" cy="279400"/>
+          </a:xfrm>
+          <a:prstGeom prst="rect">
+            <a:avLst/>
+          </a:prstGeom>
+        </p:spPr>
+      </p:pic>
+      <p:sp>
+        <p:nvSpPr>
+          <p:cNvPr id="16" name="TextBox 15"/>
           <p:cNvSpPr txBox="1"/>
           <p:nvPr/>
         </p:nvSpPr>
         <p:spPr>
           <a:xfrm>
-            <a:off x="9906000" y="6375400"/>
+            <a:off x="8445500" y="6375400"/>
             <a:ext cx="381000" cy="190500"/>
           </a:xfrm>
           <a:prstGeom prst="rect">
@@ -22713,7 +23963,7 @@
         </p:blipFill>
         <p:spPr>
           <a:xfrm>
-            <a:off x="10490200" y="6324600"/>
+            <a:off x="9417050" y="6311900"/>
             <a:ext cx="939800" cy="254000"/>
           </a:xfrm>
           <a:prstGeom prst="rect">
@@ -22723,13 +23973,81 @@
       </p:pic>
       <p:sp>
         <p:nvSpPr>
-          <p:cNvPr id="37" name="TextBox 36"/>
+          <p:cNvPr id="37" name="Rectangle 36"/>
+          <p:cNvSpPr/>
+          <p:nvPr/>
+        </p:nvSpPr>
+        <p:spPr>
+          <a:xfrm>
+            <a:off x="10509250" y="6299200"/>
+            <a:ext cx="12700" cy="279400"/>
+          </a:xfrm>
+          <a:prstGeom prst="rect">
+            <a:avLst/>
+          </a:prstGeom>
+          <a:solidFill>
+            <a:srgbClr val="CDD9DE"/>
+          </a:solidFill>
+          <a:ln>
+            <a:noFill/>
+          </a:ln>
+          <a:effectLst/>
+        </p:spPr>
+        <p:style>
+          <a:lnRef idx="1">
+            <a:schemeClr val="accent1"/>
+          </a:lnRef>
+          <a:fillRef idx="3">
+            <a:schemeClr val="accent1"/>
+          </a:fillRef>
+          <a:effectRef idx="2">
+            <a:schemeClr val="accent1"/>
+          </a:effectRef>
+          <a:fontRef idx="minor">
+            <a:schemeClr val="lt1"/>
+          </a:fontRef>
+        </p:style>
+        <p:txBody>
+          <a:bodyPr rtlCol="0" anchor="ctr"/>
+          <a:lstStyle/>
+          <a:p>
+            <a:pPr algn="ctr"/>
+          </a:p>
+        </p:txBody>
+      </p:sp>
+      <p:pic>
+        <p:nvPicPr>
+          <p:cNvPr id="38" name="Picture 37" descr="logo_jisc_placeholder.png"/>
+          <p:cNvPicPr>
+            <a:picLocks noChangeAspect="1"/>
+          </p:cNvPicPr>
+          <p:nvPr/>
+        </p:nvPicPr>
+        <p:blipFill>
+          <a:blip r:embed="rId4"/>
+          <a:stretch>
+            <a:fillRect/>
+          </a:stretch>
+        </p:blipFill>
+        <p:spPr>
+          <a:xfrm>
+            <a:off x="10661650" y="6299200"/>
+            <a:ext cx="768350" cy="279400"/>
+          </a:xfrm>
+          <a:prstGeom prst="rect">
+            <a:avLst/>
+          </a:prstGeom>
+        </p:spPr>
+      </p:pic>
+      <p:sp>
+        <p:nvSpPr>
+          <p:cNvPr id="39" name="TextBox 38"/>
           <p:cNvSpPr txBox="1"/>
           <p:nvPr/>
         </p:nvSpPr>
         <p:spPr>
           <a:xfrm>
-            <a:off x="9906000" y="6375400"/>
+            <a:off x="8445500" y="6375400"/>
             <a:ext cx="381000" cy="190500"/>
           </a:xfrm>
           <a:prstGeom prst="rect">
@@ -22939,9 +24257,55 @@
           </a:p>
         </p:txBody>
       </p:sp>
+      <p:sp>
+        <p:nvSpPr>
+          <p:cNvPr id="6" name="Rounded Rectangle 5"/>
+          <p:cNvSpPr/>
+          <p:nvPr/>
+        </p:nvSpPr>
+        <p:spPr>
+          <a:xfrm>
+            <a:off x="9264650" y="6210300"/>
+            <a:ext cx="2317750" cy="457200"/>
+          </a:xfrm>
+          <a:prstGeom prst="roundRect">
+            <a:avLst>
+              <a:gd name="adj" fmla="val 25000"/>
+            </a:avLst>
+          </a:prstGeom>
+          <a:solidFill>
+            <a:srgbClr val="FFFFFF"/>
+          </a:solidFill>
+          <a:ln>
+            <a:noFill/>
+          </a:ln>
+          <a:effectLst/>
+        </p:spPr>
+        <p:style>
+          <a:lnRef idx="1">
+            <a:schemeClr val="accent1"/>
+          </a:lnRef>
+          <a:fillRef idx="3">
+            <a:schemeClr val="accent1"/>
+          </a:fillRef>
+          <a:effectRef idx="2">
+            <a:schemeClr val="accent1"/>
+          </a:effectRef>
+          <a:fontRef idx="minor">
+            <a:schemeClr val="lt1"/>
+          </a:fontRef>
+        </p:style>
+        <p:txBody>
+          <a:bodyPr rtlCol="0" anchor="ctr"/>
+          <a:lstStyle/>
+          <a:p>
+            <a:pPr algn="ctr"/>
+          </a:p>
+        </p:txBody>
+      </p:sp>
       <p:pic>
         <p:nvPicPr>
-          <p:cNvPr id="6" name="Picture 5" descr="logo_white_c.png"/>
+          <p:cNvPr id="7" name="Picture 6" descr="logo_navy_c.png"/>
           <p:cNvPicPr>
             <a:picLocks noChangeAspect="1"/>
           </p:cNvPicPr>
@@ -22955,7 +24319,7 @@
         </p:blipFill>
         <p:spPr>
           <a:xfrm>
-            <a:off x="10490200" y="6324600"/>
+            <a:off x="9417050" y="6311900"/>
             <a:ext cx="939800" cy="254000"/>
           </a:xfrm>
           <a:prstGeom prst="rect">
@@ -22965,13 +24329,81 @@
       </p:pic>
       <p:sp>
         <p:nvSpPr>
-          <p:cNvPr id="7" name="TextBox 6"/>
+          <p:cNvPr id="8" name="Rectangle 7"/>
+          <p:cNvSpPr/>
+          <p:nvPr/>
+        </p:nvSpPr>
+        <p:spPr>
+          <a:xfrm>
+            <a:off x="10509250" y="6299200"/>
+            <a:ext cx="12700" cy="279400"/>
+          </a:xfrm>
+          <a:prstGeom prst="rect">
+            <a:avLst/>
+          </a:prstGeom>
+          <a:solidFill>
+            <a:srgbClr val="CDD9DE"/>
+          </a:solidFill>
+          <a:ln>
+            <a:noFill/>
+          </a:ln>
+          <a:effectLst/>
+        </p:spPr>
+        <p:style>
+          <a:lnRef idx="1">
+            <a:schemeClr val="accent1"/>
+          </a:lnRef>
+          <a:fillRef idx="3">
+            <a:schemeClr val="accent1"/>
+          </a:fillRef>
+          <a:effectRef idx="2">
+            <a:schemeClr val="accent1"/>
+          </a:effectRef>
+          <a:fontRef idx="minor">
+            <a:schemeClr val="lt1"/>
+          </a:fontRef>
+        </p:style>
+        <p:txBody>
+          <a:bodyPr rtlCol="0" anchor="ctr"/>
+          <a:lstStyle/>
+          <a:p>
+            <a:pPr algn="ctr"/>
+          </a:p>
+        </p:txBody>
+      </p:sp>
+      <p:pic>
+        <p:nvPicPr>
+          <p:cNvPr id="9" name="Picture 8" descr="logo_jisc_placeholder.png"/>
+          <p:cNvPicPr>
+            <a:picLocks noChangeAspect="1"/>
+          </p:cNvPicPr>
+          <p:nvPr/>
+        </p:nvPicPr>
+        <p:blipFill>
+          <a:blip r:embed="rId3"/>
+          <a:stretch>
+            <a:fillRect/>
+          </a:stretch>
+        </p:blipFill>
+        <p:spPr>
+          <a:xfrm>
+            <a:off x="10661650" y="6299200"/>
+            <a:ext cx="768350" cy="279400"/>
+          </a:xfrm>
+          <a:prstGeom prst="rect">
+            <a:avLst/>
+          </a:prstGeom>
+        </p:spPr>
+      </p:pic>
+      <p:sp>
+        <p:nvSpPr>
+          <p:cNvPr id="10" name="TextBox 9"/>
           <p:cNvSpPr txBox="1"/>
           <p:nvPr/>
         </p:nvSpPr>
         <p:spPr>
           <a:xfrm>
-            <a:off x="9906000" y="6375400"/>
+            <a:off x="8445500" y="6375400"/>
             <a:ext cx="381000" cy="190500"/>
           </a:xfrm>
           <a:prstGeom prst="rect">
@@ -23690,7 +25122,7 @@
         </p:blipFill>
         <p:spPr>
           <a:xfrm>
-            <a:off x="10490200" y="6324600"/>
+            <a:off x="9417050" y="6311900"/>
             <a:ext cx="939800" cy="254000"/>
           </a:xfrm>
           <a:prstGeom prst="rect">
@@ -23700,13 +25132,81 @@
       </p:pic>
       <p:sp>
         <p:nvSpPr>
-          <p:cNvPr id="19" name="TextBox 18"/>
+          <p:cNvPr id="19" name="Rectangle 18"/>
+          <p:cNvSpPr/>
+          <p:nvPr/>
+        </p:nvSpPr>
+        <p:spPr>
+          <a:xfrm>
+            <a:off x="10509250" y="6299200"/>
+            <a:ext cx="12700" cy="279400"/>
+          </a:xfrm>
+          <a:prstGeom prst="rect">
+            <a:avLst/>
+          </a:prstGeom>
+          <a:solidFill>
+            <a:srgbClr val="CDD9DE"/>
+          </a:solidFill>
+          <a:ln>
+            <a:noFill/>
+          </a:ln>
+          <a:effectLst/>
+        </p:spPr>
+        <p:style>
+          <a:lnRef idx="1">
+            <a:schemeClr val="accent1"/>
+          </a:lnRef>
+          <a:fillRef idx="3">
+            <a:schemeClr val="accent1"/>
+          </a:fillRef>
+          <a:effectRef idx="2">
+            <a:schemeClr val="accent1"/>
+          </a:effectRef>
+          <a:fontRef idx="minor">
+            <a:schemeClr val="lt1"/>
+          </a:fontRef>
+        </p:style>
+        <p:txBody>
+          <a:bodyPr rtlCol="0" anchor="ctr"/>
+          <a:lstStyle/>
+          <a:p>
+            <a:pPr algn="ctr"/>
+          </a:p>
+        </p:txBody>
+      </p:sp>
+      <p:pic>
+        <p:nvPicPr>
+          <p:cNvPr id="20" name="Picture 19" descr="logo_jisc_placeholder.png"/>
+          <p:cNvPicPr>
+            <a:picLocks noChangeAspect="1"/>
+          </p:cNvPicPr>
+          <p:nvPr/>
+        </p:nvPicPr>
+        <p:blipFill>
+          <a:blip r:embed="rId5"/>
+          <a:stretch>
+            <a:fillRect/>
+          </a:stretch>
+        </p:blipFill>
+        <p:spPr>
+          <a:xfrm>
+            <a:off x="10661650" y="6299200"/>
+            <a:ext cx="768350" cy="279400"/>
+          </a:xfrm>
+          <a:prstGeom prst="rect">
+            <a:avLst/>
+          </a:prstGeom>
+        </p:spPr>
+      </p:pic>
+      <p:sp>
+        <p:nvSpPr>
+          <p:cNvPr id="21" name="TextBox 20"/>
           <p:cNvSpPr txBox="1"/>
           <p:nvPr/>
         </p:nvSpPr>
         <p:spPr>
           <a:xfrm>
-            <a:off x="9906000" y="6375400"/>
+            <a:off x="8445500" y="6375400"/>
             <a:ext cx="381000" cy="190500"/>
           </a:xfrm>
           <a:prstGeom prst="rect">
@@ -24191,7 +25691,7 @@
         </p:blipFill>
         <p:spPr>
           <a:xfrm>
-            <a:off x="10490200" y="6324600"/>
+            <a:off x="9417050" y="6311900"/>
             <a:ext cx="939800" cy="254000"/>
           </a:xfrm>
           <a:prstGeom prst="rect">
@@ -24201,13 +25701,81 @@
       </p:pic>
       <p:sp>
         <p:nvSpPr>
-          <p:cNvPr id="13" name="TextBox 12"/>
+          <p:cNvPr id="13" name="Rectangle 12"/>
+          <p:cNvSpPr/>
+          <p:nvPr/>
+        </p:nvSpPr>
+        <p:spPr>
+          <a:xfrm>
+            <a:off x="10509250" y="6299200"/>
+            <a:ext cx="12700" cy="279400"/>
+          </a:xfrm>
+          <a:prstGeom prst="rect">
+            <a:avLst/>
+          </a:prstGeom>
+          <a:solidFill>
+            <a:srgbClr val="CDD9DE"/>
+          </a:solidFill>
+          <a:ln>
+            <a:noFill/>
+          </a:ln>
+          <a:effectLst/>
+        </p:spPr>
+        <p:style>
+          <a:lnRef idx="1">
+            <a:schemeClr val="accent1"/>
+          </a:lnRef>
+          <a:fillRef idx="3">
+            <a:schemeClr val="accent1"/>
+          </a:fillRef>
+          <a:effectRef idx="2">
+            <a:schemeClr val="accent1"/>
+          </a:effectRef>
+          <a:fontRef idx="minor">
+            <a:schemeClr val="lt1"/>
+          </a:fontRef>
+        </p:style>
+        <p:txBody>
+          <a:bodyPr rtlCol="0" anchor="ctr"/>
+          <a:lstStyle/>
+          <a:p>
+            <a:pPr algn="ctr"/>
+          </a:p>
+        </p:txBody>
+      </p:sp>
+      <p:pic>
+        <p:nvPicPr>
+          <p:cNvPr id="14" name="Picture 13" descr="logo_jisc_placeholder.png"/>
+          <p:cNvPicPr>
+            <a:picLocks noChangeAspect="1"/>
+          </p:cNvPicPr>
+          <p:nvPr/>
+        </p:nvPicPr>
+        <p:blipFill>
+          <a:blip r:embed="rId3"/>
+          <a:stretch>
+            <a:fillRect/>
+          </a:stretch>
+        </p:blipFill>
+        <p:spPr>
+          <a:xfrm>
+            <a:off x="10661650" y="6299200"/>
+            <a:ext cx="768350" cy="279400"/>
+          </a:xfrm>
+          <a:prstGeom prst="rect">
+            <a:avLst/>
+          </a:prstGeom>
+        </p:spPr>
+      </p:pic>
+      <p:sp>
+        <p:nvSpPr>
+          <p:cNvPr id="15" name="TextBox 14"/>
           <p:cNvSpPr txBox="1"/>
           <p:nvPr/>
         </p:nvSpPr>
         <p:spPr>
           <a:xfrm>
-            <a:off x="9906000" y="6375400"/>
+            <a:off x="8445500" y="6375400"/>
             <a:ext cx="381000" cy="190500"/>
           </a:xfrm>
           <a:prstGeom prst="rect">
@@ -24973,7 +26541,7 @@
         </p:blipFill>
         <p:spPr>
           <a:xfrm>
-            <a:off x="10490200" y="6324600"/>
+            <a:off x="9417050" y="6311900"/>
             <a:ext cx="939800" cy="254000"/>
           </a:xfrm>
           <a:prstGeom prst="rect">
@@ -24983,13 +26551,81 @@
       </p:pic>
       <p:sp>
         <p:nvSpPr>
-          <p:cNvPr id="22" name="TextBox 21"/>
+          <p:cNvPr id="22" name="Rectangle 21"/>
+          <p:cNvSpPr/>
+          <p:nvPr/>
+        </p:nvSpPr>
+        <p:spPr>
+          <a:xfrm>
+            <a:off x="10509250" y="6299200"/>
+            <a:ext cx="12700" cy="279400"/>
+          </a:xfrm>
+          <a:prstGeom prst="rect">
+            <a:avLst/>
+          </a:prstGeom>
+          <a:solidFill>
+            <a:srgbClr val="CDD9DE"/>
+          </a:solidFill>
+          <a:ln>
+            <a:noFill/>
+          </a:ln>
+          <a:effectLst/>
+        </p:spPr>
+        <p:style>
+          <a:lnRef idx="1">
+            <a:schemeClr val="accent1"/>
+          </a:lnRef>
+          <a:fillRef idx="3">
+            <a:schemeClr val="accent1"/>
+          </a:fillRef>
+          <a:effectRef idx="2">
+            <a:schemeClr val="accent1"/>
+          </a:effectRef>
+          <a:fontRef idx="minor">
+            <a:schemeClr val="lt1"/>
+          </a:fontRef>
+        </p:style>
+        <p:txBody>
+          <a:bodyPr rtlCol="0" anchor="ctr"/>
+          <a:lstStyle/>
+          <a:p>
+            <a:pPr algn="ctr"/>
+          </a:p>
+        </p:txBody>
+      </p:sp>
+      <p:pic>
+        <p:nvPicPr>
+          <p:cNvPr id="23" name="Picture 22" descr="logo_jisc_placeholder.png"/>
+          <p:cNvPicPr>
+            <a:picLocks noChangeAspect="1"/>
+          </p:cNvPicPr>
+          <p:nvPr/>
+        </p:nvPicPr>
+        <p:blipFill>
+          <a:blip r:embed="rId8"/>
+          <a:stretch>
+            <a:fillRect/>
+          </a:stretch>
+        </p:blipFill>
+        <p:spPr>
+          <a:xfrm>
+            <a:off x="10661650" y="6299200"/>
+            <a:ext cx="768350" cy="279400"/>
+          </a:xfrm>
+          <a:prstGeom prst="rect">
+            <a:avLst/>
+          </a:prstGeom>
+        </p:spPr>
+      </p:pic>
+      <p:sp>
+        <p:nvSpPr>
+          <p:cNvPr id="24" name="TextBox 23"/>
           <p:cNvSpPr txBox="1"/>
           <p:nvPr/>
         </p:nvSpPr>
         <p:spPr>
           <a:xfrm>
-            <a:off x="9906000" y="6375400"/>
+            <a:off x="8445500" y="6375400"/>
             <a:ext cx="381000" cy="190500"/>
           </a:xfrm>
           <a:prstGeom prst="rect">
@@ -25804,7 +27440,7 @@
         </p:blipFill>
         <p:spPr>
           <a:xfrm>
-            <a:off x="10490200" y="6324600"/>
+            <a:off x="9417050" y="6311900"/>
             <a:ext cx="939800" cy="254000"/>
           </a:xfrm>
           <a:prstGeom prst="rect">
@@ -25814,13 +27450,81 @@
       </p:pic>
       <p:sp>
         <p:nvSpPr>
-          <p:cNvPr id="21" name="TextBox 20"/>
+          <p:cNvPr id="21" name="Rectangle 20"/>
+          <p:cNvSpPr/>
+          <p:nvPr/>
+        </p:nvSpPr>
+        <p:spPr>
+          <a:xfrm>
+            <a:off x="10509250" y="6299200"/>
+            <a:ext cx="12700" cy="279400"/>
+          </a:xfrm>
+          <a:prstGeom prst="rect">
+            <a:avLst/>
+          </a:prstGeom>
+          <a:solidFill>
+            <a:srgbClr val="CDD9DE"/>
+          </a:solidFill>
+          <a:ln>
+            <a:noFill/>
+          </a:ln>
+          <a:effectLst/>
+        </p:spPr>
+        <p:style>
+          <a:lnRef idx="1">
+            <a:schemeClr val="accent1"/>
+          </a:lnRef>
+          <a:fillRef idx="3">
+            <a:schemeClr val="accent1"/>
+          </a:fillRef>
+          <a:effectRef idx="2">
+            <a:schemeClr val="accent1"/>
+          </a:effectRef>
+          <a:fontRef idx="minor">
+            <a:schemeClr val="lt1"/>
+          </a:fontRef>
+        </p:style>
+        <p:txBody>
+          <a:bodyPr rtlCol="0" anchor="ctr"/>
+          <a:lstStyle/>
+          <a:p>
+            <a:pPr algn="ctr"/>
+          </a:p>
+        </p:txBody>
+      </p:sp>
+      <p:pic>
+        <p:nvPicPr>
+          <p:cNvPr id="22" name="Picture 21" descr="logo_jisc_placeholder.png"/>
+          <p:cNvPicPr>
+            <a:picLocks noChangeAspect="1"/>
+          </p:cNvPicPr>
+          <p:nvPr/>
+        </p:nvPicPr>
+        <p:blipFill>
+          <a:blip r:embed="rId7"/>
+          <a:stretch>
+            <a:fillRect/>
+          </a:stretch>
+        </p:blipFill>
+        <p:spPr>
+          <a:xfrm>
+            <a:off x="10661650" y="6299200"/>
+            <a:ext cx="768350" cy="279400"/>
+          </a:xfrm>
+          <a:prstGeom prst="rect">
+            <a:avLst/>
+          </a:prstGeom>
+        </p:spPr>
+      </p:pic>
+      <p:sp>
+        <p:nvSpPr>
+          <p:cNvPr id="23" name="TextBox 22"/>
           <p:cNvSpPr txBox="1"/>
           <p:nvPr/>
         </p:nvSpPr>
         <p:spPr>
           <a:xfrm>
-            <a:off x="9906000" y="6375400"/>
+            <a:off x="8445500" y="6375400"/>
             <a:ext cx="381000" cy="190500"/>
           </a:xfrm>
           <a:prstGeom prst="rect">
@@ -26422,7 +28126,7 @@
         </p:blipFill>
         <p:spPr>
           <a:xfrm>
-            <a:off x="10490200" y="6324600"/>
+            <a:off x="9417050" y="6311900"/>
             <a:ext cx="939800" cy="254000"/>
           </a:xfrm>
           <a:prstGeom prst="rect">
@@ -26432,13 +28136,81 @@
       </p:pic>
       <p:sp>
         <p:nvSpPr>
-          <p:cNvPr id="15" name="TextBox 14"/>
+          <p:cNvPr id="15" name="Rectangle 14"/>
+          <p:cNvSpPr/>
+          <p:nvPr/>
+        </p:nvSpPr>
+        <p:spPr>
+          <a:xfrm>
+            <a:off x="10509250" y="6299200"/>
+            <a:ext cx="12700" cy="279400"/>
+          </a:xfrm>
+          <a:prstGeom prst="rect">
+            <a:avLst/>
+          </a:prstGeom>
+          <a:solidFill>
+            <a:srgbClr val="CDD9DE"/>
+          </a:solidFill>
+          <a:ln>
+            <a:noFill/>
+          </a:ln>
+          <a:effectLst/>
+        </p:spPr>
+        <p:style>
+          <a:lnRef idx="1">
+            <a:schemeClr val="accent1"/>
+          </a:lnRef>
+          <a:fillRef idx="3">
+            <a:schemeClr val="accent1"/>
+          </a:fillRef>
+          <a:effectRef idx="2">
+            <a:schemeClr val="accent1"/>
+          </a:effectRef>
+          <a:fontRef idx="minor">
+            <a:schemeClr val="lt1"/>
+          </a:fontRef>
+        </p:style>
+        <p:txBody>
+          <a:bodyPr rtlCol="0" anchor="ctr"/>
+          <a:lstStyle/>
+          <a:p>
+            <a:pPr algn="ctr"/>
+          </a:p>
+        </p:txBody>
+      </p:sp>
+      <p:pic>
+        <p:nvPicPr>
+          <p:cNvPr id="16" name="Picture 15" descr="logo_jisc_placeholder.png"/>
+          <p:cNvPicPr>
+            <a:picLocks noChangeAspect="1"/>
+          </p:cNvPicPr>
+          <p:nvPr/>
+        </p:nvPicPr>
+        <p:blipFill>
+          <a:blip r:embed="rId3"/>
+          <a:stretch>
+            <a:fillRect/>
+          </a:stretch>
+        </p:blipFill>
+        <p:spPr>
+          <a:xfrm>
+            <a:off x="10661650" y="6299200"/>
+            <a:ext cx="768350" cy="279400"/>
+          </a:xfrm>
+          <a:prstGeom prst="rect">
+            <a:avLst/>
+          </a:prstGeom>
+        </p:spPr>
+      </p:pic>
+      <p:sp>
+        <p:nvSpPr>
+          <p:cNvPr id="17" name="TextBox 16"/>
           <p:cNvSpPr txBox="1"/>
           <p:nvPr/>
         </p:nvSpPr>
         <p:spPr>
           <a:xfrm>
-            <a:off x="9906000" y="6375400"/>
+            <a:off x="8445500" y="6375400"/>
             <a:ext cx="381000" cy="190500"/>
           </a:xfrm>
           <a:prstGeom prst="rect">
@@ -26604,7 +28376,7 @@
                 </a:solidFill>
                 <a:latin typeface="League Spartan"/>
               </a:rPr>
-              <a:t>[Name]</a:t>
+              <a:t>Hannah Lawrence</a:t>
             </a:r>
           </a:p>
         </p:txBody>
@@ -26643,7 +28415,7 @@
                 </a:solidFill>
                 <a:latin typeface="Inter"/>
               </a:rPr>
-              <a:t>[Role], Jisc</a:t>
+              <a:t>Licence Manager, Jisc</a:t>
             </a:r>
           </a:p>
         </p:txBody>
@@ -26788,9 +28560,55 @@
           </a:p>
         </p:txBody>
       </p:sp>
+      <p:sp>
+        <p:nvSpPr>
+          <p:cNvPr id="9" name="Rounded Rectangle 8"/>
+          <p:cNvSpPr/>
+          <p:nvPr/>
+        </p:nvSpPr>
+        <p:spPr>
+          <a:xfrm>
+            <a:off x="9264650" y="6210300"/>
+            <a:ext cx="2317750" cy="457200"/>
+          </a:xfrm>
+          <a:prstGeom prst="roundRect">
+            <a:avLst>
+              <a:gd name="adj" fmla="val 25000"/>
+            </a:avLst>
+          </a:prstGeom>
+          <a:solidFill>
+            <a:srgbClr val="FFFFFF"/>
+          </a:solidFill>
+          <a:ln>
+            <a:noFill/>
+          </a:ln>
+          <a:effectLst/>
+        </p:spPr>
+        <p:style>
+          <a:lnRef idx="1">
+            <a:schemeClr val="accent1"/>
+          </a:lnRef>
+          <a:fillRef idx="3">
+            <a:schemeClr val="accent1"/>
+          </a:fillRef>
+          <a:effectRef idx="2">
+            <a:schemeClr val="accent1"/>
+          </a:effectRef>
+          <a:fontRef idx="minor">
+            <a:schemeClr val="lt1"/>
+          </a:fontRef>
+        </p:style>
+        <p:txBody>
+          <a:bodyPr rtlCol="0" anchor="ctr"/>
+          <a:lstStyle/>
+          <a:p>
+            <a:pPr algn="ctr"/>
+          </a:p>
+        </p:txBody>
+      </p:sp>
       <p:pic>
         <p:nvPicPr>
-          <p:cNvPr id="9" name="Picture 8" descr="logo_white_c.png"/>
+          <p:cNvPr id="10" name="Picture 9" descr="logo_navy_c.png"/>
           <p:cNvPicPr>
             <a:picLocks noChangeAspect="1"/>
           </p:cNvPicPr>
@@ -26804,7 +28622,7 @@
         </p:blipFill>
         <p:spPr>
           <a:xfrm>
-            <a:off x="10490200" y="6324600"/>
+            <a:off x="9417050" y="6311900"/>
             <a:ext cx="939800" cy="254000"/>
           </a:xfrm>
           <a:prstGeom prst="rect">
@@ -26814,13 +28632,81 @@
       </p:pic>
       <p:sp>
         <p:nvSpPr>
-          <p:cNvPr id="10" name="TextBox 9"/>
+          <p:cNvPr id="11" name="Rectangle 10"/>
+          <p:cNvSpPr/>
+          <p:nvPr/>
+        </p:nvSpPr>
+        <p:spPr>
+          <a:xfrm>
+            <a:off x="10509250" y="6299200"/>
+            <a:ext cx="12700" cy="279400"/>
+          </a:xfrm>
+          <a:prstGeom prst="rect">
+            <a:avLst/>
+          </a:prstGeom>
+          <a:solidFill>
+            <a:srgbClr val="CDD9DE"/>
+          </a:solidFill>
+          <a:ln>
+            <a:noFill/>
+          </a:ln>
+          <a:effectLst/>
+        </p:spPr>
+        <p:style>
+          <a:lnRef idx="1">
+            <a:schemeClr val="accent1"/>
+          </a:lnRef>
+          <a:fillRef idx="3">
+            <a:schemeClr val="accent1"/>
+          </a:fillRef>
+          <a:effectRef idx="2">
+            <a:schemeClr val="accent1"/>
+          </a:effectRef>
+          <a:fontRef idx="minor">
+            <a:schemeClr val="lt1"/>
+          </a:fontRef>
+        </p:style>
+        <p:txBody>
+          <a:bodyPr rtlCol="0" anchor="ctr"/>
+          <a:lstStyle/>
+          <a:p>
+            <a:pPr algn="ctr"/>
+          </a:p>
+        </p:txBody>
+      </p:sp>
+      <p:pic>
+        <p:nvPicPr>
+          <p:cNvPr id="12" name="Picture 11" descr="logo_jisc_placeholder.png"/>
+          <p:cNvPicPr>
+            <a:picLocks noChangeAspect="1"/>
+          </p:cNvPicPr>
+          <p:nvPr/>
+        </p:nvPicPr>
+        <p:blipFill>
+          <a:blip r:embed="rId3"/>
+          <a:stretch>
+            <a:fillRect/>
+          </a:stretch>
+        </p:blipFill>
+        <p:spPr>
+          <a:xfrm>
+            <a:off x="10661650" y="6299200"/>
+            <a:ext cx="768350" cy="279400"/>
+          </a:xfrm>
+          <a:prstGeom prst="rect">
+            <a:avLst/>
+          </a:prstGeom>
+        </p:spPr>
+      </p:pic>
+      <p:sp>
+        <p:nvSpPr>
+          <p:cNvPr id="13" name="TextBox 12"/>
           <p:cNvSpPr txBox="1"/>
           <p:nvPr/>
         </p:nvSpPr>
         <p:spPr>
           <a:xfrm>
-            <a:off x="9906000" y="6375400"/>
+            <a:off x="8445500" y="6375400"/>
             <a:ext cx="381000" cy="190500"/>
           </a:xfrm>
           <a:prstGeom prst="rect">
@@ -27436,7 +29322,7 @@
         </p:blipFill>
         <p:spPr>
           <a:xfrm>
-            <a:off x="10490200" y="6324600"/>
+            <a:off x="9417050" y="6311900"/>
             <a:ext cx="939800" cy="254000"/>
           </a:xfrm>
           <a:prstGeom prst="rect">
@@ -27446,13 +29332,81 @@
       </p:pic>
       <p:sp>
         <p:nvSpPr>
-          <p:cNvPr id="16" name="TextBox 15"/>
+          <p:cNvPr id="16" name="Rectangle 15"/>
+          <p:cNvSpPr/>
+          <p:nvPr/>
+        </p:nvSpPr>
+        <p:spPr>
+          <a:xfrm>
+            <a:off x="10509250" y="6299200"/>
+            <a:ext cx="12700" cy="279400"/>
+          </a:xfrm>
+          <a:prstGeom prst="rect">
+            <a:avLst/>
+          </a:prstGeom>
+          <a:solidFill>
+            <a:srgbClr val="CDD9DE"/>
+          </a:solidFill>
+          <a:ln>
+            <a:noFill/>
+          </a:ln>
+          <a:effectLst/>
+        </p:spPr>
+        <p:style>
+          <a:lnRef idx="1">
+            <a:schemeClr val="accent1"/>
+          </a:lnRef>
+          <a:fillRef idx="3">
+            <a:schemeClr val="accent1"/>
+          </a:fillRef>
+          <a:effectRef idx="2">
+            <a:schemeClr val="accent1"/>
+          </a:effectRef>
+          <a:fontRef idx="minor">
+            <a:schemeClr val="lt1"/>
+          </a:fontRef>
+        </p:style>
+        <p:txBody>
+          <a:bodyPr rtlCol="0" anchor="ctr"/>
+          <a:lstStyle/>
+          <a:p>
+            <a:pPr algn="ctr"/>
+          </a:p>
+        </p:txBody>
+      </p:sp>
+      <p:pic>
+        <p:nvPicPr>
+          <p:cNvPr id="17" name="Picture 16" descr="logo_jisc_placeholder.png"/>
+          <p:cNvPicPr>
+            <a:picLocks noChangeAspect="1"/>
+          </p:cNvPicPr>
+          <p:nvPr/>
+        </p:nvPicPr>
+        <p:blipFill>
+          <a:blip r:embed="rId3"/>
+          <a:stretch>
+            <a:fillRect/>
+          </a:stretch>
+        </p:blipFill>
+        <p:spPr>
+          <a:xfrm>
+            <a:off x="10661650" y="6299200"/>
+            <a:ext cx="768350" cy="279400"/>
+          </a:xfrm>
+          <a:prstGeom prst="rect">
+            <a:avLst/>
+          </a:prstGeom>
+        </p:spPr>
+      </p:pic>
+      <p:sp>
+        <p:nvSpPr>
+          <p:cNvPr id="18" name="TextBox 17"/>
           <p:cNvSpPr txBox="1"/>
           <p:nvPr/>
         </p:nvSpPr>
         <p:spPr>
           <a:xfrm>
-            <a:off x="9906000" y="6375400"/>
+            <a:off x="8445500" y="6375400"/>
             <a:ext cx="381000" cy="190500"/>
           </a:xfrm>
           <a:prstGeom prst="rect">
@@ -27639,9 +29593,55 @@
           </a:p>
         </p:txBody>
       </p:sp>
+      <p:sp>
+        <p:nvSpPr>
+          <p:cNvPr id="5" name="Rounded Rectangle 4"/>
+          <p:cNvSpPr/>
+          <p:nvPr/>
+        </p:nvSpPr>
+        <p:spPr>
+          <a:xfrm>
+            <a:off x="9264650" y="6210300"/>
+            <a:ext cx="2317750" cy="457200"/>
+          </a:xfrm>
+          <a:prstGeom prst="roundRect">
+            <a:avLst>
+              <a:gd name="adj" fmla="val 25000"/>
+            </a:avLst>
+          </a:prstGeom>
+          <a:solidFill>
+            <a:srgbClr val="FFFFFF"/>
+          </a:solidFill>
+          <a:ln>
+            <a:noFill/>
+          </a:ln>
+          <a:effectLst/>
+        </p:spPr>
+        <p:style>
+          <a:lnRef idx="1">
+            <a:schemeClr val="accent1"/>
+          </a:lnRef>
+          <a:fillRef idx="3">
+            <a:schemeClr val="accent1"/>
+          </a:fillRef>
+          <a:effectRef idx="2">
+            <a:schemeClr val="accent1"/>
+          </a:effectRef>
+          <a:fontRef idx="minor">
+            <a:schemeClr val="lt1"/>
+          </a:fontRef>
+        </p:style>
+        <p:txBody>
+          <a:bodyPr rtlCol="0" anchor="ctr"/>
+          <a:lstStyle/>
+          <a:p>
+            <a:pPr algn="ctr"/>
+          </a:p>
+        </p:txBody>
+      </p:sp>
       <p:pic>
         <p:nvPicPr>
-          <p:cNvPr id="5" name="Picture 4" descr="logo_white_c.png"/>
+          <p:cNvPr id="6" name="Picture 5" descr="logo_navy_c.png"/>
           <p:cNvPicPr>
             <a:picLocks noChangeAspect="1"/>
           </p:cNvPicPr>
@@ -27655,7 +29655,7 @@
         </p:blipFill>
         <p:spPr>
           <a:xfrm>
-            <a:off x="10490200" y="6324600"/>
+            <a:off x="9417050" y="6311900"/>
             <a:ext cx="939800" cy="254000"/>
           </a:xfrm>
           <a:prstGeom prst="rect">
@@ -27665,13 +29665,81 @@
       </p:pic>
       <p:sp>
         <p:nvSpPr>
-          <p:cNvPr id="6" name="TextBox 5"/>
+          <p:cNvPr id="7" name="Rectangle 6"/>
+          <p:cNvSpPr/>
+          <p:nvPr/>
+        </p:nvSpPr>
+        <p:spPr>
+          <a:xfrm>
+            <a:off x="10509250" y="6299200"/>
+            <a:ext cx="12700" cy="279400"/>
+          </a:xfrm>
+          <a:prstGeom prst="rect">
+            <a:avLst/>
+          </a:prstGeom>
+          <a:solidFill>
+            <a:srgbClr val="CDD9DE"/>
+          </a:solidFill>
+          <a:ln>
+            <a:noFill/>
+          </a:ln>
+          <a:effectLst/>
+        </p:spPr>
+        <p:style>
+          <a:lnRef idx="1">
+            <a:schemeClr val="accent1"/>
+          </a:lnRef>
+          <a:fillRef idx="3">
+            <a:schemeClr val="accent1"/>
+          </a:fillRef>
+          <a:effectRef idx="2">
+            <a:schemeClr val="accent1"/>
+          </a:effectRef>
+          <a:fontRef idx="minor">
+            <a:schemeClr val="lt1"/>
+          </a:fontRef>
+        </p:style>
+        <p:txBody>
+          <a:bodyPr rtlCol="0" anchor="ctr"/>
+          <a:lstStyle/>
+          <a:p>
+            <a:pPr algn="ctr"/>
+          </a:p>
+        </p:txBody>
+      </p:sp>
+      <p:pic>
+        <p:nvPicPr>
+          <p:cNvPr id="8" name="Picture 7" descr="logo_jisc_placeholder.png"/>
+          <p:cNvPicPr>
+            <a:picLocks noChangeAspect="1"/>
+          </p:cNvPicPr>
+          <p:nvPr/>
+        </p:nvPicPr>
+        <p:blipFill>
+          <a:blip r:embed="rId3"/>
+          <a:stretch>
+            <a:fillRect/>
+          </a:stretch>
+        </p:blipFill>
+        <p:spPr>
+          <a:xfrm>
+            <a:off x="10661650" y="6299200"/>
+            <a:ext cx="768350" cy="279400"/>
+          </a:xfrm>
+          <a:prstGeom prst="rect">
+            <a:avLst/>
+          </a:prstGeom>
+        </p:spPr>
+      </p:pic>
+      <p:sp>
+        <p:nvSpPr>
+          <p:cNvPr id="9" name="TextBox 8"/>
           <p:cNvSpPr txBox="1"/>
           <p:nvPr/>
         </p:nvSpPr>
         <p:spPr>
           <a:xfrm>
-            <a:off x="9906000" y="6375400"/>
+            <a:off x="8445500" y="6375400"/>
             <a:ext cx="381000" cy="190500"/>
           </a:xfrm>
           <a:prstGeom prst="rect">
@@ -28228,7 +30296,7 @@
         </p:blipFill>
         <p:spPr>
           <a:xfrm>
-            <a:off x="10490200" y="6324600"/>
+            <a:off x="9417050" y="6311900"/>
             <a:ext cx="939800" cy="254000"/>
           </a:xfrm>
           <a:prstGeom prst="rect">
@@ -28238,13 +30306,81 @@
       </p:pic>
       <p:sp>
         <p:nvSpPr>
-          <p:cNvPr id="15" name="TextBox 14"/>
+          <p:cNvPr id="15" name="Rectangle 14"/>
+          <p:cNvSpPr/>
+          <p:nvPr/>
+        </p:nvSpPr>
+        <p:spPr>
+          <a:xfrm>
+            <a:off x="10509250" y="6299200"/>
+            <a:ext cx="12700" cy="279400"/>
+          </a:xfrm>
+          <a:prstGeom prst="rect">
+            <a:avLst/>
+          </a:prstGeom>
+          <a:solidFill>
+            <a:srgbClr val="CDD9DE"/>
+          </a:solidFill>
+          <a:ln>
+            <a:noFill/>
+          </a:ln>
+          <a:effectLst/>
+        </p:spPr>
+        <p:style>
+          <a:lnRef idx="1">
+            <a:schemeClr val="accent1"/>
+          </a:lnRef>
+          <a:fillRef idx="3">
+            <a:schemeClr val="accent1"/>
+          </a:fillRef>
+          <a:effectRef idx="2">
+            <a:schemeClr val="accent1"/>
+          </a:effectRef>
+          <a:fontRef idx="minor">
+            <a:schemeClr val="lt1"/>
+          </a:fontRef>
+        </p:style>
+        <p:txBody>
+          <a:bodyPr rtlCol="0" anchor="ctr"/>
+          <a:lstStyle/>
+          <a:p>
+            <a:pPr algn="ctr"/>
+          </a:p>
+        </p:txBody>
+      </p:sp>
+      <p:pic>
+        <p:nvPicPr>
+          <p:cNvPr id="16" name="Picture 15" descr="logo_jisc_placeholder.png"/>
+          <p:cNvPicPr>
+            <a:picLocks noChangeAspect="1"/>
+          </p:cNvPicPr>
+          <p:nvPr/>
+        </p:nvPicPr>
+        <p:blipFill>
+          <a:blip r:embed="rId6"/>
+          <a:stretch>
+            <a:fillRect/>
+          </a:stretch>
+        </p:blipFill>
+        <p:spPr>
+          <a:xfrm>
+            <a:off x="10661650" y="6299200"/>
+            <a:ext cx="768350" cy="279400"/>
+          </a:xfrm>
+          <a:prstGeom prst="rect">
+            <a:avLst/>
+          </a:prstGeom>
+        </p:spPr>
+      </p:pic>
+      <p:sp>
+        <p:nvSpPr>
+          <p:cNvPr id="17" name="TextBox 16"/>
           <p:cNvSpPr txBox="1"/>
           <p:nvPr/>
         </p:nvSpPr>
         <p:spPr>
           <a:xfrm>
-            <a:off x="9906000" y="6375400"/>
+            <a:off x="8445500" y="6375400"/>
             <a:ext cx="381000" cy="190500"/>
           </a:xfrm>
           <a:prstGeom prst="rect">
@@ -28722,7 +30858,7 @@
         </p:blipFill>
         <p:spPr>
           <a:xfrm>
-            <a:off x="10490200" y="6324600"/>
+            <a:off x="9417050" y="6311900"/>
             <a:ext cx="939800" cy="254000"/>
           </a:xfrm>
           <a:prstGeom prst="rect">
@@ -28732,13 +30868,81 @@
       </p:pic>
       <p:sp>
         <p:nvSpPr>
-          <p:cNvPr id="14" name="TextBox 13"/>
+          <p:cNvPr id="14" name="Rectangle 13"/>
+          <p:cNvSpPr/>
+          <p:nvPr/>
+        </p:nvSpPr>
+        <p:spPr>
+          <a:xfrm>
+            <a:off x="10509250" y="6299200"/>
+            <a:ext cx="12700" cy="279400"/>
+          </a:xfrm>
+          <a:prstGeom prst="rect">
+            <a:avLst/>
+          </a:prstGeom>
+          <a:solidFill>
+            <a:srgbClr val="CDD9DE"/>
+          </a:solidFill>
+          <a:ln>
+            <a:noFill/>
+          </a:ln>
+          <a:effectLst/>
+        </p:spPr>
+        <p:style>
+          <a:lnRef idx="1">
+            <a:schemeClr val="accent1"/>
+          </a:lnRef>
+          <a:fillRef idx="3">
+            <a:schemeClr val="accent1"/>
+          </a:fillRef>
+          <a:effectRef idx="2">
+            <a:schemeClr val="accent1"/>
+          </a:effectRef>
+          <a:fontRef idx="minor">
+            <a:schemeClr val="lt1"/>
+          </a:fontRef>
+        </p:style>
+        <p:txBody>
+          <a:bodyPr rtlCol="0" anchor="ctr"/>
+          <a:lstStyle/>
+          <a:p>
+            <a:pPr algn="ctr"/>
+          </a:p>
+        </p:txBody>
+      </p:sp>
+      <p:pic>
+        <p:nvPicPr>
+          <p:cNvPr id="15" name="Picture 14" descr="logo_jisc_placeholder.png"/>
+          <p:cNvPicPr>
+            <a:picLocks noChangeAspect="1"/>
+          </p:cNvPicPr>
+          <p:nvPr/>
+        </p:nvPicPr>
+        <p:blipFill>
+          <a:blip r:embed="rId5"/>
+          <a:stretch>
+            <a:fillRect/>
+          </a:stretch>
+        </p:blipFill>
+        <p:spPr>
+          <a:xfrm>
+            <a:off x="10661650" y="6299200"/>
+            <a:ext cx="768350" cy="279400"/>
+          </a:xfrm>
+          <a:prstGeom prst="rect">
+            <a:avLst/>
+          </a:prstGeom>
+        </p:spPr>
+      </p:pic>
+      <p:sp>
+        <p:nvSpPr>
+          <p:cNvPr id="16" name="TextBox 15"/>
           <p:cNvSpPr txBox="1"/>
           <p:nvPr/>
         </p:nvSpPr>
         <p:spPr>
           <a:xfrm>
-            <a:off x="9906000" y="6375400"/>
+            <a:off x="8445500" y="6375400"/>
             <a:ext cx="381000" cy="190500"/>
           </a:xfrm>
           <a:prstGeom prst="rect">
@@ -29763,7 +31967,7 @@
         </p:blipFill>
         <p:spPr>
           <a:xfrm>
-            <a:off x="10490200" y="6324600"/>
+            <a:off x="9417050" y="6311900"/>
             <a:ext cx="939800" cy="254000"/>
           </a:xfrm>
           <a:prstGeom prst="rect">
@@ -29773,13 +31977,81 @@
       </p:pic>
       <p:sp>
         <p:nvSpPr>
-          <p:cNvPr id="26" name="TextBox 25"/>
+          <p:cNvPr id="26" name="Rectangle 25"/>
+          <p:cNvSpPr/>
+          <p:nvPr/>
+        </p:nvSpPr>
+        <p:spPr>
+          <a:xfrm>
+            <a:off x="10509250" y="6299200"/>
+            <a:ext cx="12700" cy="279400"/>
+          </a:xfrm>
+          <a:prstGeom prst="rect">
+            <a:avLst/>
+          </a:prstGeom>
+          <a:solidFill>
+            <a:srgbClr val="CDD9DE"/>
+          </a:solidFill>
+          <a:ln>
+            <a:noFill/>
+          </a:ln>
+          <a:effectLst/>
+        </p:spPr>
+        <p:style>
+          <a:lnRef idx="1">
+            <a:schemeClr val="accent1"/>
+          </a:lnRef>
+          <a:fillRef idx="3">
+            <a:schemeClr val="accent1"/>
+          </a:fillRef>
+          <a:effectRef idx="2">
+            <a:schemeClr val="accent1"/>
+          </a:effectRef>
+          <a:fontRef idx="minor">
+            <a:schemeClr val="lt1"/>
+          </a:fontRef>
+        </p:style>
+        <p:txBody>
+          <a:bodyPr rtlCol="0" anchor="ctr"/>
+          <a:lstStyle/>
+          <a:p>
+            <a:pPr algn="ctr"/>
+          </a:p>
+        </p:txBody>
+      </p:sp>
+      <p:pic>
+        <p:nvPicPr>
+          <p:cNvPr id="27" name="Picture 26" descr="logo_jisc_placeholder.png"/>
+          <p:cNvPicPr>
+            <a:picLocks noChangeAspect="1"/>
+          </p:cNvPicPr>
+          <p:nvPr/>
+        </p:nvPicPr>
+        <p:blipFill>
+          <a:blip r:embed="rId3"/>
+          <a:stretch>
+            <a:fillRect/>
+          </a:stretch>
+        </p:blipFill>
+        <p:spPr>
+          <a:xfrm>
+            <a:off x="10661650" y="6299200"/>
+            <a:ext cx="768350" cy="279400"/>
+          </a:xfrm>
+          <a:prstGeom prst="rect">
+            <a:avLst/>
+          </a:prstGeom>
+        </p:spPr>
+      </p:pic>
+      <p:sp>
+        <p:nvSpPr>
+          <p:cNvPr id="28" name="TextBox 27"/>
           <p:cNvSpPr txBox="1"/>
           <p:nvPr/>
         </p:nvSpPr>
         <p:spPr>
           <a:xfrm>
-            <a:off x="9906000" y="6375400"/>
+            <a:off x="8445500" y="6375400"/>
             <a:ext cx="381000" cy="190500"/>
           </a:xfrm>
           <a:prstGeom prst="rect">
@@ -30804,7 +33076,7 @@
         </p:blipFill>
         <p:spPr>
           <a:xfrm>
-            <a:off x="10490200" y="6324600"/>
+            <a:off x="9417050" y="6311900"/>
             <a:ext cx="939800" cy="254000"/>
           </a:xfrm>
           <a:prstGeom prst="rect">
@@ -30814,13 +33086,81 @@
       </p:pic>
       <p:sp>
         <p:nvSpPr>
-          <p:cNvPr id="26" name="TextBox 25"/>
+          <p:cNvPr id="26" name="Rectangle 25"/>
+          <p:cNvSpPr/>
+          <p:nvPr/>
+        </p:nvSpPr>
+        <p:spPr>
+          <a:xfrm>
+            <a:off x="10509250" y="6299200"/>
+            <a:ext cx="12700" cy="279400"/>
+          </a:xfrm>
+          <a:prstGeom prst="rect">
+            <a:avLst/>
+          </a:prstGeom>
+          <a:solidFill>
+            <a:srgbClr val="CDD9DE"/>
+          </a:solidFill>
+          <a:ln>
+            <a:noFill/>
+          </a:ln>
+          <a:effectLst/>
+        </p:spPr>
+        <p:style>
+          <a:lnRef idx="1">
+            <a:schemeClr val="accent1"/>
+          </a:lnRef>
+          <a:fillRef idx="3">
+            <a:schemeClr val="accent1"/>
+          </a:fillRef>
+          <a:effectRef idx="2">
+            <a:schemeClr val="accent1"/>
+          </a:effectRef>
+          <a:fontRef idx="minor">
+            <a:schemeClr val="lt1"/>
+          </a:fontRef>
+        </p:style>
+        <p:txBody>
+          <a:bodyPr rtlCol="0" anchor="ctr"/>
+          <a:lstStyle/>
+          <a:p>
+            <a:pPr algn="ctr"/>
+          </a:p>
+        </p:txBody>
+      </p:sp>
+      <p:pic>
+        <p:nvPicPr>
+          <p:cNvPr id="27" name="Picture 26" descr="logo_jisc_placeholder.png"/>
+          <p:cNvPicPr>
+            <a:picLocks noChangeAspect="1"/>
+          </p:cNvPicPr>
+          <p:nvPr/>
+        </p:nvPicPr>
+        <p:blipFill>
+          <a:blip r:embed="rId3"/>
+          <a:stretch>
+            <a:fillRect/>
+          </a:stretch>
+        </p:blipFill>
+        <p:spPr>
+          <a:xfrm>
+            <a:off x="10661650" y="6299200"/>
+            <a:ext cx="768350" cy="279400"/>
+          </a:xfrm>
+          <a:prstGeom prst="rect">
+            <a:avLst/>
+          </a:prstGeom>
+        </p:spPr>
+      </p:pic>
+      <p:sp>
+        <p:nvSpPr>
+          <p:cNvPr id="28" name="TextBox 27"/>
           <p:cNvSpPr txBox="1"/>
           <p:nvPr/>
         </p:nvSpPr>
         <p:spPr>
           <a:xfrm>
-            <a:off x="9906000" y="6375400"/>
+            <a:off x="8445500" y="6375400"/>
             <a:ext cx="381000" cy="190500"/>
           </a:xfrm>
           <a:prstGeom prst="rect">
@@ -31397,7 +33737,7 @@
         </p:blipFill>
         <p:spPr>
           <a:xfrm>
-            <a:off x="10490200" y="6324600"/>
+            <a:off x="9417050" y="6311900"/>
             <a:ext cx="939800" cy="254000"/>
           </a:xfrm>
           <a:prstGeom prst="rect">
@@ -31407,13 +33747,81 @@
       </p:pic>
       <p:sp>
         <p:nvSpPr>
-          <p:cNvPr id="15" name="TextBox 14"/>
+          <p:cNvPr id="15" name="Rectangle 14"/>
+          <p:cNvSpPr/>
+          <p:nvPr/>
+        </p:nvSpPr>
+        <p:spPr>
+          <a:xfrm>
+            <a:off x="10509250" y="6299200"/>
+            <a:ext cx="12700" cy="279400"/>
+          </a:xfrm>
+          <a:prstGeom prst="rect">
+            <a:avLst/>
+          </a:prstGeom>
+          <a:solidFill>
+            <a:srgbClr val="CDD9DE"/>
+          </a:solidFill>
+          <a:ln>
+            <a:noFill/>
+          </a:ln>
+          <a:effectLst/>
+        </p:spPr>
+        <p:style>
+          <a:lnRef idx="1">
+            <a:schemeClr val="accent1"/>
+          </a:lnRef>
+          <a:fillRef idx="3">
+            <a:schemeClr val="accent1"/>
+          </a:fillRef>
+          <a:effectRef idx="2">
+            <a:schemeClr val="accent1"/>
+          </a:effectRef>
+          <a:fontRef idx="minor">
+            <a:schemeClr val="lt1"/>
+          </a:fontRef>
+        </p:style>
+        <p:txBody>
+          <a:bodyPr rtlCol="0" anchor="ctr"/>
+          <a:lstStyle/>
+          <a:p>
+            <a:pPr algn="ctr"/>
+          </a:p>
+        </p:txBody>
+      </p:sp>
+      <p:pic>
+        <p:nvPicPr>
+          <p:cNvPr id="16" name="Picture 15" descr="logo_jisc_placeholder.png"/>
+          <p:cNvPicPr>
+            <a:picLocks noChangeAspect="1"/>
+          </p:cNvPicPr>
+          <p:nvPr/>
+        </p:nvPicPr>
+        <p:blipFill>
+          <a:blip r:embed="rId3"/>
+          <a:stretch>
+            <a:fillRect/>
+          </a:stretch>
+        </p:blipFill>
+        <p:spPr>
+          <a:xfrm>
+            <a:off x="10661650" y="6299200"/>
+            <a:ext cx="768350" cy="279400"/>
+          </a:xfrm>
+          <a:prstGeom prst="rect">
+            <a:avLst/>
+          </a:prstGeom>
+        </p:spPr>
+      </p:pic>
+      <p:sp>
+        <p:nvSpPr>
+          <p:cNvPr id="17" name="TextBox 16"/>
           <p:cNvSpPr txBox="1"/>
           <p:nvPr/>
         </p:nvSpPr>
         <p:spPr>
           <a:xfrm>
-            <a:off x="9906000" y="6375400"/>
+            <a:off x="8445500" y="6375400"/>
             <a:ext cx="381000" cy="190500"/>
           </a:xfrm>
           <a:prstGeom prst="rect">
@@ -31639,9 +34047,55 @@
           </a:p>
         </p:txBody>
       </p:sp>
+      <p:sp>
+        <p:nvSpPr>
+          <p:cNvPr id="6" name="Rounded Rectangle 5"/>
+          <p:cNvSpPr/>
+          <p:nvPr/>
+        </p:nvSpPr>
+        <p:spPr>
+          <a:xfrm>
+            <a:off x="9264650" y="6210300"/>
+            <a:ext cx="2317750" cy="457200"/>
+          </a:xfrm>
+          <a:prstGeom prst="roundRect">
+            <a:avLst>
+              <a:gd name="adj" fmla="val 25000"/>
+            </a:avLst>
+          </a:prstGeom>
+          <a:solidFill>
+            <a:srgbClr val="FFFFFF"/>
+          </a:solidFill>
+          <a:ln>
+            <a:noFill/>
+          </a:ln>
+          <a:effectLst/>
+        </p:spPr>
+        <p:style>
+          <a:lnRef idx="1">
+            <a:schemeClr val="accent1"/>
+          </a:lnRef>
+          <a:fillRef idx="3">
+            <a:schemeClr val="accent1"/>
+          </a:fillRef>
+          <a:effectRef idx="2">
+            <a:schemeClr val="accent1"/>
+          </a:effectRef>
+          <a:fontRef idx="minor">
+            <a:schemeClr val="lt1"/>
+          </a:fontRef>
+        </p:style>
+        <p:txBody>
+          <a:bodyPr rtlCol="0" anchor="ctr"/>
+          <a:lstStyle/>
+          <a:p>
+            <a:pPr algn="ctr"/>
+          </a:p>
+        </p:txBody>
+      </p:sp>
       <p:pic>
         <p:nvPicPr>
-          <p:cNvPr id="6" name="Picture 5" descr="logo_white_c.png"/>
+          <p:cNvPr id="7" name="Picture 6" descr="logo_navy_c.png"/>
           <p:cNvPicPr>
             <a:picLocks noChangeAspect="1"/>
           </p:cNvPicPr>
@@ -31655,8 +34109,76 @@
         </p:blipFill>
         <p:spPr>
           <a:xfrm>
-            <a:off x="762000" y="5969000"/>
-            <a:ext cx="1409700" cy="381000"/>
+            <a:off x="9417050" y="6311900"/>
+            <a:ext cx="939800" cy="254000"/>
+          </a:xfrm>
+          <a:prstGeom prst="rect">
+            <a:avLst/>
+          </a:prstGeom>
+        </p:spPr>
+      </p:pic>
+      <p:sp>
+        <p:nvSpPr>
+          <p:cNvPr id="8" name="Rectangle 7"/>
+          <p:cNvSpPr/>
+          <p:nvPr/>
+        </p:nvSpPr>
+        <p:spPr>
+          <a:xfrm>
+            <a:off x="10509250" y="6299200"/>
+            <a:ext cx="12700" cy="279400"/>
+          </a:xfrm>
+          <a:prstGeom prst="rect">
+            <a:avLst/>
+          </a:prstGeom>
+          <a:solidFill>
+            <a:srgbClr val="CDD9DE"/>
+          </a:solidFill>
+          <a:ln>
+            <a:noFill/>
+          </a:ln>
+          <a:effectLst/>
+        </p:spPr>
+        <p:style>
+          <a:lnRef idx="1">
+            <a:schemeClr val="accent1"/>
+          </a:lnRef>
+          <a:fillRef idx="3">
+            <a:schemeClr val="accent1"/>
+          </a:fillRef>
+          <a:effectRef idx="2">
+            <a:schemeClr val="accent1"/>
+          </a:effectRef>
+          <a:fontRef idx="minor">
+            <a:schemeClr val="lt1"/>
+          </a:fontRef>
+        </p:style>
+        <p:txBody>
+          <a:bodyPr rtlCol="0" anchor="ctr"/>
+          <a:lstStyle/>
+          <a:p>
+            <a:pPr algn="ctr"/>
+          </a:p>
+        </p:txBody>
+      </p:sp>
+      <p:pic>
+        <p:nvPicPr>
+          <p:cNvPr id="9" name="Picture 8" descr="logo_jisc_placeholder.png"/>
+          <p:cNvPicPr>
+            <a:picLocks noChangeAspect="1"/>
+          </p:cNvPicPr>
+          <p:nvPr/>
+        </p:nvPicPr>
+        <p:blipFill>
+          <a:blip r:embed="rId3"/>
+          <a:stretch>
+            <a:fillRect/>
+          </a:stretch>
+        </p:blipFill>
+        <p:spPr>
+          <a:xfrm>
+            <a:off x="10661650" y="6299200"/>
+            <a:ext cx="768350" cy="279400"/>
           </a:xfrm>
           <a:prstGeom prst="rect">
             <a:avLst/>
@@ -32005,7 +34527,7 @@
         </p:blipFill>
         <p:spPr>
           <a:xfrm>
-            <a:off x="10490200" y="6324600"/>
+            <a:off x="9417050" y="6311900"/>
             <a:ext cx="939800" cy="254000"/>
           </a:xfrm>
           <a:prstGeom prst="rect">
@@ -32015,13 +34537,81 @@
       </p:pic>
       <p:sp>
         <p:nvSpPr>
-          <p:cNvPr id="10" name="TextBox 9"/>
+          <p:cNvPr id="10" name="Rectangle 9"/>
+          <p:cNvSpPr/>
+          <p:nvPr/>
+        </p:nvSpPr>
+        <p:spPr>
+          <a:xfrm>
+            <a:off x="10509250" y="6299200"/>
+            <a:ext cx="12700" cy="279400"/>
+          </a:xfrm>
+          <a:prstGeom prst="rect">
+            <a:avLst/>
+          </a:prstGeom>
+          <a:solidFill>
+            <a:srgbClr val="CDD9DE"/>
+          </a:solidFill>
+          <a:ln>
+            <a:noFill/>
+          </a:ln>
+          <a:effectLst/>
+        </p:spPr>
+        <p:style>
+          <a:lnRef idx="1">
+            <a:schemeClr val="accent1"/>
+          </a:lnRef>
+          <a:fillRef idx="3">
+            <a:schemeClr val="accent1"/>
+          </a:fillRef>
+          <a:effectRef idx="2">
+            <a:schemeClr val="accent1"/>
+          </a:effectRef>
+          <a:fontRef idx="minor">
+            <a:schemeClr val="lt1"/>
+          </a:fontRef>
+        </p:style>
+        <p:txBody>
+          <a:bodyPr rtlCol="0" anchor="ctr"/>
+          <a:lstStyle/>
+          <a:p>
+            <a:pPr algn="ctr"/>
+          </a:p>
+        </p:txBody>
+      </p:sp>
+      <p:pic>
+        <p:nvPicPr>
+          <p:cNvPr id="11" name="Picture 10" descr="logo_jisc_placeholder.png"/>
+          <p:cNvPicPr>
+            <a:picLocks noChangeAspect="1"/>
+          </p:cNvPicPr>
+          <p:nvPr/>
+        </p:nvPicPr>
+        <p:blipFill>
+          <a:blip r:embed="rId3"/>
+          <a:stretch>
+            <a:fillRect/>
+          </a:stretch>
+        </p:blipFill>
+        <p:spPr>
+          <a:xfrm>
+            <a:off x="10661650" y="6299200"/>
+            <a:ext cx="768350" cy="279400"/>
+          </a:xfrm>
+          <a:prstGeom prst="rect">
+            <a:avLst/>
+          </a:prstGeom>
+        </p:spPr>
+      </p:pic>
+      <p:sp>
+        <p:nvSpPr>
+          <p:cNvPr id="12" name="TextBox 11"/>
           <p:cNvSpPr txBox="1"/>
           <p:nvPr/>
         </p:nvSpPr>
         <p:spPr>
           <a:xfrm>
-            <a:off x="9906000" y="6375400"/>
+            <a:off x="8445500" y="6375400"/>
             <a:ext cx="381000" cy="190500"/>
           </a:xfrm>
           <a:prstGeom prst="rect">
@@ -32394,7 +34984,7 @@
         </p:blipFill>
         <p:spPr>
           <a:xfrm>
-            <a:off x="10490200" y="6324600"/>
+            <a:off x="9417050" y="6311900"/>
             <a:ext cx="939800" cy="254000"/>
           </a:xfrm>
           <a:prstGeom prst="rect">
@@ -32404,13 +34994,81 @@
       </p:pic>
       <p:sp>
         <p:nvSpPr>
-          <p:cNvPr id="10" name="TextBox 9"/>
+          <p:cNvPr id="10" name="Rectangle 9"/>
+          <p:cNvSpPr/>
+          <p:nvPr/>
+        </p:nvSpPr>
+        <p:spPr>
+          <a:xfrm>
+            <a:off x="10509250" y="6299200"/>
+            <a:ext cx="12700" cy="279400"/>
+          </a:xfrm>
+          <a:prstGeom prst="rect">
+            <a:avLst/>
+          </a:prstGeom>
+          <a:solidFill>
+            <a:srgbClr val="CDD9DE"/>
+          </a:solidFill>
+          <a:ln>
+            <a:noFill/>
+          </a:ln>
+          <a:effectLst/>
+        </p:spPr>
+        <p:style>
+          <a:lnRef idx="1">
+            <a:schemeClr val="accent1"/>
+          </a:lnRef>
+          <a:fillRef idx="3">
+            <a:schemeClr val="accent1"/>
+          </a:fillRef>
+          <a:effectRef idx="2">
+            <a:schemeClr val="accent1"/>
+          </a:effectRef>
+          <a:fontRef idx="minor">
+            <a:schemeClr val="lt1"/>
+          </a:fontRef>
+        </p:style>
+        <p:txBody>
+          <a:bodyPr rtlCol="0" anchor="ctr"/>
+          <a:lstStyle/>
+          <a:p>
+            <a:pPr algn="ctr"/>
+          </a:p>
+        </p:txBody>
+      </p:sp>
+      <p:pic>
+        <p:nvPicPr>
+          <p:cNvPr id="11" name="Picture 10" descr="logo_jisc_placeholder.png"/>
+          <p:cNvPicPr>
+            <a:picLocks noChangeAspect="1"/>
+          </p:cNvPicPr>
+          <p:nvPr/>
+        </p:nvPicPr>
+        <p:blipFill>
+          <a:blip r:embed="rId3"/>
+          <a:stretch>
+            <a:fillRect/>
+          </a:stretch>
+        </p:blipFill>
+        <p:spPr>
+          <a:xfrm>
+            <a:off x="10661650" y="6299200"/>
+            <a:ext cx="768350" cy="279400"/>
+          </a:xfrm>
+          <a:prstGeom prst="rect">
+            <a:avLst/>
+          </a:prstGeom>
+        </p:spPr>
+      </p:pic>
+      <p:sp>
+        <p:nvSpPr>
+          <p:cNvPr id="12" name="TextBox 11"/>
           <p:cNvSpPr txBox="1"/>
           <p:nvPr/>
         </p:nvSpPr>
         <p:spPr>
           <a:xfrm>
-            <a:off x="9906000" y="6375400"/>
+            <a:off x="8445500" y="6375400"/>
             <a:ext cx="381000" cy="190500"/>
           </a:xfrm>
           <a:prstGeom prst="rect">
@@ -32849,7 +35507,7 @@
         </p:blipFill>
         <p:spPr>
           <a:xfrm>
-            <a:off x="10490200" y="6324600"/>
+            <a:off x="9417050" y="6311900"/>
             <a:ext cx="939800" cy="254000"/>
           </a:xfrm>
           <a:prstGeom prst="rect">
@@ -32859,13 +35517,81 @@
       </p:pic>
       <p:sp>
         <p:nvSpPr>
-          <p:cNvPr id="12" name="TextBox 11"/>
+          <p:cNvPr id="12" name="Rectangle 11"/>
+          <p:cNvSpPr/>
+          <p:nvPr/>
+        </p:nvSpPr>
+        <p:spPr>
+          <a:xfrm>
+            <a:off x="10509250" y="6299200"/>
+            <a:ext cx="12700" cy="279400"/>
+          </a:xfrm>
+          <a:prstGeom prst="rect">
+            <a:avLst/>
+          </a:prstGeom>
+          <a:solidFill>
+            <a:srgbClr val="CDD9DE"/>
+          </a:solidFill>
+          <a:ln>
+            <a:noFill/>
+          </a:ln>
+          <a:effectLst/>
+        </p:spPr>
+        <p:style>
+          <a:lnRef idx="1">
+            <a:schemeClr val="accent1"/>
+          </a:lnRef>
+          <a:fillRef idx="3">
+            <a:schemeClr val="accent1"/>
+          </a:fillRef>
+          <a:effectRef idx="2">
+            <a:schemeClr val="accent1"/>
+          </a:effectRef>
+          <a:fontRef idx="minor">
+            <a:schemeClr val="lt1"/>
+          </a:fontRef>
+        </p:style>
+        <p:txBody>
+          <a:bodyPr rtlCol="0" anchor="ctr"/>
+          <a:lstStyle/>
+          <a:p>
+            <a:pPr algn="ctr"/>
+          </a:p>
+        </p:txBody>
+      </p:sp>
+      <p:pic>
+        <p:nvPicPr>
+          <p:cNvPr id="13" name="Picture 12" descr="logo_jisc_placeholder.png"/>
+          <p:cNvPicPr>
+            <a:picLocks noChangeAspect="1"/>
+          </p:cNvPicPr>
+          <p:nvPr/>
+        </p:nvPicPr>
+        <p:blipFill>
+          <a:blip r:embed="rId3"/>
+          <a:stretch>
+            <a:fillRect/>
+          </a:stretch>
+        </p:blipFill>
+        <p:spPr>
+          <a:xfrm>
+            <a:off x="10661650" y="6299200"/>
+            <a:ext cx="768350" cy="279400"/>
+          </a:xfrm>
+          <a:prstGeom prst="rect">
+            <a:avLst/>
+          </a:prstGeom>
+        </p:spPr>
+      </p:pic>
+      <p:sp>
+        <p:nvSpPr>
+          <p:cNvPr id="14" name="TextBox 13"/>
           <p:cNvSpPr txBox="1"/>
           <p:nvPr/>
         </p:nvSpPr>
         <p:spPr>
           <a:xfrm>
-            <a:off x="9906000" y="6375400"/>
+            <a:off x="8445500" y="6375400"/>
             <a:ext cx="381000" cy="190500"/>
           </a:xfrm>
           <a:prstGeom prst="rect">
@@ -33238,7 +35964,7 @@
         </p:blipFill>
         <p:spPr>
           <a:xfrm>
-            <a:off x="10490200" y="6324600"/>
+            <a:off x="9417050" y="6311900"/>
             <a:ext cx="939800" cy="254000"/>
           </a:xfrm>
           <a:prstGeom prst="rect">
@@ -33248,13 +35974,81 @@
       </p:pic>
       <p:sp>
         <p:nvSpPr>
-          <p:cNvPr id="10" name="TextBox 9"/>
+          <p:cNvPr id="10" name="Rectangle 9"/>
+          <p:cNvSpPr/>
+          <p:nvPr/>
+        </p:nvSpPr>
+        <p:spPr>
+          <a:xfrm>
+            <a:off x="10509250" y="6299200"/>
+            <a:ext cx="12700" cy="279400"/>
+          </a:xfrm>
+          <a:prstGeom prst="rect">
+            <a:avLst/>
+          </a:prstGeom>
+          <a:solidFill>
+            <a:srgbClr val="CDD9DE"/>
+          </a:solidFill>
+          <a:ln>
+            <a:noFill/>
+          </a:ln>
+          <a:effectLst/>
+        </p:spPr>
+        <p:style>
+          <a:lnRef idx="1">
+            <a:schemeClr val="accent1"/>
+          </a:lnRef>
+          <a:fillRef idx="3">
+            <a:schemeClr val="accent1"/>
+          </a:fillRef>
+          <a:effectRef idx="2">
+            <a:schemeClr val="accent1"/>
+          </a:effectRef>
+          <a:fontRef idx="minor">
+            <a:schemeClr val="lt1"/>
+          </a:fontRef>
+        </p:style>
+        <p:txBody>
+          <a:bodyPr rtlCol="0" anchor="ctr"/>
+          <a:lstStyle/>
+          <a:p>
+            <a:pPr algn="ctr"/>
+          </a:p>
+        </p:txBody>
+      </p:sp>
+      <p:pic>
+        <p:nvPicPr>
+          <p:cNvPr id="11" name="Picture 10" descr="logo_jisc_placeholder.png"/>
+          <p:cNvPicPr>
+            <a:picLocks noChangeAspect="1"/>
+          </p:cNvPicPr>
+          <p:nvPr/>
+        </p:nvPicPr>
+        <p:blipFill>
+          <a:blip r:embed="rId3"/>
+          <a:stretch>
+            <a:fillRect/>
+          </a:stretch>
+        </p:blipFill>
+        <p:spPr>
+          <a:xfrm>
+            <a:off x="10661650" y="6299200"/>
+            <a:ext cx="768350" cy="279400"/>
+          </a:xfrm>
+          <a:prstGeom prst="rect">
+            <a:avLst/>
+          </a:prstGeom>
+        </p:spPr>
+      </p:pic>
+      <p:sp>
+        <p:nvSpPr>
+          <p:cNvPr id="12" name="TextBox 11"/>
           <p:cNvSpPr txBox="1"/>
           <p:nvPr/>
         </p:nvSpPr>
         <p:spPr>
           <a:xfrm>
-            <a:off x="9906000" y="6375400"/>
+            <a:off x="8445500" y="6375400"/>
             <a:ext cx="381000" cy="190500"/>
           </a:xfrm>
           <a:prstGeom prst="rect">
@@ -33627,7 +36421,7 @@
         </p:blipFill>
         <p:spPr>
           <a:xfrm>
-            <a:off x="10490200" y="6324600"/>
+            <a:off x="9417050" y="6311900"/>
             <a:ext cx="939800" cy="254000"/>
           </a:xfrm>
           <a:prstGeom prst="rect">
@@ -33637,13 +36431,81 @@
       </p:pic>
       <p:sp>
         <p:nvSpPr>
-          <p:cNvPr id="10" name="TextBox 9"/>
+          <p:cNvPr id="10" name="Rectangle 9"/>
+          <p:cNvSpPr/>
+          <p:nvPr/>
+        </p:nvSpPr>
+        <p:spPr>
+          <a:xfrm>
+            <a:off x="10509250" y="6299200"/>
+            <a:ext cx="12700" cy="279400"/>
+          </a:xfrm>
+          <a:prstGeom prst="rect">
+            <a:avLst/>
+          </a:prstGeom>
+          <a:solidFill>
+            <a:srgbClr val="CDD9DE"/>
+          </a:solidFill>
+          <a:ln>
+            <a:noFill/>
+          </a:ln>
+          <a:effectLst/>
+        </p:spPr>
+        <p:style>
+          <a:lnRef idx="1">
+            <a:schemeClr val="accent1"/>
+          </a:lnRef>
+          <a:fillRef idx="3">
+            <a:schemeClr val="accent1"/>
+          </a:fillRef>
+          <a:effectRef idx="2">
+            <a:schemeClr val="accent1"/>
+          </a:effectRef>
+          <a:fontRef idx="minor">
+            <a:schemeClr val="lt1"/>
+          </a:fontRef>
+        </p:style>
+        <p:txBody>
+          <a:bodyPr rtlCol="0" anchor="ctr"/>
+          <a:lstStyle/>
+          <a:p>
+            <a:pPr algn="ctr"/>
+          </a:p>
+        </p:txBody>
+      </p:sp>
+      <p:pic>
+        <p:nvPicPr>
+          <p:cNvPr id="11" name="Picture 10" descr="logo_jisc_placeholder.png"/>
+          <p:cNvPicPr>
+            <a:picLocks noChangeAspect="1"/>
+          </p:cNvPicPr>
+          <p:nvPr/>
+        </p:nvPicPr>
+        <p:blipFill>
+          <a:blip r:embed="rId3"/>
+          <a:stretch>
+            <a:fillRect/>
+          </a:stretch>
+        </p:blipFill>
+        <p:spPr>
+          <a:xfrm>
+            <a:off x="10661650" y="6299200"/>
+            <a:ext cx="768350" cy="279400"/>
+          </a:xfrm>
+          <a:prstGeom prst="rect">
+            <a:avLst/>
+          </a:prstGeom>
+        </p:spPr>
+      </p:pic>
+      <p:sp>
+        <p:nvSpPr>
+          <p:cNvPr id="12" name="TextBox 11"/>
           <p:cNvSpPr txBox="1"/>
           <p:nvPr/>
         </p:nvSpPr>
         <p:spPr>
           <a:xfrm>
-            <a:off x="9906000" y="6375400"/>
+            <a:off x="8445500" y="6375400"/>
             <a:ext cx="381000" cy="190500"/>
           </a:xfrm>
           <a:prstGeom prst="rect">
@@ -34016,7 +36878,7 @@
         </p:blipFill>
         <p:spPr>
           <a:xfrm>
-            <a:off x="10490200" y="6324600"/>
+            <a:off x="9417050" y="6311900"/>
             <a:ext cx="939800" cy="254000"/>
           </a:xfrm>
           <a:prstGeom prst="rect">
@@ -34026,13 +36888,81 @@
       </p:pic>
       <p:sp>
         <p:nvSpPr>
-          <p:cNvPr id="10" name="TextBox 9"/>
+          <p:cNvPr id="10" name="Rectangle 9"/>
+          <p:cNvSpPr/>
+          <p:nvPr/>
+        </p:nvSpPr>
+        <p:spPr>
+          <a:xfrm>
+            <a:off x="10509250" y="6299200"/>
+            <a:ext cx="12700" cy="279400"/>
+          </a:xfrm>
+          <a:prstGeom prst="rect">
+            <a:avLst/>
+          </a:prstGeom>
+          <a:solidFill>
+            <a:srgbClr val="CDD9DE"/>
+          </a:solidFill>
+          <a:ln>
+            <a:noFill/>
+          </a:ln>
+          <a:effectLst/>
+        </p:spPr>
+        <p:style>
+          <a:lnRef idx="1">
+            <a:schemeClr val="accent1"/>
+          </a:lnRef>
+          <a:fillRef idx="3">
+            <a:schemeClr val="accent1"/>
+          </a:fillRef>
+          <a:effectRef idx="2">
+            <a:schemeClr val="accent1"/>
+          </a:effectRef>
+          <a:fontRef idx="minor">
+            <a:schemeClr val="lt1"/>
+          </a:fontRef>
+        </p:style>
+        <p:txBody>
+          <a:bodyPr rtlCol="0" anchor="ctr"/>
+          <a:lstStyle/>
+          <a:p>
+            <a:pPr algn="ctr"/>
+          </a:p>
+        </p:txBody>
+      </p:sp>
+      <p:pic>
+        <p:nvPicPr>
+          <p:cNvPr id="11" name="Picture 10" descr="logo_jisc_placeholder.png"/>
+          <p:cNvPicPr>
+            <a:picLocks noChangeAspect="1"/>
+          </p:cNvPicPr>
+          <p:nvPr/>
+        </p:nvPicPr>
+        <p:blipFill>
+          <a:blip r:embed="rId3"/>
+          <a:stretch>
+            <a:fillRect/>
+          </a:stretch>
+        </p:blipFill>
+        <p:spPr>
+          <a:xfrm>
+            <a:off x="10661650" y="6299200"/>
+            <a:ext cx="768350" cy="279400"/>
+          </a:xfrm>
+          <a:prstGeom prst="rect">
+            <a:avLst/>
+          </a:prstGeom>
+        </p:spPr>
+      </p:pic>
+      <p:sp>
+        <p:nvSpPr>
+          <p:cNvPr id="12" name="TextBox 11"/>
           <p:cNvSpPr txBox="1"/>
           <p:nvPr/>
         </p:nvSpPr>
         <p:spPr>
           <a:xfrm>
-            <a:off x="9906000" y="6375400"/>
+            <a:off x="8445500" y="6375400"/>
             <a:ext cx="381000" cy="190500"/>
           </a:xfrm>
           <a:prstGeom prst="rect">

</xml_diff>

<commit_message>
Jisc-webinar: echt Jisc-logo op alle slides
Co-Authored-By: Claude Opus 5.5 <noreply@anthropic.com>
Claude-Session: https://claude.ai/code/session_015wepMCxdSi78pa2LxvGqQg
</commit_message>
<xml_diff>
--- a/GTM/Event manager/jisc-webinar/deck/jisc-webinar-bewerkbaar.pptx
+++ b/GTM/Event manager/jisc-webinar/deck/jisc-webinar-bewerkbaar.pptx
@@ -3447,12 +3447,12 @@
         </p:nvSpPr>
         <p:spPr>
           <a:xfrm>
-            <a:off x="584200" y="5791200"/>
-            <a:ext cx="3130550" cy="736600"/>
+            <a:off x="584200" y="5740400"/>
+            <a:ext cx="2589843" cy="838200"/>
           </a:xfrm>
           <a:prstGeom prst="roundRect">
             <a:avLst>
-              <a:gd name="adj" fmla="val 18965"/>
+              <a:gd name="adj" fmla="val 16666"/>
             </a:avLst>
           </a:prstGeom>
           <a:solidFill>
@@ -3555,7 +3555,7 @@
       </p:sp>
       <p:pic>
         <p:nvPicPr>
-          <p:cNvPr id="12" name="Picture 11" descr="logo_jisc_placeholder.png"/>
+          <p:cNvPr id="12" name="Picture 11" descr="logo_jisc.png"/>
           <p:cNvPicPr>
             <a:picLocks noChangeAspect="1"/>
           </p:cNvPicPr>
@@ -3569,8 +3569,8 @@
         </p:blipFill>
         <p:spPr>
           <a:xfrm>
-            <a:off x="2489200" y="5969000"/>
-            <a:ext cx="1047750" cy="381000"/>
+            <a:off x="2489200" y="5905500"/>
+            <a:ext cx="507043" cy="508000"/>
           </a:xfrm>
           <a:prstGeom prst="rect">
             <a:avLst/>
@@ -4349,7 +4349,7 @@
         </p:blipFill>
         <p:spPr>
           <a:xfrm>
-            <a:off x="9417050" y="6311900"/>
+            <a:off x="9830470" y="6311900"/>
             <a:ext cx="939800" cy="254000"/>
           </a:xfrm>
           <a:prstGeom prst="rect">
@@ -4365,8 +4365,8 @@
         </p:nvSpPr>
         <p:spPr>
           <a:xfrm>
-            <a:off x="10509250" y="6299200"/>
-            <a:ext cx="12700" cy="279400"/>
+            <a:off x="10922670" y="6261100"/>
+            <a:ext cx="12700" cy="355600"/>
           </a:xfrm>
           <a:prstGeom prst="rect">
             <a:avLst/>
@@ -4403,7 +4403,7 @@
       </p:sp>
       <p:pic>
         <p:nvPicPr>
-          <p:cNvPr id="23" name="Picture 22" descr="logo_jisc_placeholder.png"/>
+          <p:cNvPr id="23" name="Picture 22" descr="logo_jisc.png"/>
           <p:cNvPicPr>
             <a:picLocks noChangeAspect="1"/>
           </p:cNvPicPr>
@@ -4417,8 +4417,8 @@
         </p:blipFill>
         <p:spPr>
           <a:xfrm>
-            <a:off x="10661650" y="6299200"/>
-            <a:ext cx="768350" cy="279400"/>
+            <a:off x="11075070" y="6261100"/>
+            <a:ext cx="354930" cy="355600"/>
           </a:xfrm>
           <a:prstGeom prst="rect">
             <a:avLst/>
@@ -4589,12 +4589,12 @@
         </p:nvSpPr>
         <p:spPr>
           <a:xfrm>
-            <a:off x="9264650" y="6210300"/>
-            <a:ext cx="2317750" cy="457200"/>
+            <a:off x="9678070" y="6172200"/>
+            <a:ext cx="1904330" cy="533400"/>
           </a:xfrm>
           <a:prstGeom prst="roundRect">
             <a:avLst>
-              <a:gd name="adj" fmla="val 25000"/>
+              <a:gd name="adj" fmla="val 21428"/>
             </a:avLst>
           </a:prstGeom>
           <a:solidFill>
@@ -4643,7 +4643,7 @@
         </p:blipFill>
         <p:spPr>
           <a:xfrm>
-            <a:off x="9417050" y="6311900"/>
+            <a:off x="9830470" y="6311900"/>
             <a:ext cx="939800" cy="254000"/>
           </a:xfrm>
           <a:prstGeom prst="rect">
@@ -4659,8 +4659,8 @@
         </p:nvSpPr>
         <p:spPr>
           <a:xfrm>
-            <a:off x="10509250" y="6299200"/>
-            <a:ext cx="12700" cy="279400"/>
+            <a:off x="10922670" y="6261100"/>
+            <a:ext cx="12700" cy="355600"/>
           </a:xfrm>
           <a:prstGeom prst="rect">
             <a:avLst/>
@@ -4697,7 +4697,7 @@
       </p:sp>
       <p:pic>
         <p:nvPicPr>
-          <p:cNvPr id="7" name="Picture 6" descr="logo_jisc_placeholder.png"/>
+          <p:cNvPr id="7" name="Picture 6" descr="logo_jisc.png"/>
           <p:cNvPicPr>
             <a:picLocks noChangeAspect="1"/>
           </p:cNvPicPr>
@@ -4711,8 +4711,8 @@
         </p:blipFill>
         <p:spPr>
           <a:xfrm>
-            <a:off x="10661650" y="6299200"/>
-            <a:ext cx="768350" cy="279400"/>
+            <a:off x="11075070" y="6261100"/>
+            <a:ext cx="354930" cy="355600"/>
           </a:xfrm>
           <a:prstGeom prst="rect">
             <a:avLst/>
@@ -5479,7 +5479,7 @@
         </p:blipFill>
         <p:spPr>
           <a:xfrm>
-            <a:off x="9417050" y="6311900"/>
+            <a:off x="9830470" y="6311900"/>
             <a:ext cx="939800" cy="254000"/>
           </a:xfrm>
           <a:prstGeom prst="rect">
@@ -5495,8 +5495,8 @@
         </p:nvSpPr>
         <p:spPr>
           <a:xfrm>
-            <a:off x="10509250" y="6299200"/>
-            <a:ext cx="12700" cy="279400"/>
+            <a:off x="10922670" y="6261100"/>
+            <a:ext cx="12700" cy="355600"/>
           </a:xfrm>
           <a:prstGeom prst="rect">
             <a:avLst/>
@@ -5533,7 +5533,7 @@
       </p:sp>
       <p:pic>
         <p:nvPicPr>
-          <p:cNvPr id="21" name="Picture 20" descr="logo_jisc_placeholder.png"/>
+          <p:cNvPr id="21" name="Picture 20" descr="logo_jisc.png"/>
           <p:cNvPicPr>
             <a:picLocks noChangeAspect="1"/>
           </p:cNvPicPr>
@@ -5547,8 +5547,8 @@
         </p:blipFill>
         <p:spPr>
           <a:xfrm>
-            <a:off x="10661650" y="6299200"/>
-            <a:ext cx="768350" cy="279400"/>
+            <a:off x="11075070" y="6261100"/>
+            <a:ext cx="354930" cy="355600"/>
           </a:xfrm>
           <a:prstGeom prst="rect">
             <a:avLst/>
@@ -6375,7 +6375,7 @@
         </p:blipFill>
         <p:spPr>
           <a:xfrm>
-            <a:off x="9417050" y="6311900"/>
+            <a:off x="9830470" y="6311900"/>
             <a:ext cx="939800" cy="254000"/>
           </a:xfrm>
           <a:prstGeom prst="rect">
@@ -6391,8 +6391,8 @@
         </p:nvSpPr>
         <p:spPr>
           <a:xfrm>
-            <a:off x="10509250" y="6299200"/>
-            <a:ext cx="12700" cy="279400"/>
+            <a:off x="10922670" y="6261100"/>
+            <a:ext cx="12700" cy="355600"/>
           </a:xfrm>
           <a:prstGeom prst="rect">
             <a:avLst/>
@@ -6429,7 +6429,7 @@
       </p:sp>
       <p:pic>
         <p:nvPicPr>
-          <p:cNvPr id="21" name="Picture 20" descr="logo_jisc_placeholder.png"/>
+          <p:cNvPr id="21" name="Picture 20" descr="logo_jisc.png"/>
           <p:cNvPicPr>
             <a:picLocks noChangeAspect="1"/>
           </p:cNvPicPr>
@@ -6443,8 +6443,8 @@
         </p:blipFill>
         <p:spPr>
           <a:xfrm>
-            <a:off x="10661650" y="6299200"/>
-            <a:ext cx="768350" cy="279400"/>
+            <a:off x="11075070" y="6261100"/>
+            <a:ext cx="354930" cy="355600"/>
           </a:xfrm>
           <a:prstGeom prst="rect">
             <a:avLst/>
@@ -6615,12 +6615,12 @@
         </p:nvSpPr>
         <p:spPr>
           <a:xfrm>
-            <a:off x="9264650" y="6210300"/>
-            <a:ext cx="2317750" cy="457200"/>
+            <a:off x="9678070" y="6172200"/>
+            <a:ext cx="1904330" cy="533400"/>
           </a:xfrm>
           <a:prstGeom prst="roundRect">
             <a:avLst>
-              <a:gd name="adj" fmla="val 25000"/>
+              <a:gd name="adj" fmla="val 21428"/>
             </a:avLst>
           </a:prstGeom>
           <a:solidFill>
@@ -6669,7 +6669,7 @@
         </p:blipFill>
         <p:spPr>
           <a:xfrm>
-            <a:off x="9417050" y="6311900"/>
+            <a:off x="9830470" y="6311900"/>
             <a:ext cx="939800" cy="254000"/>
           </a:xfrm>
           <a:prstGeom prst="rect">
@@ -6685,8 +6685,8 @@
         </p:nvSpPr>
         <p:spPr>
           <a:xfrm>
-            <a:off x="10509250" y="6299200"/>
-            <a:ext cx="12700" cy="279400"/>
+            <a:off x="10922670" y="6261100"/>
+            <a:ext cx="12700" cy="355600"/>
           </a:xfrm>
           <a:prstGeom prst="rect">
             <a:avLst/>
@@ -6723,7 +6723,7 @@
       </p:sp>
       <p:pic>
         <p:nvPicPr>
-          <p:cNvPr id="7" name="Picture 6" descr="logo_jisc_placeholder.png"/>
+          <p:cNvPr id="7" name="Picture 6" descr="logo_jisc.png"/>
           <p:cNvPicPr>
             <a:picLocks noChangeAspect="1"/>
           </p:cNvPicPr>
@@ -6737,8 +6737,8 @@
         </p:blipFill>
         <p:spPr>
           <a:xfrm>
-            <a:off x="10661650" y="6299200"/>
-            <a:ext cx="768350" cy="279400"/>
+            <a:off x="11075070" y="6261100"/>
+            <a:ext cx="354930" cy="355600"/>
           </a:xfrm>
           <a:prstGeom prst="rect">
             <a:avLst/>
@@ -6971,12 +6971,12 @@
         </p:nvSpPr>
         <p:spPr>
           <a:xfrm>
-            <a:off x="9264650" y="6210300"/>
-            <a:ext cx="2317750" cy="457200"/>
+            <a:off x="9678070" y="6172200"/>
+            <a:ext cx="1904330" cy="533400"/>
           </a:xfrm>
           <a:prstGeom prst="roundRect">
             <a:avLst>
-              <a:gd name="adj" fmla="val 25000"/>
+              <a:gd name="adj" fmla="val 21428"/>
             </a:avLst>
           </a:prstGeom>
           <a:solidFill>
@@ -7025,7 +7025,7 @@
         </p:blipFill>
         <p:spPr>
           <a:xfrm>
-            <a:off x="9417050" y="6311900"/>
+            <a:off x="9830470" y="6311900"/>
             <a:ext cx="939800" cy="254000"/>
           </a:xfrm>
           <a:prstGeom prst="rect">
@@ -7041,8 +7041,8 @@
         </p:nvSpPr>
         <p:spPr>
           <a:xfrm>
-            <a:off x="10509250" y="6299200"/>
-            <a:ext cx="12700" cy="279400"/>
+            <a:off x="10922670" y="6261100"/>
+            <a:ext cx="12700" cy="355600"/>
           </a:xfrm>
           <a:prstGeom prst="rect">
             <a:avLst/>
@@ -7079,7 +7079,7 @@
       </p:sp>
       <p:pic>
         <p:nvPicPr>
-          <p:cNvPr id="9" name="Picture 8" descr="logo_jisc_placeholder.png"/>
+          <p:cNvPr id="9" name="Picture 8" descr="logo_jisc.png"/>
           <p:cNvPicPr>
             <a:picLocks noChangeAspect="1"/>
           </p:cNvPicPr>
@@ -7093,8 +7093,8 @@
         </p:blipFill>
         <p:spPr>
           <a:xfrm>
-            <a:off x="10661650" y="6299200"/>
-            <a:ext cx="768350" cy="279400"/>
+            <a:off x="11075070" y="6261100"/>
+            <a:ext cx="354930" cy="355600"/>
           </a:xfrm>
           <a:prstGeom prst="rect">
             <a:avLst/>
@@ -7712,7 +7712,7 @@
         </p:blipFill>
         <p:spPr>
           <a:xfrm>
-            <a:off x="9417050" y="6311900"/>
+            <a:off x="9830470" y="6311900"/>
             <a:ext cx="939800" cy="254000"/>
           </a:xfrm>
           <a:prstGeom prst="rect">
@@ -7728,8 +7728,8 @@
         </p:nvSpPr>
         <p:spPr>
           <a:xfrm>
-            <a:off x="10509250" y="6299200"/>
-            <a:ext cx="12700" cy="279400"/>
+            <a:off x="10922670" y="6261100"/>
+            <a:ext cx="12700" cy="355600"/>
           </a:xfrm>
           <a:prstGeom prst="rect">
             <a:avLst/>
@@ -7766,7 +7766,7 @@
       </p:sp>
       <p:pic>
         <p:nvPicPr>
-          <p:cNvPr id="16" name="Picture 15" descr="logo_jisc_placeholder.png"/>
+          <p:cNvPr id="16" name="Picture 15" descr="logo_jisc.png"/>
           <p:cNvPicPr>
             <a:picLocks noChangeAspect="1"/>
           </p:cNvPicPr>
@@ -7780,8 +7780,8 @@
         </p:blipFill>
         <p:spPr>
           <a:xfrm>
-            <a:off x="10661650" y="6299200"/>
-            <a:ext cx="768350" cy="279400"/>
+            <a:off x="11075070" y="6261100"/>
+            <a:ext cx="354930" cy="355600"/>
           </a:xfrm>
           <a:prstGeom prst="rect">
             <a:avLst/>
@@ -8992,7 +8992,7 @@
         </p:blipFill>
         <p:spPr>
           <a:xfrm>
-            <a:off x="9417050" y="6311900"/>
+            <a:off x="9830470" y="6311900"/>
             <a:ext cx="939800" cy="254000"/>
           </a:xfrm>
           <a:prstGeom prst="rect">
@@ -9008,8 +9008,8 @@
         </p:nvSpPr>
         <p:spPr>
           <a:xfrm>
-            <a:off x="10509250" y="6299200"/>
-            <a:ext cx="12700" cy="279400"/>
+            <a:off x="10922670" y="6261100"/>
+            <a:ext cx="12700" cy="355600"/>
           </a:xfrm>
           <a:prstGeom prst="rect">
             <a:avLst/>
@@ -9046,7 +9046,7 @@
       </p:sp>
       <p:pic>
         <p:nvPicPr>
-          <p:cNvPr id="29" name="Picture 28" descr="logo_jisc_placeholder.png"/>
+          <p:cNvPr id="29" name="Picture 28" descr="logo_jisc.png"/>
           <p:cNvPicPr>
             <a:picLocks noChangeAspect="1"/>
           </p:cNvPicPr>
@@ -9060,8 +9060,8 @@
         </p:blipFill>
         <p:spPr>
           <a:xfrm>
-            <a:off x="10661650" y="6299200"/>
-            <a:ext cx="768350" cy="279400"/>
+            <a:off x="11075070" y="6261100"/>
+            <a:ext cx="354930" cy="355600"/>
           </a:xfrm>
           <a:prstGeom prst="rect">
             <a:avLst/>
@@ -9903,7 +9903,7 @@
         </p:blipFill>
         <p:spPr>
           <a:xfrm>
-            <a:off x="9417050" y="6311900"/>
+            <a:off x="9830470" y="6311900"/>
             <a:ext cx="939800" cy="254000"/>
           </a:xfrm>
           <a:prstGeom prst="rect">
@@ -9919,8 +9919,8 @@
         </p:nvSpPr>
         <p:spPr>
           <a:xfrm>
-            <a:off x="10509250" y="6299200"/>
-            <a:ext cx="12700" cy="279400"/>
+            <a:off x="10922670" y="6261100"/>
+            <a:ext cx="12700" cy="355600"/>
           </a:xfrm>
           <a:prstGeom prst="rect">
             <a:avLst/>
@@ -9957,7 +9957,7 @@
       </p:sp>
       <p:pic>
         <p:nvPicPr>
-          <p:cNvPr id="22" name="Picture 21" descr="logo_jisc_placeholder.png"/>
+          <p:cNvPr id="22" name="Picture 21" descr="logo_jisc.png"/>
           <p:cNvPicPr>
             <a:picLocks noChangeAspect="1"/>
           </p:cNvPicPr>
@@ -9971,8 +9971,8 @@
         </p:blipFill>
         <p:spPr>
           <a:xfrm>
-            <a:off x="10661650" y="6299200"/>
-            <a:ext cx="768350" cy="279400"/>
+            <a:off x="11075070" y="6261100"/>
+            <a:ext cx="354930" cy="355600"/>
           </a:xfrm>
           <a:prstGeom prst="rect">
             <a:avLst/>
@@ -11595,7 +11595,7 @@
         </p:blipFill>
         <p:spPr>
           <a:xfrm>
-            <a:off x="9417050" y="6311900"/>
+            <a:off x="9830470" y="6311900"/>
             <a:ext cx="939800" cy="254000"/>
           </a:xfrm>
           <a:prstGeom prst="rect">
@@ -11611,8 +11611,8 @@
         </p:nvSpPr>
         <p:spPr>
           <a:xfrm>
-            <a:off x="10509250" y="6299200"/>
-            <a:ext cx="12700" cy="279400"/>
+            <a:off x="10922670" y="6261100"/>
+            <a:ext cx="12700" cy="355600"/>
           </a:xfrm>
           <a:prstGeom prst="rect">
             <a:avLst/>
@@ -11649,7 +11649,7 @@
       </p:sp>
       <p:pic>
         <p:nvPicPr>
-          <p:cNvPr id="41" name="Picture 40" descr="logo_jisc_placeholder.png"/>
+          <p:cNvPr id="41" name="Picture 40" descr="logo_jisc.png"/>
           <p:cNvPicPr>
             <a:picLocks noChangeAspect="1"/>
           </p:cNvPicPr>
@@ -11663,8 +11663,8 @@
         </p:blipFill>
         <p:spPr>
           <a:xfrm>
-            <a:off x="10661650" y="6299200"/>
-            <a:ext cx="768350" cy="279400"/>
+            <a:off x="11075070" y="6261100"/>
+            <a:ext cx="354930" cy="355600"/>
           </a:xfrm>
           <a:prstGeom prst="rect">
             <a:avLst/>
@@ -12405,7 +12405,7 @@
         </p:blipFill>
         <p:spPr>
           <a:xfrm>
-            <a:off x="9417050" y="6311900"/>
+            <a:off x="9830470" y="6311900"/>
             <a:ext cx="939800" cy="254000"/>
           </a:xfrm>
           <a:prstGeom prst="rect">
@@ -12421,8 +12421,8 @@
         </p:nvSpPr>
         <p:spPr>
           <a:xfrm>
-            <a:off x="10509250" y="6299200"/>
-            <a:ext cx="12700" cy="279400"/>
+            <a:off x="10922670" y="6261100"/>
+            <a:ext cx="12700" cy="355600"/>
           </a:xfrm>
           <a:prstGeom prst="rect">
             <a:avLst/>
@@ -12459,7 +12459,7 @@
       </p:sp>
       <p:pic>
         <p:nvPicPr>
-          <p:cNvPr id="20" name="Picture 19" descr="logo_jisc_placeholder.png"/>
+          <p:cNvPr id="20" name="Picture 19" descr="logo_jisc.png"/>
           <p:cNvPicPr>
             <a:picLocks noChangeAspect="1"/>
           </p:cNvPicPr>
@@ -12473,8 +12473,8 @@
         </p:blipFill>
         <p:spPr>
           <a:xfrm>
-            <a:off x="10661650" y="6299200"/>
-            <a:ext cx="768350" cy="279400"/>
+            <a:off x="11075070" y="6261100"/>
+            <a:ext cx="354930" cy="355600"/>
           </a:xfrm>
           <a:prstGeom prst="rect">
             <a:avLst/>
@@ -18636,12 +18636,12 @@
         </p:nvSpPr>
         <p:spPr>
           <a:xfrm>
-            <a:off x="9264650" y="6210300"/>
-            <a:ext cx="2317750" cy="457200"/>
+            <a:off x="9678070" y="6172200"/>
+            <a:ext cx="1904330" cy="533400"/>
           </a:xfrm>
           <a:prstGeom prst="roundRect">
             <a:avLst>
-              <a:gd name="adj" fmla="val 25000"/>
+              <a:gd name="adj" fmla="val 21428"/>
             </a:avLst>
           </a:prstGeom>
           <a:solidFill>
@@ -18690,7 +18690,7 @@
         </p:blipFill>
         <p:spPr>
           <a:xfrm>
-            <a:off x="9417050" y="6311900"/>
+            <a:off x="9830470" y="6311900"/>
             <a:ext cx="939800" cy="254000"/>
           </a:xfrm>
           <a:prstGeom prst="rect">
@@ -18706,8 +18706,8 @@
         </p:nvSpPr>
         <p:spPr>
           <a:xfrm>
-            <a:off x="10509250" y="6299200"/>
-            <a:ext cx="12700" cy="279400"/>
+            <a:off x="10922670" y="6261100"/>
+            <a:ext cx="12700" cy="355600"/>
           </a:xfrm>
           <a:prstGeom prst="rect">
             <a:avLst/>
@@ -18744,7 +18744,7 @@
       </p:sp>
       <p:pic>
         <p:nvPicPr>
-          <p:cNvPr id="138" name="Picture 137" descr="logo_jisc_placeholder.png"/>
+          <p:cNvPr id="138" name="Picture 137" descr="logo_jisc.png"/>
           <p:cNvPicPr>
             <a:picLocks noChangeAspect="1"/>
           </p:cNvPicPr>
@@ -18758,8 +18758,8 @@
         </p:blipFill>
         <p:spPr>
           <a:xfrm>
-            <a:off x="10661650" y="6299200"/>
-            <a:ext cx="768350" cy="279400"/>
+            <a:off x="11075070" y="6261100"/>
+            <a:ext cx="354930" cy="355600"/>
           </a:xfrm>
           <a:prstGeom prst="rect">
             <a:avLst/>
@@ -21612,7 +21612,7 @@
         </p:blipFill>
         <p:spPr>
           <a:xfrm>
-            <a:off x="9417050" y="6311900"/>
+            <a:off x="9830470" y="6311900"/>
             <a:ext cx="939800" cy="254000"/>
           </a:xfrm>
           <a:prstGeom prst="rect">
@@ -21628,8 +21628,8 @@
         </p:nvSpPr>
         <p:spPr>
           <a:xfrm>
-            <a:off x="10509250" y="6299200"/>
-            <a:ext cx="12700" cy="279400"/>
+            <a:off x="10922670" y="6261100"/>
+            <a:ext cx="12700" cy="355600"/>
           </a:xfrm>
           <a:prstGeom prst="rect">
             <a:avLst/>
@@ -21666,7 +21666,7 @@
       </p:sp>
       <p:pic>
         <p:nvPicPr>
-          <p:cNvPr id="65" name="Picture 64" descr="logo_jisc_placeholder.png"/>
+          <p:cNvPr id="65" name="Picture 64" descr="logo_jisc.png"/>
           <p:cNvPicPr>
             <a:picLocks noChangeAspect="1"/>
           </p:cNvPicPr>
@@ -21680,8 +21680,8 @@
         </p:blipFill>
         <p:spPr>
           <a:xfrm>
-            <a:off x="10661650" y="6299200"/>
-            <a:ext cx="768350" cy="279400"/>
+            <a:off x="11075070" y="6261100"/>
+            <a:ext cx="354930" cy="355600"/>
           </a:xfrm>
           <a:prstGeom prst="rect">
             <a:avLst/>
@@ -22270,7 +22270,7 @@
         </p:blipFill>
         <p:spPr>
           <a:xfrm>
-            <a:off x="9417050" y="6311900"/>
+            <a:off x="9830470" y="6311900"/>
             <a:ext cx="939800" cy="254000"/>
           </a:xfrm>
           <a:prstGeom prst="rect">
@@ -22286,8 +22286,8 @@
         </p:nvSpPr>
         <p:spPr>
           <a:xfrm>
-            <a:off x="10509250" y="6299200"/>
-            <a:ext cx="12700" cy="279400"/>
+            <a:off x="10922670" y="6261100"/>
+            <a:ext cx="12700" cy="355600"/>
           </a:xfrm>
           <a:prstGeom prst="rect">
             <a:avLst/>
@@ -22324,7 +22324,7 @@
       </p:sp>
       <p:pic>
         <p:nvPicPr>
-          <p:cNvPr id="15" name="Picture 14" descr="logo_jisc_placeholder.png"/>
+          <p:cNvPr id="15" name="Picture 14" descr="logo_jisc.png"/>
           <p:cNvPicPr>
             <a:picLocks noChangeAspect="1"/>
           </p:cNvPicPr>
@@ -22338,8 +22338,8 @@
         </p:blipFill>
         <p:spPr>
           <a:xfrm>
-            <a:off x="10661650" y="6299200"/>
-            <a:ext cx="768350" cy="279400"/>
+            <a:off x="11075070" y="6261100"/>
+            <a:ext cx="354930" cy="355600"/>
           </a:xfrm>
           <a:prstGeom prst="rect">
             <a:avLst/>
@@ -23963,7 +23963,7 @@
         </p:blipFill>
         <p:spPr>
           <a:xfrm>
-            <a:off x="9417050" y="6311900"/>
+            <a:off x="9830470" y="6311900"/>
             <a:ext cx="939800" cy="254000"/>
           </a:xfrm>
           <a:prstGeom prst="rect">
@@ -23979,8 +23979,8 @@
         </p:nvSpPr>
         <p:spPr>
           <a:xfrm>
-            <a:off x="10509250" y="6299200"/>
-            <a:ext cx="12700" cy="279400"/>
+            <a:off x="10922670" y="6261100"/>
+            <a:ext cx="12700" cy="355600"/>
           </a:xfrm>
           <a:prstGeom prst="rect">
             <a:avLst/>
@@ -24017,7 +24017,7 @@
       </p:sp>
       <p:pic>
         <p:nvPicPr>
-          <p:cNvPr id="38" name="Picture 37" descr="logo_jisc_placeholder.png"/>
+          <p:cNvPr id="38" name="Picture 37" descr="logo_jisc.png"/>
           <p:cNvPicPr>
             <a:picLocks noChangeAspect="1"/>
           </p:cNvPicPr>
@@ -24031,8 +24031,8 @@
         </p:blipFill>
         <p:spPr>
           <a:xfrm>
-            <a:off x="10661650" y="6299200"/>
-            <a:ext cx="768350" cy="279400"/>
+            <a:off x="11075070" y="6261100"/>
+            <a:ext cx="354930" cy="355600"/>
           </a:xfrm>
           <a:prstGeom prst="rect">
             <a:avLst/>
@@ -24265,12 +24265,12 @@
         </p:nvSpPr>
         <p:spPr>
           <a:xfrm>
-            <a:off x="9264650" y="6210300"/>
-            <a:ext cx="2317750" cy="457200"/>
+            <a:off x="9678070" y="6172200"/>
+            <a:ext cx="1904330" cy="533400"/>
           </a:xfrm>
           <a:prstGeom prst="roundRect">
             <a:avLst>
-              <a:gd name="adj" fmla="val 25000"/>
+              <a:gd name="adj" fmla="val 21428"/>
             </a:avLst>
           </a:prstGeom>
           <a:solidFill>
@@ -24319,7 +24319,7 @@
         </p:blipFill>
         <p:spPr>
           <a:xfrm>
-            <a:off x="9417050" y="6311900"/>
+            <a:off x="9830470" y="6311900"/>
             <a:ext cx="939800" cy="254000"/>
           </a:xfrm>
           <a:prstGeom prst="rect">
@@ -24335,8 +24335,8 @@
         </p:nvSpPr>
         <p:spPr>
           <a:xfrm>
-            <a:off x="10509250" y="6299200"/>
-            <a:ext cx="12700" cy="279400"/>
+            <a:off x="10922670" y="6261100"/>
+            <a:ext cx="12700" cy="355600"/>
           </a:xfrm>
           <a:prstGeom prst="rect">
             <a:avLst/>
@@ -24373,7 +24373,7 @@
       </p:sp>
       <p:pic>
         <p:nvPicPr>
-          <p:cNvPr id="9" name="Picture 8" descr="logo_jisc_placeholder.png"/>
+          <p:cNvPr id="9" name="Picture 8" descr="logo_jisc.png"/>
           <p:cNvPicPr>
             <a:picLocks noChangeAspect="1"/>
           </p:cNvPicPr>
@@ -24387,8 +24387,8 @@
         </p:blipFill>
         <p:spPr>
           <a:xfrm>
-            <a:off x="10661650" y="6299200"/>
-            <a:ext cx="768350" cy="279400"/>
+            <a:off x="11075070" y="6261100"/>
+            <a:ext cx="354930" cy="355600"/>
           </a:xfrm>
           <a:prstGeom prst="rect">
             <a:avLst/>
@@ -25122,7 +25122,7 @@
         </p:blipFill>
         <p:spPr>
           <a:xfrm>
-            <a:off x="9417050" y="6311900"/>
+            <a:off x="9830470" y="6311900"/>
             <a:ext cx="939800" cy="254000"/>
           </a:xfrm>
           <a:prstGeom prst="rect">
@@ -25138,8 +25138,8 @@
         </p:nvSpPr>
         <p:spPr>
           <a:xfrm>
-            <a:off x="10509250" y="6299200"/>
-            <a:ext cx="12700" cy="279400"/>
+            <a:off x="10922670" y="6261100"/>
+            <a:ext cx="12700" cy="355600"/>
           </a:xfrm>
           <a:prstGeom prst="rect">
             <a:avLst/>
@@ -25176,7 +25176,7 @@
       </p:sp>
       <p:pic>
         <p:nvPicPr>
-          <p:cNvPr id="20" name="Picture 19" descr="logo_jisc_placeholder.png"/>
+          <p:cNvPr id="20" name="Picture 19" descr="logo_jisc.png"/>
           <p:cNvPicPr>
             <a:picLocks noChangeAspect="1"/>
           </p:cNvPicPr>
@@ -25190,8 +25190,8 @@
         </p:blipFill>
         <p:spPr>
           <a:xfrm>
-            <a:off x="10661650" y="6299200"/>
-            <a:ext cx="768350" cy="279400"/>
+            <a:off x="11075070" y="6261100"/>
+            <a:ext cx="354930" cy="355600"/>
           </a:xfrm>
           <a:prstGeom prst="rect">
             <a:avLst/>
@@ -25691,7 +25691,7 @@
         </p:blipFill>
         <p:spPr>
           <a:xfrm>
-            <a:off x="9417050" y="6311900"/>
+            <a:off x="9830470" y="6311900"/>
             <a:ext cx="939800" cy="254000"/>
           </a:xfrm>
           <a:prstGeom prst="rect">
@@ -25707,8 +25707,8 @@
         </p:nvSpPr>
         <p:spPr>
           <a:xfrm>
-            <a:off x="10509250" y="6299200"/>
-            <a:ext cx="12700" cy="279400"/>
+            <a:off x="10922670" y="6261100"/>
+            <a:ext cx="12700" cy="355600"/>
           </a:xfrm>
           <a:prstGeom prst="rect">
             <a:avLst/>
@@ -25745,7 +25745,7 @@
       </p:sp>
       <p:pic>
         <p:nvPicPr>
-          <p:cNvPr id="14" name="Picture 13" descr="logo_jisc_placeholder.png"/>
+          <p:cNvPr id="14" name="Picture 13" descr="logo_jisc.png"/>
           <p:cNvPicPr>
             <a:picLocks noChangeAspect="1"/>
           </p:cNvPicPr>
@@ -25759,8 +25759,8 @@
         </p:blipFill>
         <p:spPr>
           <a:xfrm>
-            <a:off x="10661650" y="6299200"/>
-            <a:ext cx="768350" cy="279400"/>
+            <a:off x="11075070" y="6261100"/>
+            <a:ext cx="354930" cy="355600"/>
           </a:xfrm>
           <a:prstGeom prst="rect">
             <a:avLst/>
@@ -26541,7 +26541,7 @@
         </p:blipFill>
         <p:spPr>
           <a:xfrm>
-            <a:off x="9417050" y="6311900"/>
+            <a:off x="9830470" y="6311900"/>
             <a:ext cx="939800" cy="254000"/>
           </a:xfrm>
           <a:prstGeom prst="rect">
@@ -26557,8 +26557,8 @@
         </p:nvSpPr>
         <p:spPr>
           <a:xfrm>
-            <a:off x="10509250" y="6299200"/>
-            <a:ext cx="12700" cy="279400"/>
+            <a:off x="10922670" y="6261100"/>
+            <a:ext cx="12700" cy="355600"/>
           </a:xfrm>
           <a:prstGeom prst="rect">
             <a:avLst/>
@@ -26595,7 +26595,7 @@
       </p:sp>
       <p:pic>
         <p:nvPicPr>
-          <p:cNvPr id="23" name="Picture 22" descr="logo_jisc_placeholder.png"/>
+          <p:cNvPr id="23" name="Picture 22" descr="logo_jisc.png"/>
           <p:cNvPicPr>
             <a:picLocks noChangeAspect="1"/>
           </p:cNvPicPr>
@@ -26609,8 +26609,8 @@
         </p:blipFill>
         <p:spPr>
           <a:xfrm>
-            <a:off x="10661650" y="6299200"/>
-            <a:ext cx="768350" cy="279400"/>
+            <a:off x="11075070" y="6261100"/>
+            <a:ext cx="354930" cy="355600"/>
           </a:xfrm>
           <a:prstGeom prst="rect">
             <a:avLst/>
@@ -27440,7 +27440,7 @@
         </p:blipFill>
         <p:spPr>
           <a:xfrm>
-            <a:off x="9417050" y="6311900"/>
+            <a:off x="9830470" y="6311900"/>
             <a:ext cx="939800" cy="254000"/>
           </a:xfrm>
           <a:prstGeom prst="rect">
@@ -27456,8 +27456,8 @@
         </p:nvSpPr>
         <p:spPr>
           <a:xfrm>
-            <a:off x="10509250" y="6299200"/>
-            <a:ext cx="12700" cy="279400"/>
+            <a:off x="10922670" y="6261100"/>
+            <a:ext cx="12700" cy="355600"/>
           </a:xfrm>
           <a:prstGeom prst="rect">
             <a:avLst/>
@@ -27494,7 +27494,7 @@
       </p:sp>
       <p:pic>
         <p:nvPicPr>
-          <p:cNvPr id="22" name="Picture 21" descr="logo_jisc_placeholder.png"/>
+          <p:cNvPr id="22" name="Picture 21" descr="logo_jisc.png"/>
           <p:cNvPicPr>
             <a:picLocks noChangeAspect="1"/>
           </p:cNvPicPr>
@@ -27508,8 +27508,8 @@
         </p:blipFill>
         <p:spPr>
           <a:xfrm>
-            <a:off x="10661650" y="6299200"/>
-            <a:ext cx="768350" cy="279400"/>
+            <a:off x="11075070" y="6261100"/>
+            <a:ext cx="354930" cy="355600"/>
           </a:xfrm>
           <a:prstGeom prst="rect">
             <a:avLst/>
@@ -28126,7 +28126,7 @@
         </p:blipFill>
         <p:spPr>
           <a:xfrm>
-            <a:off x="9417050" y="6311900"/>
+            <a:off x="9830470" y="6311900"/>
             <a:ext cx="939800" cy="254000"/>
           </a:xfrm>
           <a:prstGeom prst="rect">
@@ -28142,8 +28142,8 @@
         </p:nvSpPr>
         <p:spPr>
           <a:xfrm>
-            <a:off x="10509250" y="6299200"/>
-            <a:ext cx="12700" cy="279400"/>
+            <a:off x="10922670" y="6261100"/>
+            <a:ext cx="12700" cy="355600"/>
           </a:xfrm>
           <a:prstGeom prst="rect">
             <a:avLst/>
@@ -28180,7 +28180,7 @@
       </p:sp>
       <p:pic>
         <p:nvPicPr>
-          <p:cNvPr id="16" name="Picture 15" descr="logo_jisc_placeholder.png"/>
+          <p:cNvPr id="16" name="Picture 15" descr="logo_jisc.png"/>
           <p:cNvPicPr>
             <a:picLocks noChangeAspect="1"/>
           </p:cNvPicPr>
@@ -28194,8 +28194,8 @@
         </p:blipFill>
         <p:spPr>
           <a:xfrm>
-            <a:off x="10661650" y="6299200"/>
-            <a:ext cx="768350" cy="279400"/>
+            <a:off x="11075070" y="6261100"/>
+            <a:ext cx="354930" cy="355600"/>
           </a:xfrm>
           <a:prstGeom prst="rect">
             <a:avLst/>
@@ -28568,12 +28568,12 @@
         </p:nvSpPr>
         <p:spPr>
           <a:xfrm>
-            <a:off x="9264650" y="6210300"/>
-            <a:ext cx="2317750" cy="457200"/>
+            <a:off x="9678070" y="6172200"/>
+            <a:ext cx="1904330" cy="533400"/>
           </a:xfrm>
           <a:prstGeom prst="roundRect">
             <a:avLst>
-              <a:gd name="adj" fmla="val 25000"/>
+              <a:gd name="adj" fmla="val 21428"/>
             </a:avLst>
           </a:prstGeom>
           <a:solidFill>
@@ -28622,7 +28622,7 @@
         </p:blipFill>
         <p:spPr>
           <a:xfrm>
-            <a:off x="9417050" y="6311900"/>
+            <a:off x="9830470" y="6311900"/>
             <a:ext cx="939800" cy="254000"/>
           </a:xfrm>
           <a:prstGeom prst="rect">
@@ -28638,8 +28638,8 @@
         </p:nvSpPr>
         <p:spPr>
           <a:xfrm>
-            <a:off x="10509250" y="6299200"/>
-            <a:ext cx="12700" cy="279400"/>
+            <a:off x="10922670" y="6261100"/>
+            <a:ext cx="12700" cy="355600"/>
           </a:xfrm>
           <a:prstGeom prst="rect">
             <a:avLst/>
@@ -28676,7 +28676,7 @@
       </p:sp>
       <p:pic>
         <p:nvPicPr>
-          <p:cNvPr id="12" name="Picture 11" descr="logo_jisc_placeholder.png"/>
+          <p:cNvPr id="12" name="Picture 11" descr="logo_jisc.png"/>
           <p:cNvPicPr>
             <a:picLocks noChangeAspect="1"/>
           </p:cNvPicPr>
@@ -28690,8 +28690,8 @@
         </p:blipFill>
         <p:spPr>
           <a:xfrm>
-            <a:off x="10661650" y="6299200"/>
-            <a:ext cx="768350" cy="279400"/>
+            <a:off x="11075070" y="6261100"/>
+            <a:ext cx="354930" cy="355600"/>
           </a:xfrm>
           <a:prstGeom prst="rect">
             <a:avLst/>
@@ -29322,7 +29322,7 @@
         </p:blipFill>
         <p:spPr>
           <a:xfrm>
-            <a:off x="9417050" y="6311900"/>
+            <a:off x="9830470" y="6311900"/>
             <a:ext cx="939800" cy="254000"/>
           </a:xfrm>
           <a:prstGeom prst="rect">
@@ -29338,8 +29338,8 @@
         </p:nvSpPr>
         <p:spPr>
           <a:xfrm>
-            <a:off x="10509250" y="6299200"/>
-            <a:ext cx="12700" cy="279400"/>
+            <a:off x="10922670" y="6261100"/>
+            <a:ext cx="12700" cy="355600"/>
           </a:xfrm>
           <a:prstGeom prst="rect">
             <a:avLst/>
@@ -29376,7 +29376,7 @@
       </p:sp>
       <p:pic>
         <p:nvPicPr>
-          <p:cNvPr id="17" name="Picture 16" descr="logo_jisc_placeholder.png"/>
+          <p:cNvPr id="17" name="Picture 16" descr="logo_jisc.png"/>
           <p:cNvPicPr>
             <a:picLocks noChangeAspect="1"/>
           </p:cNvPicPr>
@@ -29390,8 +29390,8 @@
         </p:blipFill>
         <p:spPr>
           <a:xfrm>
-            <a:off x="10661650" y="6299200"/>
-            <a:ext cx="768350" cy="279400"/>
+            <a:off x="11075070" y="6261100"/>
+            <a:ext cx="354930" cy="355600"/>
           </a:xfrm>
           <a:prstGeom prst="rect">
             <a:avLst/>
@@ -29601,12 +29601,12 @@
         </p:nvSpPr>
         <p:spPr>
           <a:xfrm>
-            <a:off x="9264650" y="6210300"/>
-            <a:ext cx="2317750" cy="457200"/>
+            <a:off x="9678070" y="6172200"/>
+            <a:ext cx="1904330" cy="533400"/>
           </a:xfrm>
           <a:prstGeom prst="roundRect">
             <a:avLst>
-              <a:gd name="adj" fmla="val 25000"/>
+              <a:gd name="adj" fmla="val 21428"/>
             </a:avLst>
           </a:prstGeom>
           <a:solidFill>
@@ -29655,7 +29655,7 @@
         </p:blipFill>
         <p:spPr>
           <a:xfrm>
-            <a:off x="9417050" y="6311900"/>
+            <a:off x="9830470" y="6311900"/>
             <a:ext cx="939800" cy="254000"/>
           </a:xfrm>
           <a:prstGeom prst="rect">
@@ -29671,8 +29671,8 @@
         </p:nvSpPr>
         <p:spPr>
           <a:xfrm>
-            <a:off x="10509250" y="6299200"/>
-            <a:ext cx="12700" cy="279400"/>
+            <a:off x="10922670" y="6261100"/>
+            <a:ext cx="12700" cy="355600"/>
           </a:xfrm>
           <a:prstGeom prst="rect">
             <a:avLst/>
@@ -29709,7 +29709,7 @@
       </p:sp>
       <p:pic>
         <p:nvPicPr>
-          <p:cNvPr id="8" name="Picture 7" descr="logo_jisc_placeholder.png"/>
+          <p:cNvPr id="8" name="Picture 7" descr="logo_jisc.png"/>
           <p:cNvPicPr>
             <a:picLocks noChangeAspect="1"/>
           </p:cNvPicPr>
@@ -29723,8 +29723,8 @@
         </p:blipFill>
         <p:spPr>
           <a:xfrm>
-            <a:off x="10661650" y="6299200"/>
-            <a:ext cx="768350" cy="279400"/>
+            <a:off x="11075070" y="6261100"/>
+            <a:ext cx="354930" cy="355600"/>
           </a:xfrm>
           <a:prstGeom prst="rect">
             <a:avLst/>
@@ -30296,7 +30296,7 @@
         </p:blipFill>
         <p:spPr>
           <a:xfrm>
-            <a:off x="9417050" y="6311900"/>
+            <a:off x="9830470" y="6311900"/>
             <a:ext cx="939800" cy="254000"/>
           </a:xfrm>
           <a:prstGeom prst="rect">
@@ -30312,8 +30312,8 @@
         </p:nvSpPr>
         <p:spPr>
           <a:xfrm>
-            <a:off x="10509250" y="6299200"/>
-            <a:ext cx="12700" cy="279400"/>
+            <a:off x="10922670" y="6261100"/>
+            <a:ext cx="12700" cy="355600"/>
           </a:xfrm>
           <a:prstGeom prst="rect">
             <a:avLst/>
@@ -30350,7 +30350,7 @@
       </p:sp>
       <p:pic>
         <p:nvPicPr>
-          <p:cNvPr id="16" name="Picture 15" descr="logo_jisc_placeholder.png"/>
+          <p:cNvPr id="16" name="Picture 15" descr="logo_jisc.png"/>
           <p:cNvPicPr>
             <a:picLocks noChangeAspect="1"/>
           </p:cNvPicPr>
@@ -30364,8 +30364,8 @@
         </p:blipFill>
         <p:spPr>
           <a:xfrm>
-            <a:off x="10661650" y="6299200"/>
-            <a:ext cx="768350" cy="279400"/>
+            <a:off x="11075070" y="6261100"/>
+            <a:ext cx="354930" cy="355600"/>
           </a:xfrm>
           <a:prstGeom prst="rect">
             <a:avLst/>
@@ -30858,7 +30858,7 @@
         </p:blipFill>
         <p:spPr>
           <a:xfrm>
-            <a:off x="9417050" y="6311900"/>
+            <a:off x="9830470" y="6311900"/>
             <a:ext cx="939800" cy="254000"/>
           </a:xfrm>
           <a:prstGeom prst="rect">
@@ -30874,8 +30874,8 @@
         </p:nvSpPr>
         <p:spPr>
           <a:xfrm>
-            <a:off x="10509250" y="6299200"/>
-            <a:ext cx="12700" cy="279400"/>
+            <a:off x="10922670" y="6261100"/>
+            <a:ext cx="12700" cy="355600"/>
           </a:xfrm>
           <a:prstGeom prst="rect">
             <a:avLst/>
@@ -30912,7 +30912,7 @@
       </p:sp>
       <p:pic>
         <p:nvPicPr>
-          <p:cNvPr id="15" name="Picture 14" descr="logo_jisc_placeholder.png"/>
+          <p:cNvPr id="15" name="Picture 14" descr="logo_jisc.png"/>
           <p:cNvPicPr>
             <a:picLocks noChangeAspect="1"/>
           </p:cNvPicPr>
@@ -30926,8 +30926,8 @@
         </p:blipFill>
         <p:spPr>
           <a:xfrm>
-            <a:off x="10661650" y="6299200"/>
-            <a:ext cx="768350" cy="279400"/>
+            <a:off x="11075070" y="6261100"/>
+            <a:ext cx="354930" cy="355600"/>
           </a:xfrm>
           <a:prstGeom prst="rect">
             <a:avLst/>
@@ -31967,7 +31967,7 @@
         </p:blipFill>
         <p:spPr>
           <a:xfrm>
-            <a:off x="9417050" y="6311900"/>
+            <a:off x="9830470" y="6311900"/>
             <a:ext cx="939800" cy="254000"/>
           </a:xfrm>
           <a:prstGeom prst="rect">
@@ -31983,8 +31983,8 @@
         </p:nvSpPr>
         <p:spPr>
           <a:xfrm>
-            <a:off x="10509250" y="6299200"/>
-            <a:ext cx="12700" cy="279400"/>
+            <a:off x="10922670" y="6261100"/>
+            <a:ext cx="12700" cy="355600"/>
           </a:xfrm>
           <a:prstGeom prst="rect">
             <a:avLst/>
@@ -32021,7 +32021,7 @@
       </p:sp>
       <p:pic>
         <p:nvPicPr>
-          <p:cNvPr id="27" name="Picture 26" descr="logo_jisc_placeholder.png"/>
+          <p:cNvPr id="27" name="Picture 26" descr="logo_jisc.png"/>
           <p:cNvPicPr>
             <a:picLocks noChangeAspect="1"/>
           </p:cNvPicPr>
@@ -32035,8 +32035,8 @@
         </p:blipFill>
         <p:spPr>
           <a:xfrm>
-            <a:off x="10661650" y="6299200"/>
-            <a:ext cx="768350" cy="279400"/>
+            <a:off x="11075070" y="6261100"/>
+            <a:ext cx="354930" cy="355600"/>
           </a:xfrm>
           <a:prstGeom prst="rect">
             <a:avLst/>
@@ -33076,7 +33076,7 @@
         </p:blipFill>
         <p:spPr>
           <a:xfrm>
-            <a:off x="9417050" y="6311900"/>
+            <a:off x="9830470" y="6311900"/>
             <a:ext cx="939800" cy="254000"/>
           </a:xfrm>
           <a:prstGeom prst="rect">
@@ -33092,8 +33092,8 @@
         </p:nvSpPr>
         <p:spPr>
           <a:xfrm>
-            <a:off x="10509250" y="6299200"/>
-            <a:ext cx="12700" cy="279400"/>
+            <a:off x="10922670" y="6261100"/>
+            <a:ext cx="12700" cy="355600"/>
           </a:xfrm>
           <a:prstGeom prst="rect">
             <a:avLst/>
@@ -33130,7 +33130,7 @@
       </p:sp>
       <p:pic>
         <p:nvPicPr>
-          <p:cNvPr id="27" name="Picture 26" descr="logo_jisc_placeholder.png"/>
+          <p:cNvPr id="27" name="Picture 26" descr="logo_jisc.png"/>
           <p:cNvPicPr>
             <a:picLocks noChangeAspect="1"/>
           </p:cNvPicPr>
@@ -33144,8 +33144,8 @@
         </p:blipFill>
         <p:spPr>
           <a:xfrm>
-            <a:off x="10661650" y="6299200"/>
-            <a:ext cx="768350" cy="279400"/>
+            <a:off x="11075070" y="6261100"/>
+            <a:ext cx="354930" cy="355600"/>
           </a:xfrm>
           <a:prstGeom prst="rect">
             <a:avLst/>
@@ -33737,7 +33737,7 @@
         </p:blipFill>
         <p:spPr>
           <a:xfrm>
-            <a:off x="9417050" y="6311900"/>
+            <a:off x="9830470" y="6311900"/>
             <a:ext cx="939800" cy="254000"/>
           </a:xfrm>
           <a:prstGeom prst="rect">
@@ -33753,8 +33753,8 @@
         </p:nvSpPr>
         <p:spPr>
           <a:xfrm>
-            <a:off x="10509250" y="6299200"/>
-            <a:ext cx="12700" cy="279400"/>
+            <a:off x="10922670" y="6261100"/>
+            <a:ext cx="12700" cy="355600"/>
           </a:xfrm>
           <a:prstGeom prst="rect">
             <a:avLst/>
@@ -33791,7 +33791,7 @@
       </p:sp>
       <p:pic>
         <p:nvPicPr>
-          <p:cNvPr id="16" name="Picture 15" descr="logo_jisc_placeholder.png"/>
+          <p:cNvPr id="16" name="Picture 15" descr="logo_jisc.png"/>
           <p:cNvPicPr>
             <a:picLocks noChangeAspect="1"/>
           </p:cNvPicPr>
@@ -33805,8 +33805,8 @@
         </p:blipFill>
         <p:spPr>
           <a:xfrm>
-            <a:off x="10661650" y="6299200"/>
-            <a:ext cx="768350" cy="279400"/>
+            <a:off x="11075070" y="6261100"/>
+            <a:ext cx="354930" cy="355600"/>
           </a:xfrm>
           <a:prstGeom prst="rect">
             <a:avLst/>
@@ -34055,12 +34055,12 @@
         </p:nvSpPr>
         <p:spPr>
           <a:xfrm>
-            <a:off x="9264650" y="6210300"/>
-            <a:ext cx="2317750" cy="457200"/>
+            <a:off x="9678070" y="6172200"/>
+            <a:ext cx="1904330" cy="533400"/>
           </a:xfrm>
           <a:prstGeom prst="roundRect">
             <a:avLst>
-              <a:gd name="adj" fmla="val 25000"/>
+              <a:gd name="adj" fmla="val 21428"/>
             </a:avLst>
           </a:prstGeom>
           <a:solidFill>
@@ -34109,7 +34109,7 @@
         </p:blipFill>
         <p:spPr>
           <a:xfrm>
-            <a:off x="9417050" y="6311900"/>
+            <a:off x="9830470" y="6311900"/>
             <a:ext cx="939800" cy="254000"/>
           </a:xfrm>
           <a:prstGeom prst="rect">
@@ -34125,8 +34125,8 @@
         </p:nvSpPr>
         <p:spPr>
           <a:xfrm>
-            <a:off x="10509250" y="6299200"/>
-            <a:ext cx="12700" cy="279400"/>
+            <a:off x="10922670" y="6261100"/>
+            <a:ext cx="12700" cy="355600"/>
           </a:xfrm>
           <a:prstGeom prst="rect">
             <a:avLst/>
@@ -34163,7 +34163,7 @@
       </p:sp>
       <p:pic>
         <p:nvPicPr>
-          <p:cNvPr id="9" name="Picture 8" descr="logo_jisc_placeholder.png"/>
+          <p:cNvPr id="9" name="Picture 8" descr="logo_jisc.png"/>
           <p:cNvPicPr>
             <a:picLocks noChangeAspect="1"/>
           </p:cNvPicPr>
@@ -34177,8 +34177,8 @@
         </p:blipFill>
         <p:spPr>
           <a:xfrm>
-            <a:off x="10661650" y="6299200"/>
-            <a:ext cx="768350" cy="279400"/>
+            <a:off x="11075070" y="6261100"/>
+            <a:ext cx="354930" cy="355600"/>
           </a:xfrm>
           <a:prstGeom prst="rect">
             <a:avLst/>
@@ -34527,7 +34527,7 @@
         </p:blipFill>
         <p:spPr>
           <a:xfrm>
-            <a:off x="9417050" y="6311900"/>
+            <a:off x="9830470" y="6311900"/>
             <a:ext cx="939800" cy="254000"/>
           </a:xfrm>
           <a:prstGeom prst="rect">
@@ -34543,8 +34543,8 @@
         </p:nvSpPr>
         <p:spPr>
           <a:xfrm>
-            <a:off x="10509250" y="6299200"/>
-            <a:ext cx="12700" cy="279400"/>
+            <a:off x="10922670" y="6261100"/>
+            <a:ext cx="12700" cy="355600"/>
           </a:xfrm>
           <a:prstGeom prst="rect">
             <a:avLst/>
@@ -34581,7 +34581,7 @@
       </p:sp>
       <p:pic>
         <p:nvPicPr>
-          <p:cNvPr id="11" name="Picture 10" descr="logo_jisc_placeholder.png"/>
+          <p:cNvPr id="11" name="Picture 10" descr="logo_jisc.png"/>
           <p:cNvPicPr>
             <a:picLocks noChangeAspect="1"/>
           </p:cNvPicPr>
@@ -34595,8 +34595,8 @@
         </p:blipFill>
         <p:spPr>
           <a:xfrm>
-            <a:off x="10661650" y="6299200"/>
-            <a:ext cx="768350" cy="279400"/>
+            <a:off x="11075070" y="6261100"/>
+            <a:ext cx="354930" cy="355600"/>
           </a:xfrm>
           <a:prstGeom prst="rect">
             <a:avLst/>
@@ -34984,7 +34984,7 @@
         </p:blipFill>
         <p:spPr>
           <a:xfrm>
-            <a:off x="9417050" y="6311900"/>
+            <a:off x="9830470" y="6311900"/>
             <a:ext cx="939800" cy="254000"/>
           </a:xfrm>
           <a:prstGeom prst="rect">
@@ -35000,8 +35000,8 @@
         </p:nvSpPr>
         <p:spPr>
           <a:xfrm>
-            <a:off x="10509250" y="6299200"/>
-            <a:ext cx="12700" cy="279400"/>
+            <a:off x="10922670" y="6261100"/>
+            <a:ext cx="12700" cy="355600"/>
           </a:xfrm>
           <a:prstGeom prst="rect">
             <a:avLst/>
@@ -35038,7 +35038,7 @@
       </p:sp>
       <p:pic>
         <p:nvPicPr>
-          <p:cNvPr id="11" name="Picture 10" descr="logo_jisc_placeholder.png"/>
+          <p:cNvPr id="11" name="Picture 10" descr="logo_jisc.png"/>
           <p:cNvPicPr>
             <a:picLocks noChangeAspect="1"/>
           </p:cNvPicPr>
@@ -35052,8 +35052,8 @@
         </p:blipFill>
         <p:spPr>
           <a:xfrm>
-            <a:off x="10661650" y="6299200"/>
-            <a:ext cx="768350" cy="279400"/>
+            <a:off x="11075070" y="6261100"/>
+            <a:ext cx="354930" cy="355600"/>
           </a:xfrm>
           <a:prstGeom prst="rect">
             <a:avLst/>
@@ -35507,7 +35507,7 @@
         </p:blipFill>
         <p:spPr>
           <a:xfrm>
-            <a:off x="9417050" y="6311900"/>
+            <a:off x="9830470" y="6311900"/>
             <a:ext cx="939800" cy="254000"/>
           </a:xfrm>
           <a:prstGeom prst="rect">
@@ -35523,8 +35523,8 @@
         </p:nvSpPr>
         <p:spPr>
           <a:xfrm>
-            <a:off x="10509250" y="6299200"/>
-            <a:ext cx="12700" cy="279400"/>
+            <a:off x="10922670" y="6261100"/>
+            <a:ext cx="12700" cy="355600"/>
           </a:xfrm>
           <a:prstGeom prst="rect">
             <a:avLst/>
@@ -35561,7 +35561,7 @@
       </p:sp>
       <p:pic>
         <p:nvPicPr>
-          <p:cNvPr id="13" name="Picture 12" descr="logo_jisc_placeholder.png"/>
+          <p:cNvPr id="13" name="Picture 12" descr="logo_jisc.png"/>
           <p:cNvPicPr>
             <a:picLocks noChangeAspect="1"/>
           </p:cNvPicPr>
@@ -35575,8 +35575,8 @@
         </p:blipFill>
         <p:spPr>
           <a:xfrm>
-            <a:off x="10661650" y="6299200"/>
-            <a:ext cx="768350" cy="279400"/>
+            <a:off x="11075070" y="6261100"/>
+            <a:ext cx="354930" cy="355600"/>
           </a:xfrm>
           <a:prstGeom prst="rect">
             <a:avLst/>
@@ -35964,7 +35964,7 @@
         </p:blipFill>
         <p:spPr>
           <a:xfrm>
-            <a:off x="9417050" y="6311900"/>
+            <a:off x="9830470" y="6311900"/>
             <a:ext cx="939800" cy="254000"/>
           </a:xfrm>
           <a:prstGeom prst="rect">
@@ -35980,8 +35980,8 @@
         </p:nvSpPr>
         <p:spPr>
           <a:xfrm>
-            <a:off x="10509250" y="6299200"/>
-            <a:ext cx="12700" cy="279400"/>
+            <a:off x="10922670" y="6261100"/>
+            <a:ext cx="12700" cy="355600"/>
           </a:xfrm>
           <a:prstGeom prst="rect">
             <a:avLst/>
@@ -36018,7 +36018,7 @@
       </p:sp>
       <p:pic>
         <p:nvPicPr>
-          <p:cNvPr id="11" name="Picture 10" descr="logo_jisc_placeholder.png"/>
+          <p:cNvPr id="11" name="Picture 10" descr="logo_jisc.png"/>
           <p:cNvPicPr>
             <a:picLocks noChangeAspect="1"/>
           </p:cNvPicPr>
@@ -36032,8 +36032,8 @@
         </p:blipFill>
         <p:spPr>
           <a:xfrm>
-            <a:off x="10661650" y="6299200"/>
-            <a:ext cx="768350" cy="279400"/>
+            <a:off x="11075070" y="6261100"/>
+            <a:ext cx="354930" cy="355600"/>
           </a:xfrm>
           <a:prstGeom prst="rect">
             <a:avLst/>
@@ -36421,7 +36421,7 @@
         </p:blipFill>
         <p:spPr>
           <a:xfrm>
-            <a:off x="9417050" y="6311900"/>
+            <a:off x="9830470" y="6311900"/>
             <a:ext cx="939800" cy="254000"/>
           </a:xfrm>
           <a:prstGeom prst="rect">
@@ -36437,8 +36437,8 @@
         </p:nvSpPr>
         <p:spPr>
           <a:xfrm>
-            <a:off x="10509250" y="6299200"/>
-            <a:ext cx="12700" cy="279400"/>
+            <a:off x="10922670" y="6261100"/>
+            <a:ext cx="12700" cy="355600"/>
           </a:xfrm>
           <a:prstGeom prst="rect">
             <a:avLst/>
@@ -36475,7 +36475,7 @@
       </p:sp>
       <p:pic>
         <p:nvPicPr>
-          <p:cNvPr id="11" name="Picture 10" descr="logo_jisc_placeholder.png"/>
+          <p:cNvPr id="11" name="Picture 10" descr="logo_jisc.png"/>
           <p:cNvPicPr>
             <a:picLocks noChangeAspect="1"/>
           </p:cNvPicPr>
@@ -36489,8 +36489,8 @@
         </p:blipFill>
         <p:spPr>
           <a:xfrm>
-            <a:off x="10661650" y="6299200"/>
-            <a:ext cx="768350" cy="279400"/>
+            <a:off x="11075070" y="6261100"/>
+            <a:ext cx="354930" cy="355600"/>
           </a:xfrm>
           <a:prstGeom prst="rect">
             <a:avLst/>
@@ -36878,7 +36878,7 @@
         </p:blipFill>
         <p:spPr>
           <a:xfrm>
-            <a:off x="9417050" y="6311900"/>
+            <a:off x="9830470" y="6311900"/>
             <a:ext cx="939800" cy="254000"/>
           </a:xfrm>
           <a:prstGeom prst="rect">
@@ -36894,8 +36894,8 @@
         </p:nvSpPr>
         <p:spPr>
           <a:xfrm>
-            <a:off x="10509250" y="6299200"/>
-            <a:ext cx="12700" cy="279400"/>
+            <a:off x="10922670" y="6261100"/>
+            <a:ext cx="12700" cy="355600"/>
           </a:xfrm>
           <a:prstGeom prst="rect">
             <a:avLst/>
@@ -36932,7 +36932,7 @@
       </p:sp>
       <p:pic>
         <p:nvPicPr>
-          <p:cNvPr id="11" name="Picture 10" descr="logo_jisc_placeholder.png"/>
+          <p:cNvPr id="11" name="Picture 10" descr="logo_jisc.png"/>
           <p:cNvPicPr>
             <a:picLocks noChangeAspect="1"/>
           </p:cNvPicPr>
@@ -36946,8 +36946,8 @@
         </p:blipFill>
         <p:spPr>
           <a:xfrm>
-            <a:off x="10661650" y="6299200"/>
-            <a:ext cx="768350" cy="279400"/>
+            <a:off x="11075070" y="6261100"/>
+            <a:ext cx="354930" cy="355600"/>
           </a:xfrm>
           <a:prstGeom prst="rect">
             <a:avLst/>

</xml_diff>

<commit_message>
Jisc-webinar: vragen Hannah aangepast op haar feedback, slide 'Hannah asks Eduface', pilotslide eruit
Co-Authored-By: Claude Opus 5.5 <noreply@anthropic.com>
Claude-Session: https://claude.ai/code/session_015wepMCxdSi78pa2LxvGqQg
</commit_message>
<xml_diff>
--- a/GTM/Event manager/jisc-webinar/deck/jisc-webinar-bewerkbaar.pptx
+++ b/GTM/Event manager/jisc-webinar/deck/jisc-webinar-bewerkbaar.pptx
@@ -28396,7 +28396,7 @@
                 </a:solidFill>
                 <a:latin typeface="Inter"/>
               </a:rPr>
-              <a:t>What does the sector expect from AI feedback,</a:t>
+              <a:t>Why AI marking and feedback has a place</a:t>
             </a:r>
           </a:p>
           <a:p>
@@ -28412,7 +28412,7 @@
                 </a:solidFill>
                 <a:latin typeface="Inter"/>
               </a:rPr>
-              <a:t>and what is actually working?</a:t>
+              <a:t>in Jisc’s new digital assessment framework</a:t>
             </a:r>
           </a:p>
         </p:txBody>
@@ -33042,7 +33042,7 @@
                 </a:solidFill>
                 <a:latin typeface="League Spartan"/>
               </a:rPr>
-              <a:t>What made Jisc decide to start the AI in marking and feedback pilot?</a:t>
+              <a:t>Why did Jisc decide to include AI marking and feedback in the new digital assessment framework?</a:t>
             </a:r>
           </a:p>
         </p:txBody>
@@ -33460,7 +33460,7 @@
                 </a:solidFill>
                 <a:latin typeface="Inter"/>
               </a:rPr>
-              <a:t>CONTEXT</a:t>
+              <a:t>IN CONVERSATION WITH JISC  ·  3 OF 5</a:t>
             </a:r>
           </a:p>
         </p:txBody>
@@ -33473,8 +33473,8 @@
         </p:nvSpPr>
         <p:spPr>
           <a:xfrm>
-            <a:off x="762000" y="1587500"/>
-            <a:ext cx="5715000" cy="1651000"/>
+            <a:off x="762000" y="1905000"/>
+            <a:ext cx="9525000" cy="2667000"/>
           </a:xfrm>
           <a:prstGeom prst="rect">
             <a:avLst/>
@@ -33489,133 +33489,39 @@
           <a:p>
             <a:pPr algn="l">
               <a:lnSpc>
-                <a:spcPct val="100000"/>
+                <a:spcPct val="110000"/>
               </a:lnSpc>
             </a:pPr>
             <a:r>
-              <a:rPr sz="13000" b="1">
+              <a:rPr sz="4400" b="1">
                 <a:solidFill>
-                  <a:srgbClr val="007B54"/>
+                  <a:srgbClr val="002333"/>
                 </a:solidFill>
                 <a:latin typeface="League Spartan"/>
               </a:rPr>
-              <a:t>38</a:t>
-            </a:r>
-          </a:p>
-        </p:txBody>
-      </p:sp>
-      <p:sp>
-        <p:nvSpPr>
-          <p:cNvPr id="4" name="TextBox 3"/>
-          <p:cNvSpPr txBox="1"/>
-          <p:nvPr/>
-        </p:nvSpPr>
-        <p:spPr>
-          <a:xfrm>
-            <a:off x="762000" y="3429000"/>
-            <a:ext cx="5207000" cy="889000"/>
-          </a:xfrm>
-          <a:prstGeom prst="rect">
-            <a:avLst/>
-          </a:prstGeom>
-          <a:noFill/>
-        </p:spPr>
-        <p:txBody>
-          <a:bodyPr wrap="square" lIns="0" rIns="0" tIns="0" bIns="0">
-            <a:spAutoFit/>
-          </a:bodyPr>
-          <a:lstStyle/>
-          <a:p>
-            <a:pPr algn="l">
-              <a:lnSpc>
-                <a:spcPct val="125000"/>
-              </a:lnSpc>
-            </a:pPr>
-            <a:r>
-              <a:rPr sz="2000" b="0">
-                <a:solidFill>
-                  <a:srgbClr val="002333"/>
-                </a:solidFill>
-                <a:latin typeface="Inter"/>
-              </a:rPr>
-              <a:t>colleges and universities in Jisc's</a:t>
-            </a:r>
-          </a:p>
-          <a:p>
-            <a:pPr algn="l">
-              <a:lnSpc>
-                <a:spcPct val="125000"/>
-              </a:lnSpc>
-            </a:pPr>
-            <a:r>
-              <a:rPr sz="2000" b="0">
-                <a:solidFill>
-                  <a:srgbClr val="002333"/>
-                </a:solidFill>
-                <a:latin typeface="Inter"/>
-              </a:rPr>
-              <a:t>AI in marking and feedback pilot</a:t>
-            </a:r>
-          </a:p>
-        </p:txBody>
-      </p:sp>
-      <p:sp>
-        <p:nvSpPr>
-          <p:cNvPr id="5" name="TextBox 4"/>
-          <p:cNvSpPr txBox="1"/>
-          <p:nvPr/>
-        </p:nvSpPr>
-        <p:spPr>
-          <a:xfrm>
-            <a:off x="762000" y="4445000"/>
-            <a:ext cx="5207000" cy="317500"/>
-          </a:xfrm>
-          <a:prstGeom prst="rect">
-            <a:avLst/>
-          </a:prstGeom>
-          <a:noFill/>
-        </p:spPr>
-        <p:txBody>
-          <a:bodyPr wrap="square" lIns="0" rIns="0" tIns="0" bIns="0">
-            <a:spAutoFit/>
-          </a:bodyPr>
-          <a:lstStyle/>
-          <a:p>
-            <a:pPr algn="l">
-              <a:lnSpc>
-                <a:spcPct val="115000"/>
-              </a:lnSpc>
-            </a:pPr>
-            <a:r>
-              <a:rPr sz="1500" b="0">
-                <a:solidFill>
-                  <a:srgbClr val="5B7480"/>
-                </a:solidFill>
-                <a:latin typeface="Inter"/>
-              </a:rPr>
-              <a:t>September 2025 to August 2026</a:t>
-            </a:r>
-          </a:p>
-        </p:txBody>
-      </p:sp>
-      <p:sp>
-        <p:nvSpPr>
-          <p:cNvPr id="6" name="Rounded Rectangle 5"/>
-          <p:cNvSpPr/>
-          <p:nvPr/>
-        </p:nvSpPr>
-        <p:spPr>
-          <a:xfrm>
-            <a:off x="6731000" y="1587500"/>
-            <a:ext cx="4699000" cy="3302000"/>
+              <a:t>What does a framework like this make easier for institutions?</a:t>
+            </a:r>
+          </a:p>
+        </p:txBody>
+      </p:sp>
+      <p:sp>
+        <p:nvSpPr>
+          <p:cNvPr id="4" name="Rounded Rectangle 3"/>
+          <p:cNvSpPr/>
+          <p:nvPr/>
+        </p:nvSpPr>
+        <p:spPr>
+          <a:xfrm>
+            <a:off x="762000" y="5080000"/>
+            <a:ext cx="127000" cy="127000"/>
           </a:xfrm>
           <a:prstGeom prst="roundRect">
             <a:avLst>
-              <a:gd name="adj" fmla="val 5384"/>
+              <a:gd name="adj" fmla="val 50000"/>
             </a:avLst>
           </a:prstGeom>
           <a:solidFill>
-            <a:srgbClr val="F3F7F8"/>
+            <a:srgbClr val="007B54"/>
           </a:solidFill>
           <a:ln>
             <a:noFill/>
@@ -33646,163 +33552,191 @@
       </p:sp>
       <p:sp>
         <p:nvSpPr>
-          <p:cNvPr id="7" name="TextBox 6"/>
-          <p:cNvSpPr txBox="1"/>
-          <p:nvPr/>
-        </p:nvSpPr>
-        <p:spPr>
-          <a:xfrm>
-            <a:off x="7112000" y="1905000"/>
-            <a:ext cx="4064000" cy="317500"/>
-          </a:xfrm>
-          <a:prstGeom prst="rect">
-            <a:avLst/>
-          </a:prstGeom>
-          <a:noFill/>
-        </p:spPr>
-        <p:txBody>
-          <a:bodyPr wrap="square" lIns="0" rIns="0" tIns="0" bIns="0">
-            <a:spAutoFit/>
-          </a:bodyPr>
-          <a:lstStyle/>
-          <a:p>
-            <a:pPr algn="l">
-              <a:lnSpc>
-                <a:spcPct val="100000"/>
-              </a:lnSpc>
-            </a:pPr>
-            <a:r>
-              <a:rPr sz="6000" b="1">
-                <a:solidFill>
-                  <a:srgbClr val="00E075"/>
-                </a:solidFill>
-                <a:latin typeface="League Spartan"/>
-              </a:rPr>
-              <a:t>“</a:t>
-            </a:r>
-          </a:p>
-        </p:txBody>
-      </p:sp>
-      <p:sp>
-        <p:nvSpPr>
-          <p:cNvPr id="8" name="TextBox 7"/>
-          <p:cNvSpPr txBox="1"/>
-          <p:nvPr/>
-        </p:nvSpPr>
-        <p:spPr>
-          <a:xfrm>
-            <a:off x="7112000" y="2476500"/>
-            <a:ext cx="4064000" cy="1651000"/>
-          </a:xfrm>
-          <a:prstGeom prst="rect">
-            <a:avLst/>
-          </a:prstGeom>
-          <a:noFill/>
-        </p:spPr>
-        <p:txBody>
-          <a:bodyPr wrap="square" lIns="0" rIns="0" tIns="0" bIns="0">
-            <a:spAutoFit/>
-          </a:bodyPr>
-          <a:lstStyle/>
-          <a:p>
-            <a:pPr algn="l">
-              <a:lnSpc>
-                <a:spcPct val="130000"/>
-              </a:lnSpc>
-            </a:pPr>
-            <a:r>
-              <a:rPr sz="1900" b="0">
-                <a:solidFill>
-                  <a:srgbClr val="002333"/>
-                </a:solidFill>
-                <a:latin typeface="Inter"/>
-              </a:rPr>
-              <a:t>These tools shouldn't be used as a final marker. Humans should always be reviewing the feedback.</a:t>
-            </a:r>
-          </a:p>
-        </p:txBody>
-      </p:sp>
-      <p:sp>
-        <p:nvSpPr>
-          <p:cNvPr id="9" name="TextBox 8"/>
-          <p:cNvSpPr txBox="1"/>
-          <p:nvPr/>
-        </p:nvSpPr>
-        <p:spPr>
-          <a:xfrm>
-            <a:off x="7112000" y="4318000"/>
-            <a:ext cx="4064000" cy="254000"/>
-          </a:xfrm>
-          <a:prstGeom prst="rect">
-            <a:avLst/>
-          </a:prstGeom>
-          <a:noFill/>
-        </p:spPr>
-        <p:txBody>
-          <a:bodyPr wrap="square" lIns="0" rIns="0" tIns="0" bIns="0">
-            <a:spAutoFit/>
-          </a:bodyPr>
-          <a:lstStyle/>
-          <a:p>
-            <a:pPr algn="l">
-              <a:lnSpc>
-                <a:spcPct val="115000"/>
-              </a:lnSpc>
-            </a:pPr>
-            <a:r>
-              <a:rPr sz="1400" b="1">
-                <a:solidFill>
-                  <a:srgbClr val="002333"/>
-                </a:solidFill>
-                <a:latin typeface="Inter"/>
-              </a:rPr>
-              <a:t>Tom Moule, Jisc</a:t>
-            </a:r>
-          </a:p>
-        </p:txBody>
-      </p:sp>
-      <p:sp>
-        <p:nvSpPr>
-          <p:cNvPr id="10" name="TextBox 9"/>
-          <p:cNvSpPr txBox="1"/>
-          <p:nvPr/>
-        </p:nvSpPr>
-        <p:spPr>
-          <a:xfrm>
-            <a:off x="762000" y="6350000"/>
-            <a:ext cx="7493000" cy="228600"/>
-          </a:xfrm>
-          <a:prstGeom prst="rect">
-            <a:avLst/>
-          </a:prstGeom>
-          <a:noFill/>
-        </p:spPr>
-        <p:txBody>
-          <a:bodyPr wrap="square" lIns="0" rIns="0" tIns="0" bIns="0">
-            <a:spAutoFit/>
-          </a:bodyPr>
-          <a:lstStyle/>
-          <a:p>
-            <a:pPr algn="l">
-              <a:lnSpc>
-                <a:spcPct val="115000"/>
-              </a:lnSpc>
-            </a:pPr>
-            <a:r>
-              <a:rPr sz="1100" b="0">
-                <a:solidFill>
-                  <a:srgbClr val="5B7480"/>
-                </a:solidFill>
-                <a:latin typeface="Inter"/>
-              </a:rPr>
-              <a:t>Jisc National Centre for AI, May 2026 · Times Higher Education, 27 March 2026</a:t>
-            </a:r>
+          <p:cNvPr id="5" name="Rounded Rectangle 4"/>
+          <p:cNvSpPr/>
+          <p:nvPr/>
+        </p:nvSpPr>
+        <p:spPr>
+          <a:xfrm>
+            <a:off x="977900" y="5080000"/>
+            <a:ext cx="127000" cy="127000"/>
+          </a:xfrm>
+          <a:prstGeom prst="roundRect">
+            <a:avLst>
+              <a:gd name="adj" fmla="val 50000"/>
+            </a:avLst>
+          </a:prstGeom>
+          <a:solidFill>
+            <a:srgbClr val="007B54"/>
+          </a:solidFill>
+          <a:ln>
+            <a:noFill/>
+          </a:ln>
+          <a:effectLst/>
+        </p:spPr>
+        <p:style>
+          <a:lnRef idx="1">
+            <a:schemeClr val="accent1"/>
+          </a:lnRef>
+          <a:fillRef idx="3">
+            <a:schemeClr val="accent1"/>
+          </a:fillRef>
+          <a:effectRef idx="2">
+            <a:schemeClr val="accent1"/>
+          </a:effectRef>
+          <a:fontRef idx="minor">
+            <a:schemeClr val="lt1"/>
+          </a:fontRef>
+        </p:style>
+        <p:txBody>
+          <a:bodyPr rtlCol="0" anchor="ctr"/>
+          <a:lstStyle/>
+          <a:p>
+            <a:pPr algn="ctr"/>
+          </a:p>
+        </p:txBody>
+      </p:sp>
+      <p:sp>
+        <p:nvSpPr>
+          <p:cNvPr id="6" name="Rounded Rectangle 5"/>
+          <p:cNvSpPr/>
+          <p:nvPr/>
+        </p:nvSpPr>
+        <p:spPr>
+          <a:xfrm>
+            <a:off x="1193800" y="5080000"/>
+            <a:ext cx="406400" cy="127000"/>
+          </a:xfrm>
+          <a:prstGeom prst="roundRect">
+            <a:avLst>
+              <a:gd name="adj" fmla="val 50000"/>
+            </a:avLst>
+          </a:prstGeom>
+          <a:solidFill>
+            <a:srgbClr val="00E075"/>
+          </a:solidFill>
+          <a:ln>
+            <a:noFill/>
+          </a:ln>
+          <a:effectLst/>
+        </p:spPr>
+        <p:style>
+          <a:lnRef idx="1">
+            <a:schemeClr val="accent1"/>
+          </a:lnRef>
+          <a:fillRef idx="3">
+            <a:schemeClr val="accent1"/>
+          </a:fillRef>
+          <a:effectRef idx="2">
+            <a:schemeClr val="accent1"/>
+          </a:effectRef>
+          <a:fontRef idx="minor">
+            <a:schemeClr val="lt1"/>
+          </a:fontRef>
+        </p:style>
+        <p:txBody>
+          <a:bodyPr rtlCol="0" anchor="ctr"/>
+          <a:lstStyle/>
+          <a:p>
+            <a:pPr algn="ctr"/>
+          </a:p>
+        </p:txBody>
+      </p:sp>
+      <p:sp>
+        <p:nvSpPr>
+          <p:cNvPr id="7" name="Rounded Rectangle 6"/>
+          <p:cNvSpPr/>
+          <p:nvPr/>
+        </p:nvSpPr>
+        <p:spPr>
+          <a:xfrm>
+            <a:off x="1689100" y="5080000"/>
+            <a:ext cx="127000" cy="127000"/>
+          </a:xfrm>
+          <a:prstGeom prst="roundRect">
+            <a:avLst>
+              <a:gd name="adj" fmla="val 50000"/>
+            </a:avLst>
+          </a:prstGeom>
+          <a:solidFill>
+            <a:srgbClr val="E7EEF0"/>
+          </a:solidFill>
+          <a:ln>
+            <a:noFill/>
+          </a:ln>
+          <a:effectLst/>
+        </p:spPr>
+        <p:style>
+          <a:lnRef idx="1">
+            <a:schemeClr val="accent1"/>
+          </a:lnRef>
+          <a:fillRef idx="3">
+            <a:schemeClr val="accent1"/>
+          </a:fillRef>
+          <a:effectRef idx="2">
+            <a:schemeClr val="accent1"/>
+          </a:effectRef>
+          <a:fontRef idx="minor">
+            <a:schemeClr val="lt1"/>
+          </a:fontRef>
+        </p:style>
+        <p:txBody>
+          <a:bodyPr rtlCol="0" anchor="ctr"/>
+          <a:lstStyle/>
+          <a:p>
+            <a:pPr algn="ctr"/>
+          </a:p>
+        </p:txBody>
+      </p:sp>
+      <p:sp>
+        <p:nvSpPr>
+          <p:cNvPr id="8" name="Rounded Rectangle 7"/>
+          <p:cNvSpPr/>
+          <p:nvPr/>
+        </p:nvSpPr>
+        <p:spPr>
+          <a:xfrm>
+            <a:off x="1905000" y="5080000"/>
+            <a:ext cx="127000" cy="127000"/>
+          </a:xfrm>
+          <a:prstGeom prst="roundRect">
+            <a:avLst>
+              <a:gd name="adj" fmla="val 50000"/>
+            </a:avLst>
+          </a:prstGeom>
+          <a:solidFill>
+            <a:srgbClr val="E7EEF0"/>
+          </a:solidFill>
+          <a:ln>
+            <a:noFill/>
+          </a:ln>
+          <a:effectLst/>
+        </p:spPr>
+        <p:style>
+          <a:lnRef idx="1">
+            <a:schemeClr val="accent1"/>
+          </a:lnRef>
+          <a:fillRef idx="3">
+            <a:schemeClr val="accent1"/>
+          </a:fillRef>
+          <a:effectRef idx="2">
+            <a:schemeClr val="accent1"/>
+          </a:effectRef>
+          <a:fontRef idx="minor">
+            <a:schemeClr val="lt1"/>
+          </a:fontRef>
+        </p:style>
+        <p:txBody>
+          <a:bodyPr rtlCol="0" anchor="ctr"/>
+          <a:lstStyle/>
+          <a:p>
+            <a:pPr algn="ctr"/>
           </a:p>
         </p:txBody>
       </p:sp>
       <p:pic>
         <p:nvPicPr>
-          <p:cNvPr id="11" name="Picture 10" descr="logo_navy_c.png"/>
+          <p:cNvPr id="9" name="Picture 8" descr="logo_navy_c.png"/>
           <p:cNvPicPr>
             <a:picLocks noChangeAspect="1"/>
           </p:cNvPicPr>
@@ -33826,7 +33760,7 @@
       </p:pic>
       <p:sp>
         <p:nvSpPr>
-          <p:cNvPr id="12" name="Rectangle 11"/>
+          <p:cNvPr id="10" name="Rectangle 9"/>
           <p:cNvSpPr/>
           <p:nvPr/>
         </p:nvSpPr>
@@ -33870,7 +33804,7 @@
       </p:sp>
       <p:pic>
         <p:nvPicPr>
-          <p:cNvPr id="13" name="Picture 12" descr="logo_jisc.png"/>
+          <p:cNvPr id="11" name="Picture 10" descr="logo_jisc.png"/>
           <p:cNvPicPr>
             <a:picLocks noChangeAspect="1"/>
           </p:cNvPicPr>
@@ -33894,7 +33828,7 @@
       </p:pic>
       <p:sp>
         <p:nvSpPr>
-          <p:cNvPr id="14" name="TextBox 13"/>
+          <p:cNvPr id="12" name="TextBox 11"/>
           <p:cNvSpPr txBox="1"/>
           <p:nvPr/>
         </p:nvSpPr>
@@ -33983,7 +33917,7 @@
                 </a:solidFill>
                 <a:latin typeface="Inter"/>
               </a:rPr>
-              <a:t>IN CONVERSATION WITH JISC  ·  3 OF 5</a:t>
+              <a:t>IN CONVERSATION WITH JISC  ·  4 OF 5</a:t>
             </a:r>
           </a:p>
         </p:txBody>
@@ -34022,7 +33956,7 @@
                 </a:solidFill>
                 <a:latin typeface="League Spartan"/>
               </a:rPr>
-              <a:t>The pilot points towards formative feedback. What makes AI so valuable there?</a:t>
+              <a:t>What should institutions look for when they choose an AI marking and feedback tool?</a:t>
             </a:r>
           </a:p>
         </p:txBody>
@@ -34128,7 +34062,7 @@
         <p:spPr>
           <a:xfrm>
             <a:off x="1193800" y="5080000"/>
-            <a:ext cx="406400" cy="127000"/>
+            <a:ext cx="127000" cy="127000"/>
           </a:xfrm>
           <a:prstGeom prst="roundRect">
             <a:avLst>
@@ -34136,7 +34070,7 @@
             </a:avLst>
           </a:prstGeom>
           <a:solidFill>
-            <a:srgbClr val="00E075"/>
+            <a:srgbClr val="007B54"/>
           </a:solidFill>
           <a:ln>
             <a:noFill/>
@@ -34173,8 +34107,8 @@
         </p:nvSpPr>
         <p:spPr>
           <a:xfrm>
-            <a:off x="1689100" y="5080000"/>
-            <a:ext cx="127000" cy="127000"/>
+            <a:off x="1409700" y="5080000"/>
+            <a:ext cx="406400" cy="127000"/>
           </a:xfrm>
           <a:prstGeom prst="roundRect">
             <a:avLst>
@@ -34182,7 +34116,7 @@
             </a:avLst>
           </a:prstGeom>
           <a:solidFill>
-            <a:srgbClr val="E7EEF0"/>
+            <a:srgbClr val="00E075"/>
           </a:solidFill>
           <a:ln>
             <a:noFill/>
@@ -34440,7 +34374,7 @@
                 </a:solidFill>
                 <a:latin typeface="Inter"/>
               </a:rPr>
-              <a:t>IN CONVERSATION WITH JISC  ·  4 OF 5</a:t>
+              <a:t>IN CONVERSATION WITH JISC  ·  5 OF 5</a:t>
             </a:r>
           </a:p>
         </p:txBody>
@@ -34479,7 +34413,7 @@
                 </a:solidFill>
                 <a:latin typeface="League Spartan"/>
               </a:rPr>
-              <a:t>Where do institutions tend to get stuck when they try it?</a:t>
+              <a:t>What's one piece of advice you'd give an institution starting next term?</a:t>
             </a:r>
           </a:p>
         </p:txBody>
@@ -34631,7 +34565,7 @@
         <p:spPr>
           <a:xfrm>
             <a:off x="1409700" y="5080000"/>
-            <a:ext cx="406400" cy="127000"/>
+            <a:ext cx="127000" cy="127000"/>
           </a:xfrm>
           <a:prstGeom prst="roundRect">
             <a:avLst>
@@ -34639,7 +34573,7 @@
             </a:avLst>
           </a:prstGeom>
           <a:solidFill>
-            <a:srgbClr val="00E075"/>
+            <a:srgbClr val="007B54"/>
           </a:solidFill>
           <a:ln>
             <a:noFill/>
@@ -34676,8 +34610,8 @@
         </p:nvSpPr>
         <p:spPr>
           <a:xfrm>
-            <a:off x="1905000" y="5080000"/>
-            <a:ext cx="127000" cy="127000"/>
+            <a:off x="1625600" y="5080000"/>
+            <a:ext cx="406400" cy="127000"/>
           </a:xfrm>
           <a:prstGeom prst="roundRect">
             <a:avLst>
@@ -34685,7 +34619,7 @@
             </a:avLst>
           </a:prstGeom>
           <a:solidFill>
-            <a:srgbClr val="E7EEF0"/>
+            <a:srgbClr val="00E075"/>
           </a:solidFill>
           <a:ln>
             <a:noFill/>
@@ -34897,7 +34831,7 @@
                 </a:solidFill>
                 <a:latin typeface="Inter"/>
               </a:rPr>
-              <a:t>IN CONVERSATION WITH JISC  ·  5 OF 5</a:t>
+              <a:t>HANNAH ASKS EDUFACE</a:t>
             </a:r>
           </a:p>
         </p:txBody>
@@ -34936,7 +34870,7 @@
                 </a:solidFill>
                 <a:latin typeface="League Spartan"/>
               </a:rPr>
-              <a:t>What's one piece of advice you'd give an institution starting next term?</a:t>
+              <a:t>Where do institutions tend to get stuck when they try it?</a:t>
             </a:r>
           </a:p>
         </p:txBody>
@@ -34950,7 +34884,7 @@
         <p:spPr>
           <a:xfrm>
             <a:off x="762000" y="5080000"/>
-            <a:ext cx="127000" cy="127000"/>
+            <a:ext cx="406400" cy="127000"/>
           </a:xfrm>
           <a:prstGeom prst="roundRect">
             <a:avLst>
@@ -34958,191 +34892,7 @@
             </a:avLst>
           </a:prstGeom>
           <a:solidFill>
-            <a:srgbClr val="007B54"/>
-          </a:solidFill>
-          <a:ln>
-            <a:noFill/>
-          </a:ln>
-          <a:effectLst/>
-        </p:spPr>
-        <p:style>
-          <a:lnRef idx="1">
-            <a:schemeClr val="accent1"/>
-          </a:lnRef>
-          <a:fillRef idx="3">
-            <a:schemeClr val="accent1"/>
-          </a:fillRef>
-          <a:effectRef idx="2">
-            <a:schemeClr val="accent1"/>
-          </a:effectRef>
-          <a:fontRef idx="minor">
-            <a:schemeClr val="lt1"/>
-          </a:fontRef>
-        </p:style>
-        <p:txBody>
-          <a:bodyPr rtlCol="0" anchor="ctr"/>
-          <a:lstStyle/>
-          <a:p>
-            <a:pPr algn="ctr"/>
-          </a:p>
-        </p:txBody>
-      </p:sp>
-      <p:sp>
-        <p:nvSpPr>
-          <p:cNvPr id="5" name="Rounded Rectangle 4"/>
-          <p:cNvSpPr/>
-          <p:nvPr/>
-        </p:nvSpPr>
-        <p:spPr>
-          <a:xfrm>
-            <a:off x="977900" y="5080000"/>
-            <a:ext cx="127000" cy="127000"/>
-          </a:xfrm>
-          <a:prstGeom prst="roundRect">
-            <a:avLst>
-              <a:gd name="adj" fmla="val 50000"/>
-            </a:avLst>
-          </a:prstGeom>
-          <a:solidFill>
-            <a:srgbClr val="007B54"/>
-          </a:solidFill>
-          <a:ln>
-            <a:noFill/>
-          </a:ln>
-          <a:effectLst/>
-        </p:spPr>
-        <p:style>
-          <a:lnRef idx="1">
-            <a:schemeClr val="accent1"/>
-          </a:lnRef>
-          <a:fillRef idx="3">
-            <a:schemeClr val="accent1"/>
-          </a:fillRef>
-          <a:effectRef idx="2">
-            <a:schemeClr val="accent1"/>
-          </a:effectRef>
-          <a:fontRef idx="minor">
-            <a:schemeClr val="lt1"/>
-          </a:fontRef>
-        </p:style>
-        <p:txBody>
-          <a:bodyPr rtlCol="0" anchor="ctr"/>
-          <a:lstStyle/>
-          <a:p>
-            <a:pPr algn="ctr"/>
-          </a:p>
-        </p:txBody>
-      </p:sp>
-      <p:sp>
-        <p:nvSpPr>
-          <p:cNvPr id="6" name="Rounded Rectangle 5"/>
-          <p:cNvSpPr/>
-          <p:nvPr/>
-        </p:nvSpPr>
-        <p:spPr>
-          <a:xfrm>
-            <a:off x="1193800" y="5080000"/>
-            <a:ext cx="127000" cy="127000"/>
-          </a:xfrm>
-          <a:prstGeom prst="roundRect">
-            <a:avLst>
-              <a:gd name="adj" fmla="val 50000"/>
-            </a:avLst>
-          </a:prstGeom>
-          <a:solidFill>
-            <a:srgbClr val="007B54"/>
-          </a:solidFill>
-          <a:ln>
-            <a:noFill/>
-          </a:ln>
-          <a:effectLst/>
-        </p:spPr>
-        <p:style>
-          <a:lnRef idx="1">
-            <a:schemeClr val="accent1"/>
-          </a:lnRef>
-          <a:fillRef idx="3">
-            <a:schemeClr val="accent1"/>
-          </a:fillRef>
-          <a:effectRef idx="2">
-            <a:schemeClr val="accent1"/>
-          </a:effectRef>
-          <a:fontRef idx="minor">
-            <a:schemeClr val="lt1"/>
-          </a:fontRef>
-        </p:style>
-        <p:txBody>
-          <a:bodyPr rtlCol="0" anchor="ctr"/>
-          <a:lstStyle/>
-          <a:p>
-            <a:pPr algn="ctr"/>
-          </a:p>
-        </p:txBody>
-      </p:sp>
-      <p:sp>
-        <p:nvSpPr>
-          <p:cNvPr id="7" name="Rounded Rectangle 6"/>
-          <p:cNvSpPr/>
-          <p:nvPr/>
-        </p:nvSpPr>
-        <p:spPr>
-          <a:xfrm>
-            <a:off x="1409700" y="5080000"/>
-            <a:ext cx="127000" cy="127000"/>
-          </a:xfrm>
-          <a:prstGeom prst="roundRect">
-            <a:avLst>
-              <a:gd name="adj" fmla="val 50000"/>
-            </a:avLst>
-          </a:prstGeom>
-          <a:solidFill>
-            <a:srgbClr val="007B54"/>
-          </a:solidFill>
-          <a:ln>
-            <a:noFill/>
-          </a:ln>
-          <a:effectLst/>
-        </p:spPr>
-        <p:style>
-          <a:lnRef idx="1">
-            <a:schemeClr val="accent1"/>
-          </a:lnRef>
-          <a:fillRef idx="3">
-            <a:schemeClr val="accent1"/>
-          </a:fillRef>
-          <a:effectRef idx="2">
-            <a:schemeClr val="accent1"/>
-          </a:effectRef>
-          <a:fontRef idx="minor">
-            <a:schemeClr val="lt1"/>
-          </a:fontRef>
-        </p:style>
-        <p:txBody>
-          <a:bodyPr rtlCol="0" anchor="ctr"/>
-          <a:lstStyle/>
-          <a:p>
-            <a:pPr algn="ctr"/>
-          </a:p>
-        </p:txBody>
-      </p:sp>
-      <p:sp>
-        <p:nvSpPr>
-          <p:cNvPr id="8" name="Rounded Rectangle 7"/>
-          <p:cNvSpPr/>
-          <p:nvPr/>
-        </p:nvSpPr>
-        <p:spPr>
-          <a:xfrm>
-            <a:off x="1625600" y="5080000"/>
-            <a:ext cx="406400" cy="127000"/>
-          </a:xfrm>
-          <a:prstGeom prst="roundRect">
-            <a:avLst>
-              <a:gd name="adj" fmla="val 50000"/>
-            </a:avLst>
-          </a:prstGeom>
-          <a:solidFill>
-            <a:srgbClr val="00E075"/>
+            <a:srgbClr val="E07B00"/>
           </a:solidFill>
           <a:ln>
             <a:noFill/>
@@ -35173,7 +34923,7 @@
       </p:sp>
       <p:pic>
         <p:nvPicPr>
-          <p:cNvPr id="9" name="Picture 8" descr="logo_navy_c.png"/>
+          <p:cNvPr id="5" name="Picture 4" descr="logo_navy_c.png"/>
           <p:cNvPicPr>
             <a:picLocks noChangeAspect="1"/>
           </p:cNvPicPr>
@@ -35197,7 +34947,7 @@
       </p:pic>
       <p:sp>
         <p:nvSpPr>
-          <p:cNvPr id="10" name="Rectangle 9"/>
+          <p:cNvPr id="6" name="Rectangle 5"/>
           <p:cNvSpPr/>
           <p:nvPr/>
         </p:nvSpPr>
@@ -35241,7 +34991,7 @@
       </p:sp>
       <p:pic>
         <p:nvPicPr>
-          <p:cNvPr id="11" name="Picture 10" descr="logo_jisc.png"/>
+          <p:cNvPr id="7" name="Picture 6" descr="logo_jisc.png"/>
           <p:cNvPicPr>
             <a:picLocks noChangeAspect="1"/>
           </p:cNvPicPr>
@@ -35265,7 +35015,7 @@
       </p:pic>
       <p:sp>
         <p:nvSpPr>
-          <p:cNvPr id="12" name="TextBox 11"/>
+          <p:cNvPr id="8" name="TextBox 7"/>
           <p:cNvSpPr txBox="1"/>
           <p:nvPr/>
         </p:nvSpPr>

</xml_diff>